<commit_message>
Reenfocar presentacion en caso ISO PNC
</commit_message>
<xml_diff>
--- a/presentacion/charla-excelencia-ia-organizacional.pptx
+++ b/presentacion/charla-excelencia-ia-organizacional.pptx
@@ -16,6 +16,7 @@
     <p:sldId id="264" r:id="rId15"/>
     <p:sldId id="265" r:id="rId16"/>
     <p:sldId id="266" r:id="rId17"/>
+    <p:sldId id="267" r:id="rId18"/>
   </p:sldIdLst>
   <p:sldSz cx="12191999" cy="6858000" type="screen4x3"/>
   <p:notesSz cx="6858000" cy="9144000"/>
@@ -3886,7 +3887,7 @@
                 </a:solidFill>
                 <a:latin typeface="Aptos"/>
               </a:rPr>
-              <a:t>Caso 2 · Software y productividad aumentada</a:t>
+              <a:t>Subejemplo ISO · Matriz de gaps y evidencia</a:t>
             </a:r>
           </a:p>
         </p:txBody>
@@ -4209,7 +4210,7 @@
                 </a:solidFill>
                 <a:latin typeface="Aptos"/>
               </a:rPr>
-              <a:t>Base necesaria</a:t>
+              <a:t>Entrada</a:t>
             </a:r>
           </a:p>
         </p:txBody>
@@ -4248,7 +4249,7 @@
                 </a:solidFill>
                 <a:latin typeface="Aptos"/>
               </a:rPr>
-              <a:t>Requerimientos claros, documentación técnica, estándares de arquitectura, revisión, testing y trazabilidad.</a:t>
+              <a:t>Requisito normativo, documentos, registros y procesos vinculados.</a:t>
             </a:r>
           </a:p>
         </p:txBody>
@@ -4375,7 +4376,7 @@
                 </a:solidFill>
                 <a:latin typeface="Aptos"/>
               </a:rPr>
-              <a:t>Nuevo rol del developer</a:t>
+              <a:t>Trabajo del agente</a:t>
             </a:r>
           </a:p>
         </p:txBody>
@@ -4414,7 +4415,7 @@
                 </a:solidFill>
                 <a:latin typeface="Aptos"/>
               </a:rPr>
-              <a:t>Coordina agentes para análisis, documentación, código, testing, bugs, logs e incidentes.</a:t>
+              <a:t>Busca evidencia, ubica citas, propone cobertura, justifica brechas y ordena acciones.</a:t>
             </a:r>
           </a:p>
         </p:txBody>
@@ -4541,7 +4542,7 @@
                 </a:solidFill>
                 <a:latin typeface="Aptos"/>
               </a:rPr>
-              <a:t>Resultado buscado</a:t>
+              <a:t>Salida útil</a:t>
             </a:r>
           </a:p>
         </p:txBody>
@@ -4580,7 +4581,7 @@
                 </a:solidFill>
                 <a:latin typeface="Aptos"/>
               </a:rPr>
-              <a:t>Más capacidad de entrega, menos tarea repetitiva y mejor aprovechamiento del talento crítico.</a:t>
+              <a:t>Matriz trazable: requisito, evidencia, ubicación, justificación, brecha, acción y prioridad.</a:t>
             </a:r>
           </a:p>
         </p:txBody>
@@ -4662,7 +4663,7 @@
                 </a:solidFill>
                 <a:latin typeface="Aptos"/>
               </a:rPr>
-              <a:t>El agente no reemplaza al talento crítico; lo eleva y multiplica su capacidad cuando existe método, estándares y validación.</a:t>
+              <a:t>En ISO, la IA aporta velocidad y consistencia; la validez depende de evidencia trazable y revisión experta.</a:t>
             </a:r>
           </a:p>
         </p:txBody>
@@ -4891,7 +4892,7 @@
                 </a:solidFill>
                 <a:latin typeface="Aptos"/>
               </a:rPr>
-              <a:t>SÍNTESIS EJECUTIVA</a:t>
+              <a:t>CASO APLICADO</a:t>
             </a:r>
           </a:p>
         </p:txBody>
@@ -4930,7 +4931,7 @@
                 </a:solidFill>
                 <a:latin typeface="Aptos"/>
               </a:rPr>
-              <a:t>Cierre: la secuencia de madurez</a:t>
+              <a:t>Subejemplo PNC · Madurez y oportunidades de mejora</a:t>
             </a:r>
           </a:p>
         </p:txBody>
@@ -5139,8 +5140,8 @@
         </p:nvSpPr>
         <p:spPr>
           <a:xfrm>
-            <a:off x="914400" y="1965960"/>
-            <a:ext cx="2971800" cy="1417320"/>
+            <a:off x="777240" y="1874519"/>
+            <a:ext cx="3291840" cy="2194560"/>
           </a:xfrm>
           <a:prstGeom prst="roundRect">
             <a:avLst/>
@@ -5184,8 +5185,8 @@
         </p:nvSpPr>
         <p:spPr>
           <a:xfrm>
-            <a:off x="914400" y="1965960"/>
-            <a:ext cx="73152" cy="1417320"/>
+            <a:off x="777240" y="1874519"/>
+            <a:ext cx="73152" cy="2194560"/>
           </a:xfrm>
           <a:prstGeom prst="rect">
             <a:avLst/>
@@ -5227,8 +5228,8 @@
         </p:nvSpPr>
         <p:spPr>
           <a:xfrm>
-            <a:off x="1143000" y="2130552"/>
-            <a:ext cx="2560320" cy="320040"/>
+            <a:off x="1005840" y="2039112"/>
+            <a:ext cx="2880360" cy="320040"/>
           </a:xfrm>
           <a:prstGeom prst="rect">
             <a:avLst/>
@@ -5247,13 +5248,13 @@
               </a:lnSpc>
             </a:pPr>
             <a:r>
-              <a:rPr sz="1550" b="1">
+              <a:rPr sz="1600" b="1">
                 <a:solidFill>
                   <a:srgbClr val="373739"/>
                 </a:solidFill>
                 <a:latin typeface="Aptos"/>
               </a:rPr>
-              <a:t>Información confiable</a:t>
+              <a:t>Entrada</a:t>
             </a:r>
           </a:p>
         </p:txBody>
@@ -5266,8 +5267,8 @@
         </p:nvSpPr>
         <p:spPr>
           <a:xfrm>
-            <a:off x="1143000" y="2578608"/>
-            <a:ext cx="2560320" cy="667512"/>
+            <a:off x="1005840" y="2487168"/>
+            <a:ext cx="2880360" cy="1444752"/>
           </a:xfrm>
           <a:prstGeom prst="rect">
             <a:avLst/>
@@ -5286,27 +5287,115 @@
               </a:lnSpc>
             </a:pPr>
             <a:r>
-              <a:rPr sz="1260" b="0">
+              <a:rPr sz="1300" b="0">
                 <a:solidFill>
                   <a:srgbClr val="69696C"/>
                 </a:solidFill>
                 <a:latin typeface="Aptos"/>
               </a:rPr>
-              <a:t>documentación vigente + datos íntegros</a:t>
-            </a:r>
-          </a:p>
-        </p:txBody>
-      </p:sp>
-      <p:sp>
-        <p:nvSpPr>
-          <p:cNvPr id="13" name="TextBox 12"/>
+              <a:t>Criterios del Modelo para una Gestión de Excelencia y evidencias de gestión.</a:t>
+            </a:r>
+          </a:p>
+        </p:txBody>
+      </p:sp>
+      <p:sp>
+        <p:nvSpPr>
+          <p:cNvPr id="13" name="Rounded Rectangle 12"/>
+          <p:cNvSpPr/>
+          <p:nvPr/>
+        </p:nvSpPr>
+        <p:spPr>
+          <a:xfrm>
+            <a:off x="4434840" y="1874519"/>
+            <a:ext cx="3291840" cy="2194560"/>
+          </a:xfrm>
+          <a:prstGeom prst="roundRect">
+            <a:avLst/>
+          </a:prstGeom>
+          <a:solidFill>
+            <a:srgbClr val="FFFFFF"/>
+          </a:solidFill>
+          <a:ln w="12700">
+            <a:solidFill>
+              <a:srgbClr val="E1E4E8"/>
+            </a:solidFill>
+          </a:ln>
+        </p:spPr>
+        <p:style>
+          <a:lnRef idx="1">
+            <a:schemeClr val="accent1"/>
+          </a:lnRef>
+          <a:fillRef idx="3">
+            <a:schemeClr val="accent1"/>
+          </a:fillRef>
+          <a:effectRef idx="2">
+            <a:schemeClr val="accent1"/>
+          </a:effectRef>
+          <a:fontRef idx="minor">
+            <a:schemeClr val="lt1"/>
+          </a:fontRef>
+        </p:style>
+        <p:txBody>
+          <a:bodyPr rtlCol="0" anchor="ctr"/>
+          <a:lstStyle/>
+          <a:p>
+            <a:pPr algn="ctr"/>
+          </a:p>
+        </p:txBody>
+      </p:sp>
+      <p:sp>
+        <p:nvSpPr>
+          <p:cNvPr id="14" name="Rectangle 13"/>
+          <p:cNvSpPr/>
+          <p:nvPr/>
+        </p:nvSpPr>
+        <p:spPr>
+          <a:xfrm>
+            <a:off x="4434840" y="1874519"/>
+            <a:ext cx="73152" cy="2194560"/>
+          </a:xfrm>
+          <a:prstGeom prst="rect">
+            <a:avLst/>
+          </a:prstGeom>
+          <a:solidFill>
+            <a:srgbClr val="EF6F28"/>
+          </a:solidFill>
+          <a:ln>
+            <a:noFill/>
+          </a:ln>
+        </p:spPr>
+        <p:style>
+          <a:lnRef idx="1">
+            <a:schemeClr val="accent1"/>
+          </a:lnRef>
+          <a:fillRef idx="3">
+            <a:schemeClr val="accent1"/>
+          </a:fillRef>
+          <a:effectRef idx="2">
+            <a:schemeClr val="accent1"/>
+          </a:effectRef>
+          <a:fontRef idx="minor">
+            <a:schemeClr val="lt1"/>
+          </a:fontRef>
+        </p:style>
+        <p:txBody>
+          <a:bodyPr rtlCol="0" anchor="ctr"/>
+          <a:lstStyle/>
+          <a:p>
+            <a:pPr algn="ctr"/>
+          </a:p>
+        </p:txBody>
+      </p:sp>
+      <p:sp>
+        <p:nvSpPr>
+          <p:cNvPr id="15" name="TextBox 14"/>
           <p:cNvSpPr txBox="1"/>
           <p:nvPr/>
         </p:nvSpPr>
         <p:spPr>
           <a:xfrm>
-            <a:off x="3977639" y="2450592"/>
-            <a:ext cx="320040" cy="201168"/>
+            <a:off x="4663440" y="2039112"/>
+            <a:ext cx="2880360" cy="320040"/>
           </a:xfrm>
           <a:prstGeom prst="rect">
             <a:avLst/>
@@ -5325,27 +5414,66 @@
               </a:lnSpc>
             </a:pPr>
             <a:r>
-              <a:rPr sz="2200" b="1">
-                <a:solidFill>
-                  <a:srgbClr val="69696C"/>
+              <a:rPr sz="1600" b="1">
+                <a:solidFill>
+                  <a:srgbClr val="373739"/>
                 </a:solidFill>
                 <a:latin typeface="Aptos"/>
               </a:rPr>
-              <a:t>→</a:t>
-            </a:r>
-          </a:p>
-        </p:txBody>
-      </p:sp>
-      <p:sp>
-        <p:nvSpPr>
-          <p:cNvPr id="14" name="Rounded Rectangle 13"/>
+              <a:t>Trabajo del agente</a:t>
+            </a:r>
+          </a:p>
+        </p:txBody>
+      </p:sp>
+      <p:sp>
+        <p:nvSpPr>
+          <p:cNvPr id="16" name="TextBox 15"/>
+          <p:cNvSpPr txBox="1"/>
+          <p:nvPr/>
+        </p:nvSpPr>
+        <p:spPr>
+          <a:xfrm>
+            <a:off x="4663440" y="2487168"/>
+            <a:ext cx="2880360" cy="1444752"/>
+          </a:xfrm>
+          <a:prstGeom prst="rect">
+            <a:avLst/>
+          </a:prstGeom>
+          <a:noFill/>
+        </p:spPr>
+        <p:txBody>
+          <a:bodyPr wrap="square">
+            <a:normAutofit/>
+          </a:bodyPr>
+          <a:lstStyle/>
+          <a:p>
+            <a:pPr algn="l">
+              <a:lnSpc>
+                <a:spcPct val="100000"/>
+              </a:lnSpc>
+            </a:pPr>
+            <a:r>
+              <a:rPr sz="1300" b="0">
+                <a:solidFill>
+                  <a:srgbClr val="69696C"/>
+                </a:solidFill>
+                <a:latin typeface="Aptos"/>
+              </a:rPr>
+              <a:t>Ordena evidencias, identifica fortalezas, oportunidades de mejora y brechas de madurez.</a:t>
+            </a:r>
+          </a:p>
+        </p:txBody>
+      </p:sp>
+      <p:sp>
+        <p:nvSpPr>
+          <p:cNvPr id="17" name="Rounded Rectangle 16"/>
           <p:cNvSpPr/>
           <p:nvPr/>
         </p:nvSpPr>
         <p:spPr>
           <a:xfrm>
-            <a:off x="4572000" y="1965960"/>
-            <a:ext cx="2971800" cy="1417320"/>
+            <a:off x="8092440" y="1874519"/>
+            <a:ext cx="3291840" cy="2194560"/>
           </a:xfrm>
           <a:prstGeom prst="roundRect">
             <a:avLst/>
@@ -5383,20 +5511,20 @@
       </p:sp>
       <p:sp>
         <p:nvSpPr>
-          <p:cNvPr id="15" name="Rectangle 14"/>
+          <p:cNvPr id="18" name="Rectangle 17"/>
           <p:cNvSpPr/>
           <p:nvPr/>
         </p:nvSpPr>
         <p:spPr>
           <a:xfrm>
-            <a:off x="4572000" y="1965960"/>
-            <a:ext cx="73152" cy="1417320"/>
-          </a:xfrm>
-          <a:prstGeom prst="rect">
-            <a:avLst/>
-          </a:prstGeom>
-          <a:solidFill>
-            <a:srgbClr val="EF6F28"/>
+            <a:off x="8092440" y="1874519"/>
+            <a:ext cx="73152" cy="2194560"/>
+          </a:xfrm>
+          <a:prstGeom prst="rect">
+            <a:avLst/>
+          </a:prstGeom>
+          <a:solidFill>
+            <a:srgbClr val="00ADB5"/>
           </a:solidFill>
           <a:ln>
             <a:noFill/>
@@ -5426,14 +5554,14 @@
       </p:sp>
       <p:sp>
         <p:nvSpPr>
-          <p:cNvPr id="16" name="TextBox 15"/>
+          <p:cNvPr id="19" name="TextBox 18"/>
           <p:cNvSpPr txBox="1"/>
           <p:nvPr/>
         </p:nvSpPr>
         <p:spPr>
           <a:xfrm>
-            <a:off x="4800600" y="2130552"/>
-            <a:ext cx="2560320" cy="320040"/>
+            <a:off x="8321040" y="2039112"/>
+            <a:ext cx="2880360" cy="320040"/>
           </a:xfrm>
           <a:prstGeom prst="rect">
             <a:avLst/>
@@ -5452,27 +5580,27 @@
               </a:lnSpc>
             </a:pPr>
             <a:r>
-              <a:rPr sz="1550" b="1">
+              <a:rPr sz="1600" b="1">
                 <a:solidFill>
                   <a:srgbClr val="373739"/>
                 </a:solidFill>
                 <a:latin typeface="Aptos"/>
               </a:rPr>
-              <a:t>IA con gobierno</a:t>
-            </a:r>
-          </a:p>
-        </p:txBody>
-      </p:sp>
-      <p:sp>
-        <p:nvSpPr>
-          <p:cNvPr id="17" name="TextBox 16"/>
+              <a:t>Salida útil</a:t>
+            </a:r>
+          </a:p>
+        </p:txBody>
+      </p:sp>
+      <p:sp>
+        <p:nvSpPr>
+          <p:cNvPr id="20" name="TextBox 19"/>
           <p:cNvSpPr txBox="1"/>
           <p:nvPr/>
         </p:nvSpPr>
         <p:spPr>
           <a:xfrm>
-            <a:off x="4800600" y="2578608"/>
-            <a:ext cx="2560320" cy="667512"/>
+            <a:off x="8321040" y="2487168"/>
+            <a:ext cx="2880360" cy="1444752"/>
           </a:xfrm>
           <a:prstGeom prst="rect">
             <a:avLst/>
@@ -5491,27 +5619,152 @@
               </a:lnSpc>
             </a:pPr>
             <a:r>
-              <a:rPr sz="1260" b="0">
+              <a:rPr sz="1300" b="0">
                 <a:solidFill>
                   <a:srgbClr val="69696C"/>
                 </a:solidFill>
                 <a:latin typeface="Aptos"/>
               </a:rPr>
-              <a:t>fuentes, permisos, validación y trazabilidad</a:t>
-            </a:r>
-          </a:p>
-        </p:txBody>
-      </p:sp>
-      <p:sp>
-        <p:nvSpPr>
-          <p:cNvPr id="18" name="TextBox 17"/>
+              <a:t>Diagnóstico trazable para revisión experta, priorización y planes de mejora.</a:t>
+            </a:r>
+          </a:p>
+        </p:txBody>
+      </p:sp>
+      <p:sp>
+        <p:nvSpPr>
+          <p:cNvPr id="21" name="Rounded Rectangle 20"/>
+          <p:cNvSpPr/>
+          <p:nvPr/>
+        </p:nvSpPr>
+        <p:spPr>
+          <a:xfrm>
+            <a:off x="1005840" y="4800600"/>
+            <a:ext cx="10104120" cy="777240"/>
+          </a:xfrm>
+          <a:prstGeom prst="roundRect">
+            <a:avLst/>
+          </a:prstGeom>
+          <a:solidFill>
+            <a:srgbClr val="F4F6F8"/>
+          </a:solidFill>
+          <a:ln>
+            <a:noFill/>
+          </a:ln>
+        </p:spPr>
+        <p:style>
+          <a:lnRef idx="1">
+            <a:schemeClr val="accent1"/>
+          </a:lnRef>
+          <a:fillRef idx="3">
+            <a:schemeClr val="accent1"/>
+          </a:fillRef>
+          <a:effectRef idx="2">
+            <a:schemeClr val="accent1"/>
+          </a:effectRef>
+          <a:fontRef idx="minor">
+            <a:schemeClr val="lt1"/>
+          </a:fontRef>
+        </p:style>
+        <p:txBody>
+          <a:bodyPr rtlCol="0" anchor="ctr"/>
+          <a:lstStyle/>
+          <a:p>
+            <a:pPr algn="ctr"/>
+          </a:p>
+        </p:txBody>
+      </p:sp>
+      <p:sp>
+        <p:nvSpPr>
+          <p:cNvPr id="22" name="TextBox 21"/>
           <p:cNvSpPr txBox="1"/>
           <p:nvPr/>
         </p:nvSpPr>
         <p:spPr>
           <a:xfrm>
-            <a:off x="7635240" y="2450592"/>
-            <a:ext cx="320040" cy="201168"/>
+            <a:off x="1261872" y="5001768"/>
+            <a:ext cx="9592056" cy="393192"/>
+          </a:xfrm>
+          <a:prstGeom prst="rect">
+            <a:avLst/>
+          </a:prstGeom>
+          <a:noFill/>
+        </p:spPr>
+        <p:txBody>
+          <a:bodyPr wrap="square">
+            <a:normAutofit/>
+          </a:bodyPr>
+          <a:lstStyle/>
+          <a:p>
+            <a:pPr algn="l">
+              <a:lnSpc>
+                <a:spcPct val="105000"/>
+              </a:lnSpc>
+            </a:pPr>
+            <a:r>
+              <a:rPr sz="1800" b="1">
+                <a:solidFill>
+                  <a:srgbClr val="373739"/>
+                </a:solidFill>
+                <a:latin typeface="Aptos"/>
+              </a:rPr>
+              <a:t>En PNC, la IA acelera el diagnóstico; la excelencia sigue requiriendo criterio directivo y experto.</a:t>
+            </a:r>
+          </a:p>
+        </p:txBody>
+      </p:sp>
+      <p:sp>
+        <p:nvSpPr>
+          <p:cNvPr id="23" name="Rectangle 22"/>
+          <p:cNvSpPr/>
+          <p:nvPr/>
+        </p:nvSpPr>
+        <p:spPr>
+          <a:xfrm>
+            <a:off x="1005840" y="4800600"/>
+            <a:ext cx="73152" cy="777240"/>
+          </a:xfrm>
+          <a:prstGeom prst="rect">
+            <a:avLst/>
+          </a:prstGeom>
+          <a:solidFill>
+            <a:srgbClr val="D32F7A"/>
+          </a:solidFill>
+          <a:ln>
+            <a:noFill/>
+          </a:ln>
+        </p:spPr>
+        <p:style>
+          <a:lnRef idx="1">
+            <a:schemeClr val="accent1"/>
+          </a:lnRef>
+          <a:fillRef idx="3">
+            <a:schemeClr val="accent1"/>
+          </a:fillRef>
+          <a:effectRef idx="2">
+            <a:schemeClr val="accent1"/>
+          </a:effectRef>
+          <a:fontRef idx="minor">
+            <a:schemeClr val="lt1"/>
+          </a:fontRef>
+        </p:style>
+        <p:txBody>
+          <a:bodyPr rtlCol="0" anchor="ctr"/>
+          <a:lstStyle/>
+          <a:p>
+            <a:pPr algn="ctr"/>
+          </a:p>
+        </p:txBody>
+      </p:sp>
+      <p:sp>
+        <p:nvSpPr>
+          <p:cNvPr id="24" name="TextBox 23"/>
+          <p:cNvSpPr txBox="1"/>
+          <p:nvPr/>
+        </p:nvSpPr>
+        <p:spPr>
+          <a:xfrm>
+            <a:off x="658368" y="6446520"/>
+            <a:ext cx="4023360" cy="182880"/>
           </a:xfrm>
           <a:prstGeom prst="rect">
             <a:avLst/>
@@ -5530,26 +5783,408 @@
               </a:lnSpc>
             </a:pPr>
             <a:r>
-              <a:rPr sz="2200" b="1">
+              <a:rPr sz="850" b="0">
                 <a:solidFill>
                   <a:srgbClr val="69696C"/>
                 </a:solidFill>
                 <a:latin typeface="Aptos"/>
               </a:rPr>
-              <a:t>→</a:t>
-            </a:r>
-          </a:p>
-        </p:txBody>
-      </p:sp>
-      <p:sp>
-        <p:nvSpPr>
-          <p:cNvPr id="19" name="Rounded Rectangle 18"/>
+              <a:t>EXCELENCIA · IA organizacional</a:t>
+            </a:r>
+          </a:p>
+        </p:txBody>
+      </p:sp>
+      <p:sp>
+        <p:nvSpPr>
+          <p:cNvPr id="25" name="TextBox 24"/>
+          <p:cNvSpPr txBox="1"/>
+          <p:nvPr/>
+        </p:nvSpPr>
+        <p:spPr>
+          <a:xfrm>
+            <a:off x="11109960" y="6446520"/>
+            <a:ext cx="411480" cy="182880"/>
+          </a:xfrm>
+          <a:prstGeom prst="rect">
+            <a:avLst/>
+          </a:prstGeom>
+          <a:noFill/>
+        </p:spPr>
+        <p:txBody>
+          <a:bodyPr wrap="square">
+            <a:normAutofit/>
+          </a:bodyPr>
+          <a:lstStyle/>
+          <a:p>
+            <a:pPr algn="r">
+              <a:lnSpc>
+                <a:spcPct val="100000"/>
+              </a:lnSpc>
+            </a:pPr>
+            <a:r>
+              <a:rPr sz="850" b="0">
+                <a:solidFill>
+                  <a:srgbClr val="69696C"/>
+                </a:solidFill>
+                <a:latin typeface="Aptos"/>
+              </a:rPr>
+              <a:t>11</a:t>
+            </a:r>
+          </a:p>
+        </p:txBody>
+      </p:sp>
+      <p:sp>
+        <p:nvSpPr>
+          <p:cNvPr id="26" name="Rectangle 25"/>
           <p:cNvSpPr/>
           <p:nvPr/>
         </p:nvSpPr>
         <p:spPr>
           <a:xfrm>
-            <a:off x="8229600" y="1965960"/>
+            <a:off x="658368" y="6345936"/>
+            <a:ext cx="10881360" cy="9144"/>
+          </a:xfrm>
+          <a:prstGeom prst="rect">
+            <a:avLst/>
+          </a:prstGeom>
+          <a:solidFill>
+            <a:srgbClr val="E1E4E8"/>
+          </a:solidFill>
+          <a:ln>
+            <a:noFill/>
+          </a:ln>
+        </p:spPr>
+        <p:style>
+          <a:lnRef idx="1">
+            <a:schemeClr val="accent1"/>
+          </a:lnRef>
+          <a:fillRef idx="3">
+            <a:schemeClr val="accent1"/>
+          </a:fillRef>
+          <a:effectRef idx="2">
+            <a:schemeClr val="accent1"/>
+          </a:effectRef>
+          <a:fontRef idx="minor">
+            <a:schemeClr val="lt1"/>
+          </a:fontRef>
+        </p:style>
+        <p:txBody>
+          <a:bodyPr rtlCol="0" anchor="ctr"/>
+          <a:lstStyle/>
+          <a:p>
+            <a:pPr algn="ctr"/>
+          </a:p>
+        </p:txBody>
+      </p:sp>
+    </p:spTree>
+  </p:cSld>
+  <p:clrMapOvr>
+    <a:masterClrMapping/>
+  </p:clrMapOvr>
+</p:sld>
+</file>
+
+<file path=ppt/slides/slide12.xml><?xml version="1.0" encoding="utf-8"?>
+<p:sld xmlns:a="http://schemas.openxmlformats.org/drawingml/2006/main" xmlns:p="http://schemas.openxmlformats.org/presentationml/2006/main" xmlns:r="http://schemas.openxmlformats.org/officeDocument/2006/relationships">
+  <p:cSld>
+    <p:bg>
+      <p:bgPr>
+        <a:solidFill>
+          <a:srgbClr val="FFFFFF"/>
+        </a:solidFill>
+        <a:effectLst/>
+      </p:bgPr>
+    </p:bg>
+    <p:spTree>
+      <p:nvGrpSpPr>
+        <p:cNvPr id="1" name=""/>
+        <p:cNvGrpSpPr/>
+        <p:nvPr/>
+      </p:nvGrpSpPr>
+      <p:grpSpPr/>
+      <p:sp>
+        <p:nvSpPr>
+          <p:cNvPr id="2" name="TextBox 1"/>
+          <p:cNvSpPr txBox="1"/>
+          <p:nvPr/>
+        </p:nvSpPr>
+        <p:spPr>
+          <a:xfrm>
+            <a:off x="658368" y="411480"/>
+            <a:ext cx="7772400" cy="292608"/>
+          </a:xfrm>
+          <a:prstGeom prst="rect">
+            <a:avLst/>
+          </a:prstGeom>
+          <a:noFill/>
+        </p:spPr>
+        <p:txBody>
+          <a:bodyPr wrap="square">
+            <a:normAutofit/>
+          </a:bodyPr>
+          <a:lstStyle/>
+          <a:p>
+            <a:pPr algn="l">
+              <a:lnSpc>
+                <a:spcPct val="100000"/>
+              </a:lnSpc>
+            </a:pPr>
+            <a:r>
+              <a:rPr sz="1050" b="1">
+                <a:solidFill>
+                  <a:srgbClr val="00ADB5"/>
+                </a:solidFill>
+                <a:latin typeface="Aptos"/>
+              </a:rPr>
+              <a:t>SÍNTESIS EJECUTIVA</a:t>
+            </a:r>
+          </a:p>
+        </p:txBody>
+      </p:sp>
+      <p:sp>
+        <p:nvSpPr>
+          <p:cNvPr id="3" name="TextBox 2"/>
+          <p:cNvSpPr txBox="1"/>
+          <p:nvPr/>
+        </p:nvSpPr>
+        <p:spPr>
+          <a:xfrm>
+            <a:off x="621792" y="685800"/>
+            <a:ext cx="8961120" cy="713232"/>
+          </a:xfrm>
+          <a:prstGeom prst="rect">
+            <a:avLst/>
+          </a:prstGeom>
+          <a:noFill/>
+        </p:spPr>
+        <p:txBody>
+          <a:bodyPr wrap="square">
+            <a:normAutofit/>
+          </a:bodyPr>
+          <a:lstStyle/>
+          <a:p>
+            <a:pPr algn="l">
+              <a:lnSpc>
+                <a:spcPct val="100000"/>
+              </a:lnSpc>
+            </a:pPr>
+            <a:r>
+              <a:rPr sz="2700" b="1">
+                <a:solidFill>
+                  <a:srgbClr val="373739"/>
+                </a:solidFill>
+                <a:latin typeface="Aptos"/>
+              </a:rPr>
+              <a:t>Cierre: la secuencia de madurez</a:t>
+            </a:r>
+          </a:p>
+        </p:txBody>
+      </p:sp>
+      <p:pic>
+        <p:nvPicPr>
+          <p:cNvPr id="4" name="Picture 3" descr="excelencia-logo.png"/>
+          <p:cNvPicPr>
+            <a:picLocks noChangeAspect="1"/>
+          </p:cNvPicPr>
+          <p:nvPr/>
+        </p:nvPicPr>
+        <p:blipFill>
+          <a:blip r:embed="rId2"/>
+          <a:stretch>
+            <a:fillRect/>
+          </a:stretch>
+        </p:blipFill>
+        <p:spPr>
+          <a:xfrm>
+            <a:off x="9372600" y="292608"/>
+            <a:ext cx="2148840" cy="537210"/>
+          </a:xfrm>
+          <a:prstGeom prst="rect">
+            <a:avLst/>
+          </a:prstGeom>
+        </p:spPr>
+      </p:pic>
+      <p:sp>
+        <p:nvSpPr>
+          <p:cNvPr id="5" name="Rectangle 4"/>
+          <p:cNvSpPr/>
+          <p:nvPr/>
+        </p:nvSpPr>
+        <p:spPr>
+          <a:xfrm>
+            <a:off x="658368" y="1481328"/>
+            <a:ext cx="292608" cy="50292"/>
+          </a:xfrm>
+          <a:prstGeom prst="rect">
+            <a:avLst/>
+          </a:prstGeom>
+          <a:solidFill>
+            <a:srgbClr val="F6BB26"/>
+          </a:solidFill>
+          <a:ln>
+            <a:noFill/>
+          </a:ln>
+        </p:spPr>
+        <p:style>
+          <a:lnRef idx="1">
+            <a:schemeClr val="accent1"/>
+          </a:lnRef>
+          <a:fillRef idx="3">
+            <a:schemeClr val="accent1"/>
+          </a:fillRef>
+          <a:effectRef idx="2">
+            <a:schemeClr val="accent1"/>
+          </a:effectRef>
+          <a:fontRef idx="minor">
+            <a:schemeClr val="lt1"/>
+          </a:fontRef>
+        </p:style>
+        <p:txBody>
+          <a:bodyPr rtlCol="0" anchor="ctr"/>
+          <a:lstStyle/>
+          <a:p>
+            <a:pPr algn="ctr"/>
+          </a:p>
+        </p:txBody>
+      </p:sp>
+      <p:sp>
+        <p:nvSpPr>
+          <p:cNvPr id="6" name="Rectangle 5"/>
+          <p:cNvSpPr/>
+          <p:nvPr/>
+        </p:nvSpPr>
+        <p:spPr>
+          <a:xfrm>
+            <a:off x="1042415" y="1481328"/>
+            <a:ext cx="292608" cy="50292"/>
+          </a:xfrm>
+          <a:prstGeom prst="rect">
+            <a:avLst/>
+          </a:prstGeom>
+          <a:solidFill>
+            <a:srgbClr val="EF6F28"/>
+          </a:solidFill>
+          <a:ln>
+            <a:noFill/>
+          </a:ln>
+        </p:spPr>
+        <p:style>
+          <a:lnRef idx="1">
+            <a:schemeClr val="accent1"/>
+          </a:lnRef>
+          <a:fillRef idx="3">
+            <a:schemeClr val="accent1"/>
+          </a:fillRef>
+          <a:effectRef idx="2">
+            <a:schemeClr val="accent1"/>
+          </a:effectRef>
+          <a:fontRef idx="minor">
+            <a:schemeClr val="lt1"/>
+          </a:fontRef>
+        </p:style>
+        <p:txBody>
+          <a:bodyPr rtlCol="0" anchor="ctr"/>
+          <a:lstStyle/>
+          <a:p>
+            <a:pPr algn="ctr"/>
+          </a:p>
+        </p:txBody>
+      </p:sp>
+      <p:sp>
+        <p:nvSpPr>
+          <p:cNvPr id="7" name="Rectangle 6"/>
+          <p:cNvSpPr/>
+          <p:nvPr/>
+        </p:nvSpPr>
+        <p:spPr>
+          <a:xfrm>
+            <a:off x="1426464" y="1481328"/>
+            <a:ext cx="292608" cy="50292"/>
+          </a:xfrm>
+          <a:prstGeom prst="rect">
+            <a:avLst/>
+          </a:prstGeom>
+          <a:solidFill>
+            <a:srgbClr val="D32F7A"/>
+          </a:solidFill>
+          <a:ln>
+            <a:noFill/>
+          </a:ln>
+        </p:spPr>
+        <p:style>
+          <a:lnRef idx="1">
+            <a:schemeClr val="accent1"/>
+          </a:lnRef>
+          <a:fillRef idx="3">
+            <a:schemeClr val="accent1"/>
+          </a:fillRef>
+          <a:effectRef idx="2">
+            <a:schemeClr val="accent1"/>
+          </a:effectRef>
+          <a:fontRef idx="minor">
+            <a:schemeClr val="lt1"/>
+          </a:fontRef>
+        </p:style>
+        <p:txBody>
+          <a:bodyPr rtlCol="0" anchor="ctr"/>
+          <a:lstStyle/>
+          <a:p>
+            <a:pPr algn="ctr"/>
+          </a:p>
+        </p:txBody>
+      </p:sp>
+      <p:sp>
+        <p:nvSpPr>
+          <p:cNvPr id="8" name="Rectangle 7"/>
+          <p:cNvSpPr/>
+          <p:nvPr/>
+        </p:nvSpPr>
+        <p:spPr>
+          <a:xfrm>
+            <a:off x="1810512" y="1481328"/>
+            <a:ext cx="292608" cy="50292"/>
+          </a:xfrm>
+          <a:prstGeom prst="rect">
+            <a:avLst/>
+          </a:prstGeom>
+          <a:solidFill>
+            <a:srgbClr val="00ADB5"/>
+          </a:solidFill>
+          <a:ln>
+            <a:noFill/>
+          </a:ln>
+        </p:spPr>
+        <p:style>
+          <a:lnRef idx="1">
+            <a:schemeClr val="accent1"/>
+          </a:lnRef>
+          <a:fillRef idx="3">
+            <a:schemeClr val="accent1"/>
+          </a:fillRef>
+          <a:effectRef idx="2">
+            <a:schemeClr val="accent1"/>
+          </a:effectRef>
+          <a:fontRef idx="minor">
+            <a:schemeClr val="lt1"/>
+          </a:fontRef>
+        </p:style>
+        <p:txBody>
+          <a:bodyPr rtlCol="0" anchor="ctr"/>
+          <a:lstStyle/>
+          <a:p>
+            <a:pPr algn="ctr"/>
+          </a:p>
+        </p:txBody>
+      </p:sp>
+      <p:sp>
+        <p:nvSpPr>
+          <p:cNvPr id="9" name="Rounded Rectangle 8"/>
+          <p:cNvSpPr/>
+          <p:nvPr/>
+        </p:nvSpPr>
+        <p:spPr>
+          <a:xfrm>
+            <a:off x="914400" y="1965960"/>
             <a:ext cx="2971800" cy="1417320"/>
           </a:xfrm>
           <a:prstGeom prst="roundRect">
@@ -5588,20 +6223,20 @@
       </p:sp>
       <p:sp>
         <p:nvSpPr>
-          <p:cNvPr id="20" name="Rectangle 19"/>
+          <p:cNvPr id="10" name="Rectangle 9"/>
           <p:cNvSpPr/>
           <p:nvPr/>
         </p:nvSpPr>
         <p:spPr>
           <a:xfrm>
-            <a:off x="8229600" y="1965960"/>
+            <a:off x="914400" y="1965960"/>
             <a:ext cx="73152" cy="1417320"/>
           </a:xfrm>
           <a:prstGeom prst="rect">
             <a:avLst/>
           </a:prstGeom>
           <a:solidFill>
-            <a:srgbClr val="D32F7A"/>
+            <a:srgbClr val="F6BB26"/>
           </a:solidFill>
           <a:ln>
             <a:noFill/>
@@ -5631,13 +6266,13 @@
       </p:sp>
       <p:sp>
         <p:nvSpPr>
-          <p:cNvPr id="21" name="TextBox 20"/>
+          <p:cNvPr id="11" name="TextBox 10"/>
           <p:cNvSpPr txBox="1"/>
           <p:nvPr/>
         </p:nvSpPr>
         <p:spPr>
           <a:xfrm>
-            <a:off x="8458200" y="2130552"/>
+            <a:off x="1143000" y="2130552"/>
             <a:ext cx="2560320" cy="320040"/>
           </a:xfrm>
           <a:prstGeom prst="rect">
@@ -5663,20 +6298,20 @@
                 </a:solidFill>
                 <a:latin typeface="Aptos"/>
               </a:rPr>
-              <a:t>Agentes gobernados</a:t>
-            </a:r>
-          </a:p>
-        </p:txBody>
-      </p:sp>
-      <p:sp>
-        <p:nvSpPr>
-          <p:cNvPr id="22" name="TextBox 21"/>
+              <a:t>Información confiable</a:t>
+            </a:r>
+          </a:p>
+        </p:txBody>
+      </p:sp>
+      <p:sp>
+        <p:nvSpPr>
+          <p:cNvPr id="12" name="TextBox 11"/>
           <p:cNvSpPr txBox="1"/>
           <p:nvPr/>
         </p:nvSpPr>
         <p:spPr>
           <a:xfrm>
-            <a:off x="8458200" y="2578608"/>
+            <a:off x="1143000" y="2578608"/>
             <a:ext cx="2560320" cy="667512"/>
           </a:xfrm>
           <a:prstGeom prst="rect">
@@ -5702,30 +6337,71 @@
                 </a:solidFill>
                 <a:latin typeface="Aptos"/>
               </a:rPr>
-              <a:t>tareas/procesos con métricas y resultados</a:t>
-            </a:r>
-          </a:p>
-        </p:txBody>
-      </p:sp>
-      <p:sp>
-        <p:nvSpPr>
-          <p:cNvPr id="23" name="Rounded Rectangle 22"/>
+              <a:t>documentación vigente + datos íntegros</a:t>
+            </a:r>
+          </a:p>
+        </p:txBody>
+      </p:sp>
+      <p:sp>
+        <p:nvSpPr>
+          <p:cNvPr id="13" name="TextBox 12"/>
+          <p:cNvSpPr txBox="1"/>
+          <p:nvPr/>
+        </p:nvSpPr>
+        <p:spPr>
+          <a:xfrm>
+            <a:off x="3977639" y="2450592"/>
+            <a:ext cx="320040" cy="201168"/>
+          </a:xfrm>
+          <a:prstGeom prst="rect">
+            <a:avLst/>
+          </a:prstGeom>
+          <a:noFill/>
+        </p:spPr>
+        <p:txBody>
+          <a:bodyPr wrap="square">
+            <a:normAutofit/>
+          </a:bodyPr>
+          <a:lstStyle/>
+          <a:p>
+            <a:pPr algn="l">
+              <a:lnSpc>
+                <a:spcPct val="100000"/>
+              </a:lnSpc>
+            </a:pPr>
+            <a:r>
+              <a:rPr sz="2200" b="1">
+                <a:solidFill>
+                  <a:srgbClr val="69696C"/>
+                </a:solidFill>
+                <a:latin typeface="Aptos"/>
+              </a:rPr>
+              <a:t>→</a:t>
+            </a:r>
+          </a:p>
+        </p:txBody>
+      </p:sp>
+      <p:sp>
+        <p:nvSpPr>
+          <p:cNvPr id="14" name="Rounded Rectangle 13"/>
           <p:cNvSpPr/>
           <p:nvPr/>
         </p:nvSpPr>
         <p:spPr>
           <a:xfrm>
-            <a:off x="914400" y="4160520"/>
-            <a:ext cx="10241280" cy="914400"/>
+            <a:off x="4572000" y="1965960"/>
+            <a:ext cx="2971800" cy="1417320"/>
           </a:xfrm>
           <a:prstGeom prst="roundRect">
             <a:avLst/>
           </a:prstGeom>
           <a:solidFill>
-            <a:srgbClr val="F4F6F8"/>
-          </a:solidFill>
-          <a:ln>
-            <a:noFill/>
+            <a:srgbClr val="FFFFFF"/>
+          </a:solidFill>
+          <a:ln w="12700">
+            <a:solidFill>
+              <a:srgbClr val="E1E4E8"/>
+            </a:solidFill>
           </a:ln>
         </p:spPr>
         <p:style>
@@ -5752,6 +6428,375 @@
       </p:sp>
       <p:sp>
         <p:nvSpPr>
+          <p:cNvPr id="15" name="Rectangle 14"/>
+          <p:cNvSpPr/>
+          <p:nvPr/>
+        </p:nvSpPr>
+        <p:spPr>
+          <a:xfrm>
+            <a:off x="4572000" y="1965960"/>
+            <a:ext cx="73152" cy="1417320"/>
+          </a:xfrm>
+          <a:prstGeom prst="rect">
+            <a:avLst/>
+          </a:prstGeom>
+          <a:solidFill>
+            <a:srgbClr val="EF6F28"/>
+          </a:solidFill>
+          <a:ln>
+            <a:noFill/>
+          </a:ln>
+        </p:spPr>
+        <p:style>
+          <a:lnRef idx="1">
+            <a:schemeClr val="accent1"/>
+          </a:lnRef>
+          <a:fillRef idx="3">
+            <a:schemeClr val="accent1"/>
+          </a:fillRef>
+          <a:effectRef idx="2">
+            <a:schemeClr val="accent1"/>
+          </a:effectRef>
+          <a:fontRef idx="minor">
+            <a:schemeClr val="lt1"/>
+          </a:fontRef>
+        </p:style>
+        <p:txBody>
+          <a:bodyPr rtlCol="0" anchor="ctr"/>
+          <a:lstStyle/>
+          <a:p>
+            <a:pPr algn="ctr"/>
+          </a:p>
+        </p:txBody>
+      </p:sp>
+      <p:sp>
+        <p:nvSpPr>
+          <p:cNvPr id="16" name="TextBox 15"/>
+          <p:cNvSpPr txBox="1"/>
+          <p:nvPr/>
+        </p:nvSpPr>
+        <p:spPr>
+          <a:xfrm>
+            <a:off x="4800600" y="2130552"/>
+            <a:ext cx="2560320" cy="320040"/>
+          </a:xfrm>
+          <a:prstGeom prst="rect">
+            <a:avLst/>
+          </a:prstGeom>
+          <a:noFill/>
+        </p:spPr>
+        <p:txBody>
+          <a:bodyPr wrap="square">
+            <a:normAutofit/>
+          </a:bodyPr>
+          <a:lstStyle/>
+          <a:p>
+            <a:pPr algn="l">
+              <a:lnSpc>
+                <a:spcPct val="100000"/>
+              </a:lnSpc>
+            </a:pPr>
+            <a:r>
+              <a:rPr sz="1550" b="1">
+                <a:solidFill>
+                  <a:srgbClr val="373739"/>
+                </a:solidFill>
+                <a:latin typeface="Aptos"/>
+              </a:rPr>
+              <a:t>IA con gobierno</a:t>
+            </a:r>
+          </a:p>
+        </p:txBody>
+      </p:sp>
+      <p:sp>
+        <p:nvSpPr>
+          <p:cNvPr id="17" name="TextBox 16"/>
+          <p:cNvSpPr txBox="1"/>
+          <p:nvPr/>
+        </p:nvSpPr>
+        <p:spPr>
+          <a:xfrm>
+            <a:off x="4800600" y="2578608"/>
+            <a:ext cx="2560320" cy="667512"/>
+          </a:xfrm>
+          <a:prstGeom prst="rect">
+            <a:avLst/>
+          </a:prstGeom>
+          <a:noFill/>
+        </p:spPr>
+        <p:txBody>
+          <a:bodyPr wrap="square">
+            <a:normAutofit/>
+          </a:bodyPr>
+          <a:lstStyle/>
+          <a:p>
+            <a:pPr algn="l">
+              <a:lnSpc>
+                <a:spcPct val="100000"/>
+              </a:lnSpc>
+            </a:pPr>
+            <a:r>
+              <a:rPr sz="1260" b="0">
+                <a:solidFill>
+                  <a:srgbClr val="69696C"/>
+                </a:solidFill>
+                <a:latin typeface="Aptos"/>
+              </a:rPr>
+              <a:t>fuentes, permisos, validación y trazabilidad</a:t>
+            </a:r>
+          </a:p>
+        </p:txBody>
+      </p:sp>
+      <p:sp>
+        <p:nvSpPr>
+          <p:cNvPr id="18" name="TextBox 17"/>
+          <p:cNvSpPr txBox="1"/>
+          <p:nvPr/>
+        </p:nvSpPr>
+        <p:spPr>
+          <a:xfrm>
+            <a:off x="7635240" y="2450592"/>
+            <a:ext cx="320040" cy="201168"/>
+          </a:xfrm>
+          <a:prstGeom prst="rect">
+            <a:avLst/>
+          </a:prstGeom>
+          <a:noFill/>
+        </p:spPr>
+        <p:txBody>
+          <a:bodyPr wrap="square">
+            <a:normAutofit/>
+          </a:bodyPr>
+          <a:lstStyle/>
+          <a:p>
+            <a:pPr algn="l">
+              <a:lnSpc>
+                <a:spcPct val="100000"/>
+              </a:lnSpc>
+            </a:pPr>
+            <a:r>
+              <a:rPr sz="2200" b="1">
+                <a:solidFill>
+                  <a:srgbClr val="69696C"/>
+                </a:solidFill>
+                <a:latin typeface="Aptos"/>
+              </a:rPr>
+              <a:t>→</a:t>
+            </a:r>
+          </a:p>
+        </p:txBody>
+      </p:sp>
+      <p:sp>
+        <p:nvSpPr>
+          <p:cNvPr id="19" name="Rounded Rectangle 18"/>
+          <p:cNvSpPr/>
+          <p:nvPr/>
+        </p:nvSpPr>
+        <p:spPr>
+          <a:xfrm>
+            <a:off x="8229600" y="1965960"/>
+            <a:ext cx="2971800" cy="1417320"/>
+          </a:xfrm>
+          <a:prstGeom prst="roundRect">
+            <a:avLst/>
+          </a:prstGeom>
+          <a:solidFill>
+            <a:srgbClr val="FFFFFF"/>
+          </a:solidFill>
+          <a:ln w="12700">
+            <a:solidFill>
+              <a:srgbClr val="E1E4E8"/>
+            </a:solidFill>
+          </a:ln>
+        </p:spPr>
+        <p:style>
+          <a:lnRef idx="1">
+            <a:schemeClr val="accent1"/>
+          </a:lnRef>
+          <a:fillRef idx="3">
+            <a:schemeClr val="accent1"/>
+          </a:fillRef>
+          <a:effectRef idx="2">
+            <a:schemeClr val="accent1"/>
+          </a:effectRef>
+          <a:fontRef idx="minor">
+            <a:schemeClr val="lt1"/>
+          </a:fontRef>
+        </p:style>
+        <p:txBody>
+          <a:bodyPr rtlCol="0" anchor="ctr"/>
+          <a:lstStyle/>
+          <a:p>
+            <a:pPr algn="ctr"/>
+          </a:p>
+        </p:txBody>
+      </p:sp>
+      <p:sp>
+        <p:nvSpPr>
+          <p:cNvPr id="20" name="Rectangle 19"/>
+          <p:cNvSpPr/>
+          <p:nvPr/>
+        </p:nvSpPr>
+        <p:spPr>
+          <a:xfrm>
+            <a:off x="8229600" y="1965960"/>
+            <a:ext cx="73152" cy="1417320"/>
+          </a:xfrm>
+          <a:prstGeom prst="rect">
+            <a:avLst/>
+          </a:prstGeom>
+          <a:solidFill>
+            <a:srgbClr val="D32F7A"/>
+          </a:solidFill>
+          <a:ln>
+            <a:noFill/>
+          </a:ln>
+        </p:spPr>
+        <p:style>
+          <a:lnRef idx="1">
+            <a:schemeClr val="accent1"/>
+          </a:lnRef>
+          <a:fillRef idx="3">
+            <a:schemeClr val="accent1"/>
+          </a:fillRef>
+          <a:effectRef idx="2">
+            <a:schemeClr val="accent1"/>
+          </a:effectRef>
+          <a:fontRef idx="minor">
+            <a:schemeClr val="lt1"/>
+          </a:fontRef>
+        </p:style>
+        <p:txBody>
+          <a:bodyPr rtlCol="0" anchor="ctr"/>
+          <a:lstStyle/>
+          <a:p>
+            <a:pPr algn="ctr"/>
+          </a:p>
+        </p:txBody>
+      </p:sp>
+      <p:sp>
+        <p:nvSpPr>
+          <p:cNvPr id="21" name="TextBox 20"/>
+          <p:cNvSpPr txBox="1"/>
+          <p:nvPr/>
+        </p:nvSpPr>
+        <p:spPr>
+          <a:xfrm>
+            <a:off x="8458200" y="2130552"/>
+            <a:ext cx="2560320" cy="320040"/>
+          </a:xfrm>
+          <a:prstGeom prst="rect">
+            <a:avLst/>
+          </a:prstGeom>
+          <a:noFill/>
+        </p:spPr>
+        <p:txBody>
+          <a:bodyPr wrap="square">
+            <a:normAutofit/>
+          </a:bodyPr>
+          <a:lstStyle/>
+          <a:p>
+            <a:pPr algn="l">
+              <a:lnSpc>
+                <a:spcPct val="100000"/>
+              </a:lnSpc>
+            </a:pPr>
+            <a:r>
+              <a:rPr sz="1550" b="1">
+                <a:solidFill>
+                  <a:srgbClr val="373739"/>
+                </a:solidFill>
+                <a:latin typeface="Aptos"/>
+              </a:rPr>
+              <a:t>Agentes gobernados</a:t>
+            </a:r>
+          </a:p>
+        </p:txBody>
+      </p:sp>
+      <p:sp>
+        <p:nvSpPr>
+          <p:cNvPr id="22" name="TextBox 21"/>
+          <p:cNvSpPr txBox="1"/>
+          <p:nvPr/>
+        </p:nvSpPr>
+        <p:spPr>
+          <a:xfrm>
+            <a:off x="8458200" y="2578608"/>
+            <a:ext cx="2560320" cy="667512"/>
+          </a:xfrm>
+          <a:prstGeom prst="rect">
+            <a:avLst/>
+          </a:prstGeom>
+          <a:noFill/>
+        </p:spPr>
+        <p:txBody>
+          <a:bodyPr wrap="square">
+            <a:normAutofit/>
+          </a:bodyPr>
+          <a:lstStyle/>
+          <a:p>
+            <a:pPr algn="l">
+              <a:lnSpc>
+                <a:spcPct val="100000"/>
+              </a:lnSpc>
+            </a:pPr>
+            <a:r>
+              <a:rPr sz="1260" b="0">
+                <a:solidFill>
+                  <a:srgbClr val="69696C"/>
+                </a:solidFill>
+                <a:latin typeface="Aptos"/>
+              </a:rPr>
+              <a:t>tareas/procesos con métricas y resultados</a:t>
+            </a:r>
+          </a:p>
+        </p:txBody>
+      </p:sp>
+      <p:sp>
+        <p:nvSpPr>
+          <p:cNvPr id="23" name="Rounded Rectangle 22"/>
+          <p:cNvSpPr/>
+          <p:nvPr/>
+        </p:nvSpPr>
+        <p:spPr>
+          <a:xfrm>
+            <a:off x="914400" y="4160520"/>
+            <a:ext cx="10241280" cy="914400"/>
+          </a:xfrm>
+          <a:prstGeom prst="roundRect">
+            <a:avLst/>
+          </a:prstGeom>
+          <a:solidFill>
+            <a:srgbClr val="F4F6F8"/>
+          </a:solidFill>
+          <a:ln>
+            <a:noFill/>
+          </a:ln>
+        </p:spPr>
+        <p:style>
+          <a:lnRef idx="1">
+            <a:schemeClr val="accent1"/>
+          </a:lnRef>
+          <a:fillRef idx="3">
+            <a:schemeClr val="accent1"/>
+          </a:fillRef>
+          <a:effectRef idx="2">
+            <a:schemeClr val="accent1"/>
+          </a:effectRef>
+          <a:fontRef idx="minor">
+            <a:schemeClr val="lt1"/>
+          </a:fontRef>
+        </p:style>
+        <p:txBody>
+          <a:bodyPr rtlCol="0" anchor="ctr"/>
+          <a:lstStyle/>
+          <a:p>
+            <a:pPr algn="ctr"/>
+          </a:p>
+        </p:txBody>
+      </p:sp>
+      <p:sp>
+        <p:nvSpPr>
           <p:cNvPr id="24" name="TextBox 23"/>
           <p:cNvSpPr txBox="1"/>
           <p:nvPr/>
@@ -5944,7 +6989,7 @@
                 </a:solidFill>
                 <a:latin typeface="Aptos"/>
               </a:rPr>
-              <a:t>11</a:t>
+              <a:t>12</a:t>
             </a:r>
           </a:p>
         </p:txBody>
@@ -14082,7 +15127,7 @@
                 </a:solidFill>
                 <a:latin typeface="Aptos"/>
               </a:rPr>
-              <a:t>Tecnología y software</a:t>
+              <a:t>Tecnología y sistemas</a:t>
             </a:r>
           </a:p>
         </p:txBody>
@@ -14684,7 +15729,7 @@
                 </a:solidFill>
                 <a:latin typeface="Aptos"/>
               </a:rPr>
-              <a:t>Caso 1 · Documentación, calidad, ISO y PNC</a:t>
+              <a:t>Caso único · Documentación, calidad, ISO y PNC</a:t>
             </a:r>
           </a:p>
         </p:txBody>
@@ -15324,7 +16369,7 @@
                 <a:latin typeface="Aptos"/>
               </a:rPr>
               <a:t>Evidencias, brechas
-y acciones</a:t>
+y oportunidades</a:t>
             </a:r>
           </a:p>
         </p:txBody>
@@ -15492,103 +16537,25 @@
       </p:sp>
       <p:sp>
         <p:nvSpPr>
-          <p:cNvPr id="24" name="TextBox 23"/>
-          <p:cNvSpPr txBox="1"/>
-          <p:nvPr/>
-        </p:nvSpPr>
-        <p:spPr>
-          <a:xfrm>
-            <a:off x="914400" y="3063240"/>
-            <a:ext cx="4892040" cy="1554480"/>
-          </a:xfrm>
-          <a:prstGeom prst="rect">
-            <a:avLst/>
-          </a:prstGeom>
-          <a:noFill/>
-        </p:spPr>
-        <p:txBody>
-          <a:bodyPr wrap="square">
-            <a:normAutofit/>
-          </a:bodyPr>
-          <a:lstStyle/>
-          <a:p>
-            <a:pPr>
-              <a:lnSpc>
-                <a:spcPct val="104000"/>
-              </a:lnSpc>
-              <a:spcAft>
-                <a:spcPts val="900"/>
-              </a:spcAft>
-              <a:defRPr sz="1550">
-                <a:solidFill>
-                  <a:srgbClr val="373739"/>
-                </a:solidFill>
-                <a:latin typeface="Aptos"/>
-              </a:defRPr>
-            </a:pPr>
-            <a:r>
-              <a:t>• Velocidad en lectura sistemática.</a:t>
-            </a:r>
-          </a:p>
-          <a:p>
-            <a:pPr>
-              <a:lnSpc>
-                <a:spcPct val="104000"/>
-              </a:lnSpc>
-              <a:spcAft>
-                <a:spcPts val="900"/>
-              </a:spcAft>
-              <a:defRPr sz="1550">
-                <a:solidFill>
-                  <a:srgbClr val="373739"/>
-                </a:solidFill>
-                <a:latin typeface="Aptos"/>
-              </a:defRPr>
-            </a:pPr>
-            <a:r>
-              <a:t>• Trazabilidad entre requisito y evidencia.</a:t>
-            </a:r>
-          </a:p>
-          <a:p>
-            <a:pPr>
-              <a:lnSpc>
-                <a:spcPct val="104000"/>
-              </a:lnSpc>
-              <a:spcAft>
-                <a:spcPts val="900"/>
-              </a:spcAft>
-              <a:defRPr sz="1550">
-                <a:solidFill>
-                  <a:srgbClr val="373739"/>
-                </a:solidFill>
-                <a:latin typeface="Aptos"/>
-              </a:defRPr>
-            </a:pPr>
-            <a:r>
-              <a:t>• Mayor consistencia para matrices complejas.</a:t>
-            </a:r>
-          </a:p>
-        </p:txBody>
-      </p:sp>
-      <p:sp>
-        <p:nvSpPr>
-          <p:cNvPr id="25" name="Rounded Rectangle 24"/>
+          <p:cNvPr id="24" name="Rounded Rectangle 23"/>
           <p:cNvSpPr/>
           <p:nvPr/>
         </p:nvSpPr>
         <p:spPr>
           <a:xfrm>
-            <a:off x="6309360" y="2971800"/>
-            <a:ext cx="4846320" cy="1417320"/>
+            <a:off x="914400" y="3154680"/>
+            <a:ext cx="4709160" cy="1234440"/>
           </a:xfrm>
           <a:prstGeom prst="roundRect">
             <a:avLst/>
           </a:prstGeom>
           <a:solidFill>
-            <a:srgbClr val="F4F6F8"/>
-          </a:solidFill>
-          <a:ln>
-            <a:noFill/>
+            <a:srgbClr val="FFFFFF"/>
+          </a:solidFill>
+          <a:ln w="12700">
+            <a:solidFill>
+              <a:srgbClr val="E1E4E8"/>
+            </a:solidFill>
           </a:ln>
         </p:spPr>
         <p:style>
@@ -15615,14 +16582,344 @@
       </p:sp>
       <p:sp>
         <p:nvSpPr>
+          <p:cNvPr id="25" name="Rectangle 24"/>
+          <p:cNvSpPr/>
+          <p:nvPr/>
+        </p:nvSpPr>
+        <p:spPr>
+          <a:xfrm>
+            <a:off x="914400" y="3154680"/>
+            <a:ext cx="73152" cy="1234440"/>
+          </a:xfrm>
+          <a:prstGeom prst="rect">
+            <a:avLst/>
+          </a:prstGeom>
+          <a:solidFill>
+            <a:srgbClr val="00ADB5"/>
+          </a:solidFill>
+          <a:ln>
+            <a:noFill/>
+          </a:ln>
+        </p:spPr>
+        <p:style>
+          <a:lnRef idx="1">
+            <a:schemeClr val="accent1"/>
+          </a:lnRef>
+          <a:fillRef idx="3">
+            <a:schemeClr val="accent1"/>
+          </a:fillRef>
+          <a:effectRef idx="2">
+            <a:schemeClr val="accent1"/>
+          </a:effectRef>
+          <a:fontRef idx="minor">
+            <a:schemeClr val="lt1"/>
+          </a:fontRef>
+        </p:style>
+        <p:txBody>
+          <a:bodyPr rtlCol="0" anchor="ctr"/>
+          <a:lstStyle/>
+          <a:p>
+            <a:pPr algn="ctr"/>
+          </a:p>
+        </p:txBody>
+      </p:sp>
+      <p:sp>
+        <p:nvSpPr>
           <p:cNvPr id="26" name="TextBox 25"/>
           <p:cNvSpPr txBox="1"/>
           <p:nvPr/>
         </p:nvSpPr>
         <p:spPr>
           <a:xfrm>
-            <a:off x="6565392" y="3172968"/>
-            <a:ext cx="4334256" cy="1033272"/>
+            <a:off x="1143000" y="3319272"/>
+            <a:ext cx="4297680" cy="320040"/>
+          </a:xfrm>
+          <a:prstGeom prst="rect">
+            <a:avLst/>
+          </a:prstGeom>
+          <a:noFill/>
+        </p:spPr>
+        <p:txBody>
+          <a:bodyPr wrap="square">
+            <a:normAutofit/>
+          </a:bodyPr>
+          <a:lstStyle/>
+          <a:p>
+            <a:pPr algn="l">
+              <a:lnSpc>
+                <a:spcPct val="100000"/>
+              </a:lnSpc>
+            </a:pPr>
+            <a:r>
+              <a:rPr sz="1550" b="1">
+                <a:solidFill>
+                  <a:srgbClr val="373739"/>
+                </a:solidFill>
+                <a:latin typeface="Aptos"/>
+              </a:rPr>
+              <a:t>Subejemplo ISO</a:t>
+            </a:r>
+          </a:p>
+        </p:txBody>
+      </p:sp>
+      <p:sp>
+        <p:nvSpPr>
+          <p:cNvPr id="27" name="TextBox 26"/>
+          <p:cNvSpPr txBox="1"/>
+          <p:nvPr/>
+        </p:nvSpPr>
+        <p:spPr>
+          <a:xfrm>
+            <a:off x="1143000" y="3767328"/>
+            <a:ext cx="4297680" cy="484632"/>
+          </a:xfrm>
+          <a:prstGeom prst="rect">
+            <a:avLst/>
+          </a:prstGeom>
+          <a:noFill/>
+        </p:spPr>
+        <p:txBody>
+          <a:bodyPr wrap="square">
+            <a:normAutofit/>
+          </a:bodyPr>
+          <a:lstStyle/>
+          <a:p>
+            <a:pPr algn="l">
+              <a:lnSpc>
+                <a:spcPct val="100000"/>
+              </a:lnSpc>
+            </a:pPr>
+            <a:r>
+              <a:rPr sz="1280" b="0">
+                <a:solidFill>
+                  <a:srgbClr val="69696C"/>
+                </a:solidFill>
+                <a:latin typeface="Aptos"/>
+              </a:rPr>
+              <a:t>Requisitos, evidencia, cobertura, brechas y acciones de cierre.</a:t>
+            </a:r>
+          </a:p>
+        </p:txBody>
+      </p:sp>
+      <p:sp>
+        <p:nvSpPr>
+          <p:cNvPr id="28" name="Rounded Rectangle 27"/>
+          <p:cNvSpPr/>
+          <p:nvPr/>
+        </p:nvSpPr>
+        <p:spPr>
+          <a:xfrm>
+            <a:off x="6172200" y="3154680"/>
+            <a:ext cx="4709160" cy="1234440"/>
+          </a:xfrm>
+          <a:prstGeom prst="roundRect">
+            <a:avLst/>
+          </a:prstGeom>
+          <a:solidFill>
+            <a:srgbClr val="FFFFFF"/>
+          </a:solidFill>
+          <a:ln w="12700">
+            <a:solidFill>
+              <a:srgbClr val="E1E4E8"/>
+            </a:solidFill>
+          </a:ln>
+        </p:spPr>
+        <p:style>
+          <a:lnRef idx="1">
+            <a:schemeClr val="accent1"/>
+          </a:lnRef>
+          <a:fillRef idx="3">
+            <a:schemeClr val="accent1"/>
+          </a:fillRef>
+          <a:effectRef idx="2">
+            <a:schemeClr val="accent1"/>
+          </a:effectRef>
+          <a:fontRef idx="minor">
+            <a:schemeClr val="lt1"/>
+          </a:fontRef>
+        </p:style>
+        <p:txBody>
+          <a:bodyPr rtlCol="0" anchor="ctr"/>
+          <a:lstStyle/>
+          <a:p>
+            <a:pPr algn="ctr"/>
+          </a:p>
+        </p:txBody>
+      </p:sp>
+      <p:sp>
+        <p:nvSpPr>
+          <p:cNvPr id="29" name="Rectangle 28"/>
+          <p:cNvSpPr/>
+          <p:nvPr/>
+        </p:nvSpPr>
+        <p:spPr>
+          <a:xfrm>
+            <a:off x="6172200" y="3154680"/>
+            <a:ext cx="73152" cy="1234440"/>
+          </a:xfrm>
+          <a:prstGeom prst="rect">
+            <a:avLst/>
+          </a:prstGeom>
+          <a:solidFill>
+            <a:srgbClr val="D32F7A"/>
+          </a:solidFill>
+          <a:ln>
+            <a:noFill/>
+          </a:ln>
+        </p:spPr>
+        <p:style>
+          <a:lnRef idx="1">
+            <a:schemeClr val="accent1"/>
+          </a:lnRef>
+          <a:fillRef idx="3">
+            <a:schemeClr val="accent1"/>
+          </a:fillRef>
+          <a:effectRef idx="2">
+            <a:schemeClr val="accent1"/>
+          </a:effectRef>
+          <a:fontRef idx="minor">
+            <a:schemeClr val="lt1"/>
+          </a:fontRef>
+        </p:style>
+        <p:txBody>
+          <a:bodyPr rtlCol="0" anchor="ctr"/>
+          <a:lstStyle/>
+          <a:p>
+            <a:pPr algn="ctr"/>
+          </a:p>
+        </p:txBody>
+      </p:sp>
+      <p:sp>
+        <p:nvSpPr>
+          <p:cNvPr id="30" name="TextBox 29"/>
+          <p:cNvSpPr txBox="1"/>
+          <p:nvPr/>
+        </p:nvSpPr>
+        <p:spPr>
+          <a:xfrm>
+            <a:off x="6400800" y="3319272"/>
+            <a:ext cx="4297680" cy="320040"/>
+          </a:xfrm>
+          <a:prstGeom prst="rect">
+            <a:avLst/>
+          </a:prstGeom>
+          <a:noFill/>
+        </p:spPr>
+        <p:txBody>
+          <a:bodyPr wrap="square">
+            <a:normAutofit/>
+          </a:bodyPr>
+          <a:lstStyle/>
+          <a:p>
+            <a:pPr algn="l">
+              <a:lnSpc>
+                <a:spcPct val="100000"/>
+              </a:lnSpc>
+            </a:pPr>
+            <a:r>
+              <a:rPr sz="1550" b="1">
+                <a:solidFill>
+                  <a:srgbClr val="373739"/>
+                </a:solidFill>
+                <a:latin typeface="Aptos"/>
+              </a:rPr>
+              <a:t>Subejemplo PNC</a:t>
+            </a:r>
+          </a:p>
+        </p:txBody>
+      </p:sp>
+      <p:sp>
+        <p:nvSpPr>
+          <p:cNvPr id="31" name="TextBox 30"/>
+          <p:cNvSpPr txBox="1"/>
+          <p:nvPr/>
+        </p:nvSpPr>
+        <p:spPr>
+          <a:xfrm>
+            <a:off x="6400800" y="3767328"/>
+            <a:ext cx="4297680" cy="484632"/>
+          </a:xfrm>
+          <a:prstGeom prst="rect">
+            <a:avLst/>
+          </a:prstGeom>
+          <a:noFill/>
+        </p:spPr>
+        <p:txBody>
+          <a:bodyPr wrap="square">
+            <a:normAutofit/>
+          </a:bodyPr>
+          <a:lstStyle/>
+          <a:p>
+            <a:pPr algn="l">
+              <a:lnSpc>
+                <a:spcPct val="100000"/>
+              </a:lnSpc>
+            </a:pPr>
+            <a:r>
+              <a:rPr sz="1280" b="0">
+                <a:solidFill>
+                  <a:srgbClr val="69696C"/>
+                </a:solidFill>
+                <a:latin typeface="Aptos"/>
+              </a:rPr>
+              <a:t>Modelo de excelencia, fortalezas, oportunidades de mejora e insumos de evaluación.</a:t>
+            </a:r>
+          </a:p>
+        </p:txBody>
+      </p:sp>
+      <p:sp>
+        <p:nvSpPr>
+          <p:cNvPr id="32" name="Rounded Rectangle 31"/>
+          <p:cNvSpPr/>
+          <p:nvPr/>
+        </p:nvSpPr>
+        <p:spPr>
+          <a:xfrm>
+            <a:off x="960120" y="4892040"/>
+            <a:ext cx="10149840" cy="749808"/>
+          </a:xfrm>
+          <a:prstGeom prst="roundRect">
+            <a:avLst/>
+          </a:prstGeom>
+          <a:solidFill>
+            <a:srgbClr val="F4F6F8"/>
+          </a:solidFill>
+          <a:ln>
+            <a:noFill/>
+          </a:ln>
+        </p:spPr>
+        <p:style>
+          <a:lnRef idx="1">
+            <a:schemeClr val="accent1"/>
+          </a:lnRef>
+          <a:fillRef idx="3">
+            <a:schemeClr val="accent1"/>
+          </a:fillRef>
+          <a:effectRef idx="2">
+            <a:schemeClr val="accent1"/>
+          </a:effectRef>
+          <a:fontRef idx="minor">
+            <a:schemeClr val="lt1"/>
+          </a:fontRef>
+        </p:style>
+        <p:txBody>
+          <a:bodyPr rtlCol="0" anchor="ctr"/>
+          <a:lstStyle/>
+          <a:p>
+            <a:pPr algn="ctr"/>
+          </a:p>
+        </p:txBody>
+      </p:sp>
+      <p:sp>
+        <p:nvSpPr>
+          <p:cNvPr id="33" name="TextBox 32"/>
+          <p:cNvSpPr txBox="1"/>
+          <p:nvPr/>
+        </p:nvSpPr>
+        <p:spPr>
+          <a:xfrm>
+            <a:off x="1216152" y="5093207"/>
+            <a:ext cx="9637776" cy="365759"/>
           </a:xfrm>
           <a:prstGeom prst="rect">
             <a:avLst/>
@@ -15654,14 +16951,14 @@
       </p:sp>
       <p:sp>
         <p:nvSpPr>
-          <p:cNvPr id="27" name="Rectangle 26"/>
+          <p:cNvPr id="34" name="Rectangle 33"/>
           <p:cNvSpPr/>
           <p:nvPr/>
         </p:nvSpPr>
         <p:spPr>
           <a:xfrm>
-            <a:off x="6309360" y="2971800"/>
-            <a:ext cx="73152" cy="1417320"/>
+            <a:off x="960120" y="4892040"/>
+            <a:ext cx="73152" cy="749808"/>
           </a:xfrm>
           <a:prstGeom prst="rect">
             <a:avLst/>
@@ -15697,7 +16994,7 @@
       </p:sp>
       <p:sp>
         <p:nvSpPr>
-          <p:cNvPr id="28" name="TextBox 27"/>
+          <p:cNvPr id="35" name="TextBox 34"/>
           <p:cNvSpPr txBox="1"/>
           <p:nvPr/>
         </p:nvSpPr>
@@ -15736,7 +17033,7 @@
       </p:sp>
       <p:sp>
         <p:nvSpPr>
-          <p:cNvPr id="29" name="TextBox 28"/>
+          <p:cNvPr id="36" name="TextBox 35"/>
           <p:cNvSpPr txBox="1"/>
           <p:nvPr/>
         </p:nvSpPr>
@@ -15775,7 +17072,7 @@
       </p:sp>
       <p:sp>
         <p:nvSpPr>
-          <p:cNvPr id="30" name="Rectangle 29"/>
+          <p:cNvPr id="37" name="Rectangle 36"/>
           <p:cNvSpPr/>
           <p:nvPr/>
         </p:nvSpPr>

</xml_diff>

<commit_message>
Armar subejemplo ISO con matriz VMOS
</commit_message>
<xml_diff>
--- a/presentacion/charla-excelencia-ia-organizacional.pptx
+++ b/presentacion/charla-excelencia-ia-organizacional.pptx
@@ -3887,7 +3887,7 @@
                 </a:solidFill>
                 <a:latin typeface="Aptos"/>
               </a:rPr>
-              <a:t>Subejemplo ISO · Matriz de gaps y evidencia</a:t>
+              <a:t>Subejemplo ISO · Matriz de gaps VMOS</a:t>
             </a:r>
           </a:p>
         </p:txBody>
@@ -4090,14 +4090,53 @@
       </p:sp>
       <p:sp>
         <p:nvSpPr>
-          <p:cNvPr id="9" name="Rounded Rectangle 8"/>
+          <p:cNvPr id="9" name="TextBox 8"/>
+          <p:cNvSpPr txBox="1"/>
+          <p:nvPr/>
+        </p:nvSpPr>
+        <p:spPr>
+          <a:xfrm>
+            <a:off x="786384" y="1627632"/>
+            <a:ext cx="9692640" cy="256032"/>
+          </a:xfrm>
+          <a:prstGeom prst="rect">
+            <a:avLst/>
+          </a:prstGeom>
+          <a:noFill/>
+        </p:spPr>
+        <p:txBody>
+          <a:bodyPr wrap="square">
+            <a:normAutofit/>
+          </a:bodyPr>
+          <a:lstStyle/>
+          <a:p>
+            <a:pPr algn="l">
+              <a:lnSpc>
+                <a:spcPct val="100000"/>
+              </a:lnSpc>
+            </a:pPr>
+            <a:r>
+              <a:rPr sz="1150" b="0">
+                <a:solidFill>
+                  <a:srgbClr val="69696C"/>
+                </a:solidFill>
+                <a:latin typeface="Aptos"/>
+              </a:rPr>
+              <a:t>Muestra real tomada de matriz-gaps-iso-vmos.xlsx · filas Excel 14 a 23 · ids 13 a 22 · cláusula 6</a:t>
+            </a:r>
+          </a:p>
+        </p:txBody>
+      </p:sp>
+      <p:sp>
+        <p:nvSpPr>
+          <p:cNvPr id="10" name="Rounded Rectangle 9"/>
           <p:cNvSpPr/>
           <p:nvPr/>
         </p:nvSpPr>
         <p:spPr>
           <a:xfrm>
-            <a:off x="777240" y="1874519"/>
-            <a:ext cx="3291840" cy="2194560"/>
+            <a:off x="777240" y="1993392"/>
+            <a:ext cx="2514600" cy="1170432"/>
           </a:xfrm>
           <a:prstGeom prst="roundRect">
             <a:avLst/>
@@ -4135,14 +4174,14 @@
       </p:sp>
       <p:sp>
         <p:nvSpPr>
-          <p:cNvPr id="10" name="Rectangle 9"/>
+          <p:cNvPr id="11" name="Rectangle 10"/>
           <p:cNvSpPr/>
           <p:nvPr/>
         </p:nvSpPr>
         <p:spPr>
           <a:xfrm>
-            <a:off x="777240" y="1874519"/>
-            <a:ext cx="73152" cy="2194560"/>
+            <a:off x="777240" y="1993392"/>
+            <a:ext cx="73152" cy="1170432"/>
           </a:xfrm>
           <a:prstGeom prst="rect">
             <a:avLst/>
@@ -4178,14 +4217,14 @@
       </p:sp>
       <p:sp>
         <p:nvSpPr>
-          <p:cNvPr id="11" name="TextBox 10"/>
+          <p:cNvPr id="12" name="TextBox 11"/>
           <p:cNvSpPr txBox="1"/>
           <p:nvPr/>
         </p:nvSpPr>
         <p:spPr>
           <a:xfrm>
-            <a:off x="1005840" y="2039112"/>
-            <a:ext cx="2880360" cy="320040"/>
+            <a:off x="1005840" y="2157984"/>
+            <a:ext cx="2103120" cy="320040"/>
           </a:xfrm>
           <a:prstGeom prst="rect">
             <a:avLst/>
@@ -4204,27 +4243,27 @@
               </a:lnSpc>
             </a:pPr>
             <a:r>
-              <a:rPr sz="1600" b="1">
+              <a:rPr sz="1500" b="1">
                 <a:solidFill>
                   <a:srgbClr val="373739"/>
                 </a:solidFill>
                 <a:latin typeface="Aptos"/>
               </a:rPr>
-              <a:t>Entrada</a:t>
-            </a:r>
-          </a:p>
-        </p:txBody>
-      </p:sp>
-      <p:sp>
-        <p:nvSpPr>
-          <p:cNvPr id="12" name="TextBox 11"/>
+              <a:t>Alcance</a:t>
+            </a:r>
+          </a:p>
+        </p:txBody>
+      </p:sp>
+      <p:sp>
+        <p:nvSpPr>
+          <p:cNvPr id="13" name="TextBox 12"/>
           <p:cNvSpPr txBox="1"/>
           <p:nvPr/>
         </p:nvSpPr>
         <p:spPr>
           <a:xfrm>
-            <a:off x="1005840" y="2487168"/>
-            <a:ext cx="2880360" cy="1444752"/>
+            <a:off x="1005840" y="2606040"/>
+            <a:ext cx="2103120" cy="420624"/>
           </a:xfrm>
           <a:prstGeom prst="rect">
             <a:avLst/>
@@ -4243,27 +4282,27 @@
               </a:lnSpc>
             </a:pPr>
             <a:r>
-              <a:rPr sz="1300" b="0">
+              <a:rPr sz="1160" b="0">
                 <a:solidFill>
                   <a:srgbClr val="69696C"/>
                 </a:solidFill>
                 <a:latin typeface="Aptos"/>
               </a:rPr>
-              <a:t>Requisito normativo, documentos, registros y procesos vinculados.</a:t>
-            </a:r>
-          </a:p>
-        </p:txBody>
-      </p:sp>
-      <p:sp>
-        <p:nvSpPr>
-          <p:cNvPr id="13" name="Rounded Rectangle 12"/>
+              <a:t>10 requisitos ISO de planificación: riesgos, ambiente, SST, legales, objetivos y cambios.</a:t>
+            </a:r>
+          </a:p>
+        </p:txBody>
+      </p:sp>
+      <p:sp>
+        <p:nvSpPr>
+          <p:cNvPr id="14" name="Rounded Rectangle 13"/>
           <p:cNvSpPr/>
           <p:nvPr/>
         </p:nvSpPr>
         <p:spPr>
           <a:xfrm>
-            <a:off x="4434840" y="1874519"/>
-            <a:ext cx="3291840" cy="2194560"/>
+            <a:off x="3520440" y="1993392"/>
+            <a:ext cx="2514600" cy="1170432"/>
           </a:xfrm>
           <a:prstGeom prst="roundRect">
             <a:avLst/>
@@ -4301,14 +4340,14 @@
       </p:sp>
       <p:sp>
         <p:nvSpPr>
-          <p:cNvPr id="14" name="Rectangle 13"/>
+          <p:cNvPr id="15" name="Rectangle 14"/>
           <p:cNvSpPr/>
           <p:nvPr/>
         </p:nvSpPr>
         <p:spPr>
           <a:xfrm>
-            <a:off x="4434840" y="1874519"/>
-            <a:ext cx="73152" cy="2194560"/>
+            <a:off x="3520440" y="1993392"/>
+            <a:ext cx="73152" cy="1170432"/>
           </a:xfrm>
           <a:prstGeom prst="rect">
             <a:avLst/>
@@ -4344,14 +4383,14 @@
       </p:sp>
       <p:sp>
         <p:nvSpPr>
-          <p:cNvPr id="15" name="TextBox 14"/>
+          <p:cNvPr id="16" name="TextBox 15"/>
           <p:cNvSpPr txBox="1"/>
           <p:nvPr/>
         </p:nvSpPr>
         <p:spPr>
           <a:xfrm>
-            <a:off x="4663440" y="2039112"/>
-            <a:ext cx="2880360" cy="320040"/>
+            <a:off x="3749039" y="2157984"/>
+            <a:ext cx="2103120" cy="320040"/>
           </a:xfrm>
           <a:prstGeom prst="rect">
             <a:avLst/>
@@ -4370,27 +4409,27 @@
               </a:lnSpc>
             </a:pPr>
             <a:r>
-              <a:rPr sz="1600" b="1">
+              <a:rPr sz="1500" b="1">
                 <a:solidFill>
                   <a:srgbClr val="373739"/>
                 </a:solidFill>
                 <a:latin typeface="Aptos"/>
               </a:rPr>
-              <a:t>Trabajo del agente</a:t>
-            </a:r>
-          </a:p>
-        </p:txBody>
-      </p:sp>
-      <p:sp>
-        <p:nvSpPr>
-          <p:cNvPr id="16" name="TextBox 15"/>
+              <a:t>Resultado</a:t>
+            </a:r>
+          </a:p>
+        </p:txBody>
+      </p:sp>
+      <p:sp>
+        <p:nvSpPr>
+          <p:cNvPr id="17" name="TextBox 16"/>
           <p:cNvSpPr txBox="1"/>
           <p:nvPr/>
         </p:nvSpPr>
         <p:spPr>
           <a:xfrm>
-            <a:off x="4663440" y="2487168"/>
-            <a:ext cx="2880360" cy="1444752"/>
+            <a:off x="3749039" y="2606040"/>
+            <a:ext cx="2103120" cy="420624"/>
           </a:xfrm>
           <a:prstGeom prst="rect">
             <a:avLst/>
@@ -4409,27 +4448,27 @@
               </a:lnSpc>
             </a:pPr>
             <a:r>
-              <a:rPr sz="1300" b="0">
+              <a:rPr sz="1160" b="0">
                 <a:solidFill>
                   <a:srgbClr val="69696C"/>
                 </a:solidFill>
                 <a:latin typeface="Aptos"/>
               </a:rPr>
-              <a:t>Busca evidencia, ubica citas, propone cobertura, justifica brechas y ordena acciones.</a:t>
-            </a:r>
-          </a:p>
-        </p:txBody>
-      </p:sp>
-      <p:sp>
-        <p:nvSpPr>
-          <p:cNvPr id="17" name="Rounded Rectangle 16"/>
+              <a:t>3 cubiertos y 7 parciales. La matriz distingue evidencia suficiente de brechas documentales.</a:t>
+            </a:r>
+          </a:p>
+        </p:txBody>
+      </p:sp>
+      <p:sp>
+        <p:nvSpPr>
+          <p:cNvPr id="18" name="Rounded Rectangle 17"/>
           <p:cNvSpPr/>
           <p:nvPr/>
         </p:nvSpPr>
         <p:spPr>
           <a:xfrm>
-            <a:off x="8092440" y="1874519"/>
-            <a:ext cx="3291840" cy="2194560"/>
+            <a:off x="6263640" y="1993392"/>
+            <a:ext cx="2514600" cy="1170432"/>
           </a:xfrm>
           <a:prstGeom prst="roundRect">
             <a:avLst/>
@@ -4467,14 +4506,14 @@
       </p:sp>
       <p:sp>
         <p:nvSpPr>
-          <p:cNvPr id="18" name="Rectangle 17"/>
+          <p:cNvPr id="19" name="Rectangle 18"/>
           <p:cNvSpPr/>
           <p:nvPr/>
         </p:nvSpPr>
         <p:spPr>
           <a:xfrm>
-            <a:off x="8092440" y="1874519"/>
-            <a:ext cx="73152" cy="2194560"/>
+            <a:off x="6263640" y="1993392"/>
+            <a:ext cx="73152" cy="1170432"/>
           </a:xfrm>
           <a:prstGeom prst="rect">
             <a:avLst/>
@@ -4510,14 +4549,14 @@
       </p:sp>
       <p:sp>
         <p:nvSpPr>
-          <p:cNvPr id="19" name="TextBox 18"/>
+          <p:cNvPr id="20" name="TextBox 19"/>
           <p:cNvSpPr txBox="1"/>
           <p:nvPr/>
         </p:nvSpPr>
         <p:spPr>
           <a:xfrm>
-            <a:off x="8321040" y="2039112"/>
-            <a:ext cx="2880360" cy="320040"/>
+            <a:off x="6492240" y="2157984"/>
+            <a:ext cx="2103120" cy="320040"/>
           </a:xfrm>
           <a:prstGeom prst="rect">
             <a:avLst/>
@@ -4536,27 +4575,27 @@
               </a:lnSpc>
             </a:pPr>
             <a:r>
-              <a:rPr sz="1600" b="1">
+              <a:rPr sz="1500" b="1">
                 <a:solidFill>
                   <a:srgbClr val="373739"/>
                 </a:solidFill>
                 <a:latin typeface="Aptos"/>
               </a:rPr>
-              <a:t>Salida útil</a:t>
-            </a:r>
-          </a:p>
-        </p:txBody>
-      </p:sp>
-      <p:sp>
-        <p:nvSpPr>
-          <p:cNvPr id="20" name="TextBox 19"/>
+              <a:t>Evidencias</a:t>
+            </a:r>
+          </a:p>
+        </p:txBody>
+      </p:sp>
+      <p:sp>
+        <p:nvSpPr>
+          <p:cNvPr id="21" name="TextBox 20"/>
           <p:cNvSpPr txBox="1"/>
           <p:nvPr/>
         </p:nvSpPr>
         <p:spPr>
           <a:xfrm>
-            <a:off x="8321040" y="2487168"/>
-            <a:ext cx="2880360" cy="1444752"/>
+            <a:off x="6492240" y="2606040"/>
+            <a:ext cx="2103120" cy="420624"/>
           </a:xfrm>
           <a:prstGeom prst="rect">
             <a:avLst/>
@@ -4575,36 +4614,38 @@
               </a:lnSpc>
             </a:pPr>
             <a:r>
-              <a:rPr sz="1300" b="0">
+              <a:rPr sz="1140" b="0">
                 <a:solidFill>
                   <a:srgbClr val="69696C"/>
                 </a:solidFill>
                 <a:latin typeface="Aptos"/>
               </a:rPr>
-              <a:t>Matriz trazable: requisito, evidencia, ubicación, justificación, brecha, acción y prioridad.</a:t>
-            </a:r>
-          </a:p>
-        </p:txBody>
-      </p:sp>
-      <p:sp>
-        <p:nvSpPr>
-          <p:cNvPr id="21" name="Rounded Rectangle 20"/>
+              <a:t>PRO-EXC-RIE, PRO-EXC-AMB, PRO-EXC-SOP, PRO-EXC-REQ y proceso de Excelencia.</a:t>
+            </a:r>
+          </a:p>
+        </p:txBody>
+      </p:sp>
+      <p:sp>
+        <p:nvSpPr>
+          <p:cNvPr id="22" name="Rounded Rectangle 21"/>
           <p:cNvSpPr/>
           <p:nvPr/>
         </p:nvSpPr>
         <p:spPr>
           <a:xfrm>
-            <a:off x="1005840" y="4800600"/>
-            <a:ext cx="10104120" cy="777240"/>
+            <a:off x="9006840" y="1993392"/>
+            <a:ext cx="2514600" cy="1170432"/>
           </a:xfrm>
           <a:prstGeom prst="roundRect">
             <a:avLst/>
           </a:prstGeom>
           <a:solidFill>
-            <a:srgbClr val="F4F6F8"/>
-          </a:solidFill>
-          <a:ln>
-            <a:noFill/>
+            <a:srgbClr val="FFFFFF"/>
+          </a:solidFill>
+          <a:ln w="12700">
+            <a:solidFill>
+              <a:srgbClr val="E1E4E8"/>
+            </a:solidFill>
           </a:ln>
         </p:spPr>
         <p:style>
@@ -4631,14 +4672,662 @@
       </p:sp>
       <p:sp>
         <p:nvSpPr>
-          <p:cNvPr id="22" name="TextBox 21"/>
+          <p:cNvPr id="23" name="Rectangle 22"/>
+          <p:cNvSpPr/>
+          <p:nvPr/>
+        </p:nvSpPr>
+        <p:spPr>
+          <a:xfrm>
+            <a:off x="9006840" y="1993392"/>
+            <a:ext cx="73152" cy="1170432"/>
+          </a:xfrm>
+          <a:prstGeom prst="rect">
+            <a:avLst/>
+          </a:prstGeom>
+          <a:solidFill>
+            <a:srgbClr val="F6BB26"/>
+          </a:solidFill>
+          <a:ln>
+            <a:noFill/>
+          </a:ln>
+        </p:spPr>
+        <p:style>
+          <a:lnRef idx="1">
+            <a:schemeClr val="accent1"/>
+          </a:lnRef>
+          <a:fillRef idx="3">
+            <a:schemeClr val="accent1"/>
+          </a:fillRef>
+          <a:effectRef idx="2">
+            <a:schemeClr val="accent1"/>
+          </a:effectRef>
+          <a:fontRef idx="minor">
+            <a:schemeClr val="lt1"/>
+          </a:fontRef>
+        </p:style>
+        <p:txBody>
+          <a:bodyPr rtlCol="0" anchor="ctr"/>
+          <a:lstStyle/>
+          <a:p>
+            <a:pPr algn="ctr"/>
+          </a:p>
+        </p:txBody>
+      </p:sp>
+      <p:sp>
+        <p:nvSpPr>
+          <p:cNvPr id="24" name="TextBox 23"/>
           <p:cNvSpPr txBox="1"/>
           <p:nvPr/>
         </p:nvSpPr>
         <p:spPr>
           <a:xfrm>
-            <a:off x="1261872" y="5001768"/>
-            <a:ext cx="9592056" cy="393192"/>
+            <a:off x="9235440" y="2157984"/>
+            <a:ext cx="2103120" cy="320040"/>
+          </a:xfrm>
+          <a:prstGeom prst="rect">
+            <a:avLst/>
+          </a:prstGeom>
+          <a:noFill/>
+        </p:spPr>
+        <p:txBody>
+          <a:bodyPr wrap="square">
+            <a:normAutofit/>
+          </a:bodyPr>
+          <a:lstStyle/>
+          <a:p>
+            <a:pPr algn="l">
+              <a:lnSpc>
+                <a:spcPct val="100000"/>
+              </a:lnSpc>
+            </a:pPr>
+            <a:r>
+              <a:rPr sz="1500" b="1">
+                <a:solidFill>
+                  <a:srgbClr val="373739"/>
+                </a:solidFill>
+                <a:latin typeface="Aptos"/>
+              </a:rPr>
+              <a:t>Brechas</a:t>
+            </a:r>
+          </a:p>
+        </p:txBody>
+      </p:sp>
+      <p:sp>
+        <p:nvSpPr>
+          <p:cNvPr id="25" name="TextBox 24"/>
+          <p:cNvSpPr txBox="1"/>
+          <p:nvPr/>
+        </p:nvSpPr>
+        <p:spPr>
+          <a:xfrm>
+            <a:off x="9235440" y="2606040"/>
+            <a:ext cx="2103120" cy="420624"/>
+          </a:xfrm>
+          <a:prstGeom prst="rect">
+            <a:avLst/>
+          </a:prstGeom>
+          <a:noFill/>
+        </p:spPr>
+        <p:txBody>
+          <a:bodyPr wrap="square">
+            <a:normAutofit/>
+          </a:bodyPr>
+          <a:lstStyle/>
+          <a:p>
+            <a:pPr algn="l">
+              <a:lnSpc>
+                <a:spcPct val="100000"/>
+              </a:lnSpc>
+            </a:pPr>
+            <a:r>
+              <a:rPr sz="1140" b="0">
+                <a:solidFill>
+                  <a:srgbClr val="69696C"/>
+                </a:solidFill>
+                <a:latin typeface="Aptos"/>
+              </a:rPr>
+              <a:t>Faltan registros/matrices integradas para aspectos, SST, objetivos SIG y cambios.</a:t>
+            </a:r>
+          </a:p>
+        </p:txBody>
+      </p:sp>
+      <p:sp>
+        <p:nvSpPr>
+          <p:cNvPr id="26" name="Rounded Rectangle 25"/>
+          <p:cNvSpPr/>
+          <p:nvPr/>
+        </p:nvSpPr>
+        <p:spPr>
+          <a:xfrm>
+            <a:off x="868680" y="3493008"/>
+            <a:ext cx="1325880" cy="310896"/>
+          </a:xfrm>
+          <a:prstGeom prst="roundRect">
+            <a:avLst/>
+          </a:prstGeom>
+          <a:solidFill>
+            <a:srgbClr val="00ADB5"/>
+          </a:solidFill>
+          <a:ln>
+            <a:noFill/>
+          </a:ln>
+        </p:spPr>
+        <p:style>
+          <a:lnRef idx="1">
+            <a:schemeClr val="accent1"/>
+          </a:lnRef>
+          <a:fillRef idx="3">
+            <a:schemeClr val="accent1"/>
+          </a:fillRef>
+          <a:effectRef idx="2">
+            <a:schemeClr val="accent1"/>
+          </a:effectRef>
+          <a:fontRef idx="minor">
+            <a:schemeClr val="lt1"/>
+          </a:fontRef>
+        </p:style>
+        <p:txBody>
+          <a:bodyPr rtlCol="0" anchor="ctr"/>
+          <a:lstStyle/>
+          <a:p>
+            <a:pPr algn="ctr"/>
+          </a:p>
+        </p:txBody>
+      </p:sp>
+      <p:sp>
+        <p:nvSpPr>
+          <p:cNvPr id="27" name="TextBox 26"/>
+          <p:cNvSpPr txBox="1"/>
+          <p:nvPr/>
+        </p:nvSpPr>
+        <p:spPr>
+          <a:xfrm>
+            <a:off x="932688" y="3566160"/>
+            <a:ext cx="1188720" cy="118872"/>
+          </a:xfrm>
+          <a:prstGeom prst="rect">
+            <a:avLst/>
+          </a:prstGeom>
+          <a:noFill/>
+        </p:spPr>
+        <p:txBody>
+          <a:bodyPr wrap="square">
+            <a:normAutofit/>
+          </a:bodyPr>
+          <a:lstStyle/>
+          <a:p>
+            <a:pPr algn="ctr">
+              <a:lnSpc>
+                <a:spcPct val="100000"/>
+              </a:lnSpc>
+            </a:pPr>
+            <a:r>
+              <a:rPr sz="880" b="1">
+                <a:solidFill>
+                  <a:srgbClr val="FFFFFF"/>
+                </a:solidFill>
+                <a:latin typeface="Aptos"/>
+              </a:rPr>
+              <a:t>Cubierto</a:t>
+            </a:r>
+          </a:p>
+        </p:txBody>
+      </p:sp>
+      <p:sp>
+        <p:nvSpPr>
+          <p:cNvPr id="28" name="TextBox 27"/>
+          <p:cNvSpPr txBox="1"/>
+          <p:nvPr/>
+        </p:nvSpPr>
+        <p:spPr>
+          <a:xfrm>
+            <a:off x="2423160" y="3538727"/>
+            <a:ext cx="8366760" cy="201168"/>
+          </a:xfrm>
+          <a:prstGeom prst="rect">
+            <a:avLst/>
+          </a:prstGeom>
+          <a:noFill/>
+        </p:spPr>
+        <p:txBody>
+          <a:bodyPr wrap="square">
+            <a:normAutofit/>
+          </a:bodyPr>
+          <a:lstStyle/>
+          <a:p>
+            <a:pPr algn="l">
+              <a:lnSpc>
+                <a:spcPct val="100000"/>
+              </a:lnSpc>
+            </a:pPr>
+            <a:r>
+              <a:rPr sz="1080" b="0">
+                <a:solidFill>
+                  <a:srgbClr val="373739"/>
+                </a:solidFill>
+                <a:latin typeface="Aptos"/>
+              </a:rPr>
+              <a:t>Riesgos y oportunidades; requisitos legales; planificación de acciones</a:t>
+            </a:r>
+          </a:p>
+        </p:txBody>
+      </p:sp>
+      <p:sp>
+        <p:nvSpPr>
+          <p:cNvPr id="29" name="Rounded Rectangle 28"/>
+          <p:cNvSpPr/>
+          <p:nvPr/>
+        </p:nvSpPr>
+        <p:spPr>
+          <a:xfrm>
+            <a:off x="868680" y="3931920"/>
+            <a:ext cx="1325880" cy="310896"/>
+          </a:xfrm>
+          <a:prstGeom prst="roundRect">
+            <a:avLst/>
+          </a:prstGeom>
+          <a:solidFill>
+            <a:srgbClr val="EF6F28"/>
+          </a:solidFill>
+          <a:ln>
+            <a:noFill/>
+          </a:ln>
+        </p:spPr>
+        <p:style>
+          <a:lnRef idx="1">
+            <a:schemeClr val="accent1"/>
+          </a:lnRef>
+          <a:fillRef idx="3">
+            <a:schemeClr val="accent1"/>
+          </a:fillRef>
+          <a:effectRef idx="2">
+            <a:schemeClr val="accent1"/>
+          </a:effectRef>
+          <a:fontRef idx="minor">
+            <a:schemeClr val="lt1"/>
+          </a:fontRef>
+        </p:style>
+        <p:txBody>
+          <a:bodyPr rtlCol="0" anchor="ctr"/>
+          <a:lstStyle/>
+          <a:p>
+            <a:pPr algn="ctr"/>
+          </a:p>
+        </p:txBody>
+      </p:sp>
+      <p:sp>
+        <p:nvSpPr>
+          <p:cNvPr id="30" name="TextBox 29"/>
+          <p:cNvSpPr txBox="1"/>
+          <p:nvPr/>
+        </p:nvSpPr>
+        <p:spPr>
+          <a:xfrm>
+            <a:off x="932688" y="4005072"/>
+            <a:ext cx="1188720" cy="118872"/>
+          </a:xfrm>
+          <a:prstGeom prst="rect">
+            <a:avLst/>
+          </a:prstGeom>
+          <a:noFill/>
+        </p:spPr>
+        <p:txBody>
+          <a:bodyPr wrap="square">
+            <a:normAutofit/>
+          </a:bodyPr>
+          <a:lstStyle/>
+          <a:p>
+            <a:pPr algn="ctr">
+              <a:lnSpc>
+                <a:spcPct val="100000"/>
+              </a:lnSpc>
+            </a:pPr>
+            <a:r>
+              <a:rPr sz="880" b="1">
+                <a:solidFill>
+                  <a:srgbClr val="FFFFFF"/>
+                </a:solidFill>
+                <a:latin typeface="Aptos"/>
+              </a:rPr>
+              <a:t>Parcial</a:t>
+            </a:r>
+          </a:p>
+        </p:txBody>
+      </p:sp>
+      <p:sp>
+        <p:nvSpPr>
+          <p:cNvPr id="31" name="TextBox 30"/>
+          <p:cNvSpPr txBox="1"/>
+          <p:nvPr/>
+        </p:nvSpPr>
+        <p:spPr>
+          <a:xfrm>
+            <a:off x="2423160" y="3977639"/>
+            <a:ext cx="8366760" cy="201168"/>
+          </a:xfrm>
+          <a:prstGeom prst="rect">
+            <a:avLst/>
+          </a:prstGeom>
+          <a:noFill/>
+        </p:spPr>
+        <p:txBody>
+          <a:bodyPr wrap="square">
+            <a:normAutofit/>
+          </a:bodyPr>
+          <a:lstStyle/>
+          <a:p>
+            <a:pPr algn="l">
+              <a:lnSpc>
+                <a:spcPct val="100000"/>
+              </a:lnSpc>
+            </a:pPr>
+            <a:r>
+              <a:rPr sz="1080" b="0">
+                <a:solidFill>
+                  <a:srgbClr val="373739"/>
+                </a:solidFill>
+                <a:latin typeface="Aptos"/>
+              </a:rPr>
+              <a:t>Aspectos ambientales; peligros/riesgos/oportunidades SST</a:t>
+            </a:r>
+          </a:p>
+        </p:txBody>
+      </p:sp>
+      <p:sp>
+        <p:nvSpPr>
+          <p:cNvPr id="32" name="Rounded Rectangle 31"/>
+          <p:cNvSpPr/>
+          <p:nvPr/>
+        </p:nvSpPr>
+        <p:spPr>
+          <a:xfrm>
+            <a:off x="868680" y="4370831"/>
+            <a:ext cx="1325880" cy="310896"/>
+          </a:xfrm>
+          <a:prstGeom prst="roundRect">
+            <a:avLst/>
+          </a:prstGeom>
+          <a:solidFill>
+            <a:srgbClr val="D32F7A"/>
+          </a:solidFill>
+          <a:ln>
+            <a:noFill/>
+          </a:ln>
+        </p:spPr>
+        <p:style>
+          <a:lnRef idx="1">
+            <a:schemeClr val="accent1"/>
+          </a:lnRef>
+          <a:fillRef idx="3">
+            <a:schemeClr val="accent1"/>
+          </a:fillRef>
+          <a:effectRef idx="2">
+            <a:schemeClr val="accent1"/>
+          </a:effectRef>
+          <a:fontRef idx="minor">
+            <a:schemeClr val="lt1"/>
+          </a:fontRef>
+        </p:style>
+        <p:txBody>
+          <a:bodyPr rtlCol="0" anchor="ctr"/>
+          <a:lstStyle/>
+          <a:p>
+            <a:pPr algn="ctr"/>
+          </a:p>
+        </p:txBody>
+      </p:sp>
+      <p:sp>
+        <p:nvSpPr>
+          <p:cNvPr id="33" name="TextBox 32"/>
+          <p:cNvSpPr txBox="1"/>
+          <p:nvPr/>
+        </p:nvSpPr>
+        <p:spPr>
+          <a:xfrm>
+            <a:off x="932688" y="4443983"/>
+            <a:ext cx="1188720" cy="118872"/>
+          </a:xfrm>
+          <a:prstGeom prst="rect">
+            <a:avLst/>
+          </a:prstGeom>
+          <a:noFill/>
+        </p:spPr>
+        <p:txBody>
+          <a:bodyPr wrap="square">
+            <a:normAutofit/>
+          </a:bodyPr>
+          <a:lstStyle/>
+          <a:p>
+            <a:pPr algn="ctr">
+              <a:lnSpc>
+                <a:spcPct val="100000"/>
+              </a:lnSpc>
+            </a:pPr>
+            <a:r>
+              <a:rPr sz="880" b="1">
+                <a:solidFill>
+                  <a:srgbClr val="FFFFFF"/>
+                </a:solidFill>
+                <a:latin typeface="Aptos"/>
+              </a:rPr>
+              <a:t>Parcial</a:t>
+            </a:r>
+          </a:p>
+        </p:txBody>
+      </p:sp>
+      <p:sp>
+        <p:nvSpPr>
+          <p:cNvPr id="34" name="TextBox 33"/>
+          <p:cNvSpPr txBox="1"/>
+          <p:nvPr/>
+        </p:nvSpPr>
+        <p:spPr>
+          <a:xfrm>
+            <a:off x="2423160" y="4416551"/>
+            <a:ext cx="8366760" cy="201168"/>
+          </a:xfrm>
+          <a:prstGeom prst="rect">
+            <a:avLst/>
+          </a:prstGeom>
+          <a:noFill/>
+        </p:spPr>
+        <p:txBody>
+          <a:bodyPr wrap="square">
+            <a:normAutofit/>
+          </a:bodyPr>
+          <a:lstStyle/>
+          <a:p>
+            <a:pPr algn="l">
+              <a:lnSpc>
+                <a:spcPct val="100000"/>
+              </a:lnSpc>
+            </a:pPr>
+            <a:r>
+              <a:rPr sz="1080" b="0">
+                <a:solidFill>
+                  <a:srgbClr val="373739"/>
+                </a:solidFill>
+                <a:latin typeface="Aptos"/>
+              </a:rPr>
+              <a:t>Objetivos del sistema y planificación para lograrlos</a:t>
+            </a:r>
+          </a:p>
+        </p:txBody>
+      </p:sp>
+      <p:sp>
+        <p:nvSpPr>
+          <p:cNvPr id="35" name="Rounded Rectangle 34"/>
+          <p:cNvSpPr/>
+          <p:nvPr/>
+        </p:nvSpPr>
+        <p:spPr>
+          <a:xfrm>
+            <a:off x="868680" y="4809744"/>
+            <a:ext cx="1325880" cy="310896"/>
+          </a:xfrm>
+          <a:prstGeom prst="roundRect">
+            <a:avLst/>
+          </a:prstGeom>
+          <a:solidFill>
+            <a:srgbClr val="F6BB26"/>
+          </a:solidFill>
+          <a:ln>
+            <a:noFill/>
+          </a:ln>
+        </p:spPr>
+        <p:style>
+          <a:lnRef idx="1">
+            <a:schemeClr val="accent1"/>
+          </a:lnRef>
+          <a:fillRef idx="3">
+            <a:schemeClr val="accent1"/>
+          </a:fillRef>
+          <a:effectRef idx="2">
+            <a:schemeClr val="accent1"/>
+          </a:effectRef>
+          <a:fontRef idx="minor">
+            <a:schemeClr val="lt1"/>
+          </a:fontRef>
+        </p:style>
+        <p:txBody>
+          <a:bodyPr rtlCol="0" anchor="ctr"/>
+          <a:lstStyle/>
+          <a:p>
+            <a:pPr algn="ctr"/>
+          </a:p>
+        </p:txBody>
+      </p:sp>
+      <p:sp>
+        <p:nvSpPr>
+          <p:cNvPr id="36" name="TextBox 35"/>
+          <p:cNvSpPr txBox="1"/>
+          <p:nvPr/>
+        </p:nvSpPr>
+        <p:spPr>
+          <a:xfrm>
+            <a:off x="932688" y="4882896"/>
+            <a:ext cx="1188720" cy="118872"/>
+          </a:xfrm>
+          <a:prstGeom prst="rect">
+            <a:avLst/>
+          </a:prstGeom>
+          <a:noFill/>
+        </p:spPr>
+        <p:txBody>
+          <a:bodyPr wrap="square">
+            <a:normAutofit/>
+          </a:bodyPr>
+          <a:lstStyle/>
+          <a:p>
+            <a:pPr algn="ctr">
+              <a:lnSpc>
+                <a:spcPct val="100000"/>
+              </a:lnSpc>
+            </a:pPr>
+            <a:r>
+              <a:rPr sz="880" b="1">
+                <a:solidFill>
+                  <a:srgbClr val="FFFFFF"/>
+                </a:solidFill>
+                <a:latin typeface="Aptos"/>
+              </a:rPr>
+              <a:t>Parcial</a:t>
+            </a:r>
+          </a:p>
+        </p:txBody>
+      </p:sp>
+      <p:sp>
+        <p:nvSpPr>
+          <p:cNvPr id="37" name="TextBox 36"/>
+          <p:cNvSpPr txBox="1"/>
+          <p:nvPr/>
+        </p:nvSpPr>
+        <p:spPr>
+          <a:xfrm>
+            <a:off x="2423160" y="4855464"/>
+            <a:ext cx="8366760" cy="201168"/>
+          </a:xfrm>
+          <a:prstGeom prst="rect">
+            <a:avLst/>
+          </a:prstGeom>
+          <a:noFill/>
+        </p:spPr>
+        <p:txBody>
+          <a:bodyPr wrap="square">
+            <a:normAutofit/>
+          </a:bodyPr>
+          <a:lstStyle/>
+          <a:p>
+            <a:pPr algn="l">
+              <a:lnSpc>
+                <a:spcPct val="100000"/>
+              </a:lnSpc>
+            </a:pPr>
+            <a:r>
+              <a:rPr sz="1080" b="0">
+                <a:solidFill>
+                  <a:srgbClr val="373739"/>
+                </a:solidFill>
+                <a:latin typeface="Aptos"/>
+              </a:rPr>
+              <a:t>Gestión del cambio: consecuencias, recursos, responsables e impactos SST</a:t>
+            </a:r>
+          </a:p>
+        </p:txBody>
+      </p:sp>
+      <p:sp>
+        <p:nvSpPr>
+          <p:cNvPr id="38" name="Rounded Rectangle 37"/>
+          <p:cNvSpPr/>
+          <p:nvPr/>
+        </p:nvSpPr>
+        <p:spPr>
+          <a:xfrm>
+            <a:off x="868680" y="5440680"/>
+            <a:ext cx="10469880" cy="566928"/>
+          </a:xfrm>
+          <a:prstGeom prst="roundRect">
+            <a:avLst/>
+          </a:prstGeom>
+          <a:solidFill>
+            <a:srgbClr val="F4F6F8"/>
+          </a:solidFill>
+          <a:ln>
+            <a:noFill/>
+          </a:ln>
+        </p:spPr>
+        <p:style>
+          <a:lnRef idx="1">
+            <a:schemeClr val="accent1"/>
+          </a:lnRef>
+          <a:fillRef idx="3">
+            <a:schemeClr val="accent1"/>
+          </a:fillRef>
+          <a:effectRef idx="2">
+            <a:schemeClr val="accent1"/>
+          </a:effectRef>
+          <a:fontRef idx="minor">
+            <a:schemeClr val="lt1"/>
+          </a:fontRef>
+        </p:style>
+        <p:txBody>
+          <a:bodyPr rtlCol="0" anchor="ctr"/>
+          <a:lstStyle/>
+          <a:p>
+            <a:pPr algn="ctr"/>
+          </a:p>
+        </p:txBody>
+      </p:sp>
+      <p:sp>
+        <p:nvSpPr>
+          <p:cNvPr id="39" name="TextBox 38"/>
+          <p:cNvSpPr txBox="1"/>
+          <p:nvPr/>
+        </p:nvSpPr>
+        <p:spPr>
+          <a:xfrm>
+            <a:off x="1124712" y="5641848"/>
+            <a:ext cx="9957815" cy="182880"/>
           </a:xfrm>
           <a:prstGeom prst="rect">
             <a:avLst/>
@@ -4663,21 +5352,21 @@
                 </a:solidFill>
                 <a:latin typeface="Aptos"/>
               </a:rPr>
-              <a:t>En ISO, la IA aporta velocidad y consistencia; la validez depende de evidencia trazable y revisión experta.</a:t>
-            </a:r>
-          </a:p>
-        </p:txBody>
-      </p:sp>
-      <p:sp>
-        <p:nvSpPr>
-          <p:cNvPr id="23" name="Rectangle 22"/>
+              <a:t>Mensaje para la charla: el agente acelera lectura, cruce y trazabilidad; el experto conserva el criterio de cobertura y la decisión final.</a:t>
+            </a:r>
+          </a:p>
+        </p:txBody>
+      </p:sp>
+      <p:sp>
+        <p:nvSpPr>
+          <p:cNvPr id="40" name="Rectangle 39"/>
           <p:cNvSpPr/>
           <p:nvPr/>
         </p:nvSpPr>
         <p:spPr>
           <a:xfrm>
-            <a:off x="1005840" y="4800600"/>
-            <a:ext cx="73152" cy="777240"/>
+            <a:off x="868680" y="5440680"/>
+            <a:ext cx="73152" cy="566928"/>
           </a:xfrm>
           <a:prstGeom prst="rect">
             <a:avLst/>
@@ -4713,7 +5402,7 @@
       </p:sp>
       <p:sp>
         <p:nvSpPr>
-          <p:cNvPr id="24" name="TextBox 23"/>
+          <p:cNvPr id="41" name="TextBox 40"/>
           <p:cNvSpPr txBox="1"/>
           <p:nvPr/>
         </p:nvSpPr>
@@ -4752,7 +5441,7 @@
       </p:sp>
       <p:sp>
         <p:nvSpPr>
-          <p:cNvPr id="25" name="TextBox 24"/>
+          <p:cNvPr id="42" name="TextBox 41"/>
           <p:cNvSpPr txBox="1"/>
           <p:nvPr/>
         </p:nvSpPr>
@@ -4791,7 +5480,7 @@
       </p:sp>
       <p:sp>
         <p:nvSpPr>
-          <p:cNvPr id="26" name="Rectangle 25"/>
+          <p:cNvPr id="43" name="Rectangle 42"/>
           <p:cNvSpPr/>
           <p:nvPr/>
         </p:nvSpPr>

</xml_diff>

<commit_message>
Armar subejemplo PNC con matriz VMOS
</commit_message>
<xml_diff>
--- a/presentacion/charla-excelencia-ia-organizacional.pptx
+++ b/presentacion/charla-excelencia-ia-organizacional.pptx
@@ -5620,7 +5620,7 @@
                 </a:solidFill>
                 <a:latin typeface="Aptos"/>
               </a:rPr>
-              <a:t>Subejemplo PNC · Madurez y oportunidades de mejora</a:t>
+              <a:t>Subejemplo PNC · Planeamiento estratégico VMOS</a:t>
             </a:r>
           </a:p>
         </p:txBody>
@@ -5823,14 +5823,53 @@
       </p:sp>
       <p:sp>
         <p:nvSpPr>
-          <p:cNvPr id="9" name="Rounded Rectangle 8"/>
+          <p:cNvPr id="9" name="TextBox 8"/>
+          <p:cNvSpPr txBox="1"/>
+          <p:nvPr/>
+        </p:nvSpPr>
+        <p:spPr>
+          <a:xfrm>
+            <a:off x="786384" y="1627632"/>
+            <a:ext cx="9784080" cy="256032"/>
+          </a:xfrm>
+          <a:prstGeom prst="rect">
+            <a:avLst/>
+          </a:prstGeom>
+          <a:noFill/>
+        </p:spPr>
+        <p:txBody>
+          <a:bodyPr wrap="square">
+            <a:normAutofit/>
+          </a:bodyPr>
+          <a:lstStyle/>
+          <a:p>
+            <a:pPr algn="l">
+              <a:lnSpc>
+                <a:spcPct val="100000"/>
+              </a:lnSpc>
+            </a:pPr>
+            <a:r>
+              <a:rPr sz="1100" b="0">
+                <a:solidFill>
+                  <a:srgbClr val="69696C"/>
+                </a:solidFill>
+                <a:latin typeface="Aptos"/>
+              </a:rPr>
+              <a:t>Muestra real tomada de matriz-gaps-pnc-vmos.xlsx · filas Excel 14 a 22 · ids 13 a 21 · Criterio 1. Liderazgo / Factor 1.3</a:t>
+            </a:r>
+          </a:p>
+        </p:txBody>
+      </p:sp>
+      <p:sp>
+        <p:nvSpPr>
+          <p:cNvPr id="10" name="Rounded Rectangle 9"/>
           <p:cNvSpPr/>
           <p:nvPr/>
         </p:nvSpPr>
         <p:spPr>
           <a:xfrm>
-            <a:off x="777240" y="1874519"/>
-            <a:ext cx="3291840" cy="2194560"/>
+            <a:off x="777240" y="1993392"/>
+            <a:ext cx="2514600" cy="1170432"/>
           </a:xfrm>
           <a:prstGeom prst="roundRect">
             <a:avLst/>
@@ -5868,20 +5907,20 @@
       </p:sp>
       <p:sp>
         <p:nvSpPr>
-          <p:cNvPr id="10" name="Rectangle 9"/>
+          <p:cNvPr id="11" name="Rectangle 10"/>
           <p:cNvSpPr/>
           <p:nvPr/>
         </p:nvSpPr>
         <p:spPr>
           <a:xfrm>
-            <a:off x="777240" y="1874519"/>
-            <a:ext cx="73152" cy="2194560"/>
-          </a:xfrm>
-          <a:prstGeom prst="rect">
-            <a:avLst/>
-          </a:prstGeom>
-          <a:solidFill>
-            <a:srgbClr val="F6BB26"/>
+            <a:off x="777240" y="1993392"/>
+            <a:ext cx="73152" cy="1170432"/>
+          </a:xfrm>
+          <a:prstGeom prst="rect">
+            <a:avLst/>
+          </a:prstGeom>
+          <a:solidFill>
+            <a:srgbClr val="00ADB5"/>
           </a:solidFill>
           <a:ln>
             <a:noFill/>
@@ -5911,14 +5950,14 @@
       </p:sp>
       <p:sp>
         <p:nvSpPr>
-          <p:cNvPr id="11" name="TextBox 10"/>
+          <p:cNvPr id="12" name="TextBox 11"/>
           <p:cNvSpPr txBox="1"/>
           <p:nvPr/>
         </p:nvSpPr>
         <p:spPr>
           <a:xfrm>
-            <a:off x="1005840" y="2039112"/>
-            <a:ext cx="2880360" cy="320040"/>
+            <a:off x="1005840" y="2157984"/>
+            <a:ext cx="2103120" cy="320040"/>
           </a:xfrm>
           <a:prstGeom prst="rect">
             <a:avLst/>
@@ -5937,27 +5976,27 @@
               </a:lnSpc>
             </a:pPr>
             <a:r>
-              <a:rPr sz="1600" b="1">
+              <a:rPr sz="1500" b="1">
                 <a:solidFill>
                   <a:srgbClr val="373739"/>
                 </a:solidFill>
                 <a:latin typeface="Aptos"/>
               </a:rPr>
-              <a:t>Entrada</a:t>
-            </a:r>
-          </a:p>
-        </p:txBody>
-      </p:sp>
-      <p:sp>
-        <p:nvSpPr>
-          <p:cNvPr id="12" name="TextBox 11"/>
+              <a:t>Alcance</a:t>
+            </a:r>
+          </a:p>
+        </p:txBody>
+      </p:sp>
+      <p:sp>
+        <p:nvSpPr>
+          <p:cNvPr id="13" name="TextBox 12"/>
           <p:cNvSpPr txBox="1"/>
           <p:nvPr/>
         </p:nvSpPr>
         <p:spPr>
           <a:xfrm>
-            <a:off x="1005840" y="2487168"/>
-            <a:ext cx="2880360" cy="1444752"/>
+            <a:off x="1005840" y="2606040"/>
+            <a:ext cx="2103120" cy="420624"/>
           </a:xfrm>
           <a:prstGeom prst="rect">
             <a:avLst/>
@@ -5976,27 +6015,27 @@
               </a:lnSpc>
             </a:pPr>
             <a:r>
-              <a:rPr sz="1300" b="0">
+              <a:rPr sz="1160" b="0">
                 <a:solidFill>
                   <a:srgbClr val="69696C"/>
                 </a:solidFill>
                 <a:latin typeface="Aptos"/>
               </a:rPr>
-              <a:t>Criterios del Modelo para una Gestión de Excelencia y evidencias de gestión.</a:t>
-            </a:r>
-          </a:p>
-        </p:txBody>
-      </p:sp>
-      <p:sp>
-        <p:nvSpPr>
-          <p:cNvPr id="13" name="Rounded Rectangle 12"/>
+              <a:t>9 aspectos del factor 1.3: planeamiento estratégico y operativo.</a:t>
+            </a:r>
+          </a:p>
+        </p:txBody>
+      </p:sp>
+      <p:sp>
+        <p:nvSpPr>
+          <p:cNvPr id="14" name="Rounded Rectangle 13"/>
           <p:cNvSpPr/>
           <p:nvPr/>
         </p:nvSpPr>
         <p:spPr>
           <a:xfrm>
-            <a:off x="4434840" y="1874519"/>
-            <a:ext cx="3291840" cy="2194560"/>
+            <a:off x="3520440" y="1993392"/>
+            <a:ext cx="2514600" cy="1170432"/>
           </a:xfrm>
           <a:prstGeom prst="roundRect">
             <a:avLst/>
@@ -6034,14 +6073,14 @@
       </p:sp>
       <p:sp>
         <p:nvSpPr>
-          <p:cNvPr id="14" name="Rectangle 13"/>
+          <p:cNvPr id="15" name="Rectangle 14"/>
           <p:cNvSpPr/>
           <p:nvPr/>
         </p:nvSpPr>
         <p:spPr>
           <a:xfrm>
-            <a:off x="4434840" y="1874519"/>
-            <a:ext cx="73152" cy="2194560"/>
+            <a:off x="3520440" y="1993392"/>
+            <a:ext cx="73152" cy="1170432"/>
           </a:xfrm>
           <a:prstGeom prst="rect">
             <a:avLst/>
@@ -6077,14 +6116,14 @@
       </p:sp>
       <p:sp>
         <p:nvSpPr>
-          <p:cNvPr id="15" name="TextBox 14"/>
+          <p:cNvPr id="16" name="TextBox 15"/>
           <p:cNvSpPr txBox="1"/>
           <p:nvPr/>
         </p:nvSpPr>
         <p:spPr>
           <a:xfrm>
-            <a:off x="4663440" y="2039112"/>
-            <a:ext cx="2880360" cy="320040"/>
+            <a:off x="3749039" y="2157984"/>
+            <a:ext cx="2103120" cy="320040"/>
           </a:xfrm>
           <a:prstGeom prst="rect">
             <a:avLst/>
@@ -6103,27 +6142,27 @@
               </a:lnSpc>
             </a:pPr>
             <a:r>
-              <a:rPr sz="1600" b="1">
+              <a:rPr sz="1500" b="1">
                 <a:solidFill>
                   <a:srgbClr val="373739"/>
                 </a:solidFill>
                 <a:latin typeface="Aptos"/>
               </a:rPr>
-              <a:t>Trabajo del agente</a:t>
-            </a:r>
-          </a:p>
-        </p:txBody>
-      </p:sp>
-      <p:sp>
-        <p:nvSpPr>
-          <p:cNvPr id="16" name="TextBox 15"/>
+              <a:t>Evidencias</a:t>
+            </a:r>
+          </a:p>
+        </p:txBody>
+      </p:sp>
+      <p:sp>
+        <p:nvSpPr>
+          <p:cNvPr id="17" name="TextBox 16"/>
           <p:cNvSpPr txBox="1"/>
           <p:nvPr/>
         </p:nvSpPr>
         <p:spPr>
           <a:xfrm>
-            <a:off x="4663440" y="2487168"/>
-            <a:ext cx="2880360" cy="1444752"/>
+            <a:off x="3749039" y="2606040"/>
+            <a:ext cx="2103120" cy="420624"/>
           </a:xfrm>
           <a:prstGeom prst="rect">
             <a:avLst/>
@@ -6142,27 +6181,27 @@
               </a:lnSpc>
             </a:pPr>
             <a:r>
-              <a:rPr sz="1300" b="0">
+              <a:rPr sz="1120" b="0">
                 <a:solidFill>
                   <a:srgbClr val="69696C"/>
                 </a:solidFill>
                 <a:latin typeface="Aptos"/>
               </a:rPr>
-              <a:t>Ordena evidencias, identifica fortalezas, oportunidades de mejora y brechas de madurez.</a:t>
-            </a:r>
-          </a:p>
-        </p:txBody>
-      </p:sp>
-      <p:sp>
-        <p:nvSpPr>
-          <p:cNvPr id="17" name="Rounded Rectangle 16"/>
+              <a:t>Estrategia, Sustentabilidad, Finanzas, Personas, Riesgos, Comunicaciones e Innovación.</a:t>
+            </a:r>
+          </a:p>
+        </p:txBody>
+      </p:sp>
+      <p:sp>
+        <p:nvSpPr>
+          <p:cNvPr id="18" name="Rounded Rectangle 17"/>
           <p:cNvSpPr/>
           <p:nvPr/>
         </p:nvSpPr>
         <p:spPr>
           <a:xfrm>
-            <a:off x="8092440" y="1874519"/>
-            <a:ext cx="3291840" cy="2194560"/>
+            <a:off x="6263640" y="1993392"/>
+            <a:ext cx="2514600" cy="1170432"/>
           </a:xfrm>
           <a:prstGeom prst="roundRect">
             <a:avLst/>
@@ -6200,20 +6239,20 @@
       </p:sp>
       <p:sp>
         <p:nvSpPr>
-          <p:cNvPr id="18" name="Rectangle 17"/>
+          <p:cNvPr id="19" name="Rectangle 18"/>
           <p:cNvSpPr/>
           <p:nvPr/>
         </p:nvSpPr>
         <p:spPr>
           <a:xfrm>
-            <a:off x="8092440" y="1874519"/>
-            <a:ext cx="73152" cy="2194560"/>
-          </a:xfrm>
-          <a:prstGeom prst="rect">
-            <a:avLst/>
-          </a:prstGeom>
-          <a:solidFill>
-            <a:srgbClr val="00ADB5"/>
+            <a:off x="6263640" y="1993392"/>
+            <a:ext cx="73152" cy="1170432"/>
+          </a:xfrm>
+          <a:prstGeom prst="rect">
+            <a:avLst/>
+          </a:prstGeom>
+          <a:solidFill>
+            <a:srgbClr val="D32F7A"/>
           </a:solidFill>
           <a:ln>
             <a:noFill/>
@@ -6243,14 +6282,14 @@
       </p:sp>
       <p:sp>
         <p:nvSpPr>
-          <p:cNvPr id="19" name="TextBox 18"/>
+          <p:cNvPr id="20" name="TextBox 19"/>
           <p:cNvSpPr txBox="1"/>
           <p:nvPr/>
         </p:nvSpPr>
         <p:spPr>
           <a:xfrm>
-            <a:off x="8321040" y="2039112"/>
-            <a:ext cx="2880360" cy="320040"/>
+            <a:off x="6492240" y="2157984"/>
+            <a:ext cx="2103120" cy="320040"/>
           </a:xfrm>
           <a:prstGeom prst="rect">
             <a:avLst/>
@@ -6269,27 +6308,27 @@
               </a:lnSpc>
             </a:pPr>
             <a:r>
-              <a:rPr sz="1600" b="1">
+              <a:rPr sz="1500" b="1">
                 <a:solidFill>
                   <a:srgbClr val="373739"/>
                 </a:solidFill>
                 <a:latin typeface="Aptos"/>
               </a:rPr>
-              <a:t>Salida útil</a:t>
-            </a:r>
-          </a:p>
-        </p:txBody>
-      </p:sp>
-      <p:sp>
-        <p:nvSpPr>
-          <p:cNvPr id="20" name="TextBox 19"/>
+              <a:t>Lectura PNC</a:t>
+            </a:r>
+          </a:p>
+        </p:txBody>
+      </p:sp>
+      <p:sp>
+        <p:nvSpPr>
+          <p:cNvPr id="21" name="TextBox 20"/>
           <p:cNvSpPr txBox="1"/>
           <p:nvPr/>
         </p:nvSpPr>
         <p:spPr>
           <a:xfrm>
-            <a:off x="8321040" y="2487168"/>
-            <a:ext cx="2880360" cy="1444752"/>
+            <a:off x="6492240" y="2606040"/>
+            <a:ext cx="2103120" cy="420624"/>
           </a:xfrm>
           <a:prstGeom prst="rect">
             <a:avLst/>
@@ -6308,36 +6347,38 @@
               </a:lnSpc>
             </a:pPr>
             <a:r>
-              <a:rPr sz="1300" b="0">
+              <a:rPr sz="1160" b="0">
                 <a:solidFill>
                   <a:srgbClr val="69696C"/>
                 </a:solidFill>
                 <a:latin typeface="Aptos"/>
               </a:rPr>
-              <a:t>Diagnóstico trazable para revisión experta, priorización y planes de mejora.</a:t>
-            </a:r>
-          </a:p>
-        </p:txBody>
-      </p:sp>
-      <p:sp>
-        <p:nvSpPr>
-          <p:cNvPr id="21" name="Rounded Rectangle 20"/>
+              <a:t>El agente ordena evidencias por aspecto, criterio, factor y fuente.</a:t>
+            </a:r>
+          </a:p>
+        </p:txBody>
+      </p:sp>
+      <p:sp>
+        <p:nvSpPr>
+          <p:cNvPr id="22" name="Rounded Rectangle 21"/>
           <p:cNvSpPr/>
           <p:nvPr/>
         </p:nvSpPr>
         <p:spPr>
           <a:xfrm>
-            <a:off x="1005840" y="4800600"/>
-            <a:ext cx="10104120" cy="777240"/>
+            <a:off x="9006840" y="1993392"/>
+            <a:ext cx="2514600" cy="1170432"/>
           </a:xfrm>
           <a:prstGeom prst="roundRect">
             <a:avLst/>
           </a:prstGeom>
           <a:solidFill>
-            <a:srgbClr val="F4F6F8"/>
-          </a:solidFill>
-          <a:ln>
-            <a:noFill/>
+            <a:srgbClr val="FFFFFF"/>
+          </a:solidFill>
+          <a:ln w="12700">
+            <a:solidFill>
+              <a:srgbClr val="E1E4E8"/>
+            </a:solidFill>
           </a:ln>
         </p:spPr>
         <p:style>
@@ -6364,14 +6405,662 @@
       </p:sp>
       <p:sp>
         <p:nvSpPr>
-          <p:cNvPr id="22" name="TextBox 21"/>
+          <p:cNvPr id="23" name="Rectangle 22"/>
+          <p:cNvSpPr/>
+          <p:nvPr/>
+        </p:nvSpPr>
+        <p:spPr>
+          <a:xfrm>
+            <a:off x="9006840" y="1993392"/>
+            <a:ext cx="73152" cy="1170432"/>
+          </a:xfrm>
+          <a:prstGeom prst="rect">
+            <a:avLst/>
+          </a:prstGeom>
+          <a:solidFill>
+            <a:srgbClr val="F6BB26"/>
+          </a:solidFill>
+          <a:ln>
+            <a:noFill/>
+          </a:ln>
+        </p:spPr>
+        <p:style>
+          <a:lnRef idx="1">
+            <a:schemeClr val="accent1"/>
+          </a:lnRef>
+          <a:fillRef idx="3">
+            <a:schemeClr val="accent1"/>
+          </a:fillRef>
+          <a:effectRef idx="2">
+            <a:schemeClr val="accent1"/>
+          </a:effectRef>
+          <a:fontRef idx="minor">
+            <a:schemeClr val="lt1"/>
+          </a:fontRef>
+        </p:style>
+        <p:txBody>
+          <a:bodyPr rtlCol="0" anchor="ctr"/>
+          <a:lstStyle/>
+          <a:p>
+            <a:pPr algn="ctr"/>
+          </a:p>
+        </p:txBody>
+      </p:sp>
+      <p:sp>
+        <p:nvSpPr>
+          <p:cNvPr id="24" name="TextBox 23"/>
           <p:cNvSpPr txBox="1"/>
           <p:nvPr/>
         </p:nvSpPr>
         <p:spPr>
           <a:xfrm>
-            <a:off x="1261872" y="5001768"/>
-            <a:ext cx="9592056" cy="393192"/>
+            <a:off x="9235440" y="2157984"/>
+            <a:ext cx="2103120" cy="320040"/>
+          </a:xfrm>
+          <a:prstGeom prst="rect">
+            <a:avLst/>
+          </a:prstGeom>
+          <a:noFill/>
+        </p:spPr>
+        <p:txBody>
+          <a:bodyPr wrap="square">
+            <a:normAutofit/>
+          </a:bodyPr>
+          <a:lstStyle/>
+          <a:p>
+            <a:pPr algn="l">
+              <a:lnSpc>
+                <a:spcPct val="100000"/>
+              </a:lnSpc>
+            </a:pPr>
+            <a:r>
+              <a:rPr sz="1500" b="1">
+                <a:solidFill>
+                  <a:srgbClr val="373739"/>
+                </a:solidFill>
+                <a:latin typeface="Aptos"/>
+              </a:rPr>
+              <a:t>Salida útil</a:t>
+            </a:r>
+          </a:p>
+        </p:txBody>
+      </p:sp>
+      <p:sp>
+        <p:nvSpPr>
+          <p:cNvPr id="25" name="TextBox 24"/>
+          <p:cNvSpPr txBox="1"/>
+          <p:nvPr/>
+        </p:nvSpPr>
+        <p:spPr>
+          <a:xfrm>
+            <a:off x="9235440" y="2606040"/>
+            <a:ext cx="2103120" cy="420624"/>
+          </a:xfrm>
+          <a:prstGeom prst="rect">
+            <a:avLst/>
+          </a:prstGeom>
+          <a:noFill/>
+        </p:spPr>
+        <p:txBody>
+          <a:bodyPr wrap="square">
+            <a:normAutofit/>
+          </a:bodyPr>
+          <a:lstStyle/>
+          <a:p>
+            <a:pPr algn="l">
+              <a:lnSpc>
+                <a:spcPct val="100000"/>
+              </a:lnSpc>
+            </a:pPr>
+            <a:r>
+              <a:rPr sz="1160" b="0">
+                <a:solidFill>
+                  <a:srgbClr val="69696C"/>
+                </a:solidFill>
+                <a:latin typeface="Aptos"/>
+              </a:rPr>
+              <a:t>Diagnóstico trazable para revisión experta y priorización de mejoras.</a:t>
+            </a:r>
+          </a:p>
+        </p:txBody>
+      </p:sp>
+      <p:sp>
+        <p:nvSpPr>
+          <p:cNvPr id="26" name="Rounded Rectangle 25"/>
+          <p:cNvSpPr/>
+          <p:nvPr/>
+        </p:nvSpPr>
+        <p:spPr>
+          <a:xfrm>
+            <a:off x="868680" y="3493008"/>
+            <a:ext cx="1828800" cy="310896"/>
+          </a:xfrm>
+          <a:prstGeom prst="roundRect">
+            <a:avLst/>
+          </a:prstGeom>
+          <a:solidFill>
+            <a:srgbClr val="F6BB26"/>
+          </a:solidFill>
+          <a:ln>
+            <a:noFill/>
+          </a:ln>
+        </p:spPr>
+        <p:style>
+          <a:lnRef idx="1">
+            <a:schemeClr val="accent1"/>
+          </a:lnRef>
+          <a:fillRef idx="3">
+            <a:schemeClr val="accent1"/>
+          </a:fillRef>
+          <a:effectRef idx="2">
+            <a:schemeClr val="accent1"/>
+          </a:effectRef>
+          <a:fontRef idx="minor">
+            <a:schemeClr val="lt1"/>
+          </a:fontRef>
+        </p:style>
+        <p:txBody>
+          <a:bodyPr rtlCol="0" anchor="ctr"/>
+          <a:lstStyle/>
+          <a:p>
+            <a:pPr algn="ctr"/>
+          </a:p>
+        </p:txBody>
+      </p:sp>
+      <p:sp>
+        <p:nvSpPr>
+          <p:cNvPr id="27" name="TextBox 26"/>
+          <p:cNvSpPr txBox="1"/>
+          <p:nvPr/>
+        </p:nvSpPr>
+        <p:spPr>
+          <a:xfrm>
+            <a:off x="941832" y="3566160"/>
+            <a:ext cx="1682496" cy="118872"/>
+          </a:xfrm>
+          <a:prstGeom prst="rect">
+            <a:avLst/>
+          </a:prstGeom>
+          <a:noFill/>
+        </p:spPr>
+        <p:txBody>
+          <a:bodyPr wrap="square">
+            <a:normAutofit/>
+          </a:bodyPr>
+          <a:lstStyle/>
+          <a:p>
+            <a:pPr algn="ctr">
+              <a:lnSpc>
+                <a:spcPct val="100000"/>
+              </a:lnSpc>
+            </a:pPr>
+            <a:r>
+              <a:rPr sz="869" b="1">
+                <a:solidFill>
+                  <a:srgbClr val="FFFFFF"/>
+                </a:solidFill>
+                <a:latin typeface="Aptos"/>
+              </a:rPr>
+              <a:t>Horizonte y objetivos</a:t>
+            </a:r>
+          </a:p>
+        </p:txBody>
+      </p:sp>
+      <p:sp>
+        <p:nvSpPr>
+          <p:cNvPr id="28" name="TextBox 27"/>
+          <p:cNvSpPr txBox="1"/>
+          <p:nvPr/>
+        </p:nvSpPr>
+        <p:spPr>
+          <a:xfrm>
+            <a:off x="2880360" y="3538727"/>
+            <a:ext cx="7909560" cy="201168"/>
+          </a:xfrm>
+          <a:prstGeom prst="rect">
+            <a:avLst/>
+          </a:prstGeom>
+          <a:noFill/>
+        </p:spPr>
+        <p:txBody>
+          <a:bodyPr wrap="square">
+            <a:normAutofit/>
+          </a:bodyPr>
+          <a:lstStyle/>
+          <a:p>
+            <a:pPr algn="l">
+              <a:lnSpc>
+                <a:spcPct val="100000"/>
+              </a:lnSpc>
+            </a:pPr>
+            <a:r>
+              <a:rPr sz="1060" b="0">
+                <a:solidFill>
+                  <a:srgbClr val="373739"/>
+                </a:solidFill>
+                <a:latin typeface="Aptos"/>
+              </a:rPr>
+              <a:t>largo/corto plazo, objetivos estratégicos, planes operativos</a:t>
+            </a:r>
+          </a:p>
+        </p:txBody>
+      </p:sp>
+      <p:sp>
+        <p:nvSpPr>
+          <p:cNvPr id="29" name="Rounded Rectangle 28"/>
+          <p:cNvSpPr/>
+          <p:nvPr/>
+        </p:nvSpPr>
+        <p:spPr>
+          <a:xfrm>
+            <a:off x="868680" y="3931920"/>
+            <a:ext cx="1828800" cy="310896"/>
+          </a:xfrm>
+          <a:prstGeom prst="roundRect">
+            <a:avLst/>
+          </a:prstGeom>
+          <a:solidFill>
+            <a:srgbClr val="EF6F28"/>
+          </a:solidFill>
+          <a:ln>
+            <a:noFill/>
+          </a:ln>
+        </p:spPr>
+        <p:style>
+          <a:lnRef idx="1">
+            <a:schemeClr val="accent1"/>
+          </a:lnRef>
+          <a:fillRef idx="3">
+            <a:schemeClr val="accent1"/>
+          </a:fillRef>
+          <a:effectRef idx="2">
+            <a:schemeClr val="accent1"/>
+          </a:effectRef>
+          <a:fontRef idx="minor">
+            <a:schemeClr val="lt1"/>
+          </a:fontRef>
+        </p:style>
+        <p:txBody>
+          <a:bodyPr rtlCol="0" anchor="ctr"/>
+          <a:lstStyle/>
+          <a:p>
+            <a:pPr algn="ctr"/>
+          </a:p>
+        </p:txBody>
+      </p:sp>
+      <p:sp>
+        <p:nvSpPr>
+          <p:cNvPr id="30" name="TextBox 29"/>
+          <p:cNvSpPr txBox="1"/>
+          <p:nvPr/>
+        </p:nvSpPr>
+        <p:spPr>
+          <a:xfrm>
+            <a:off x="941832" y="4005072"/>
+            <a:ext cx="1682496" cy="118872"/>
+          </a:xfrm>
+          <a:prstGeom prst="rect">
+            <a:avLst/>
+          </a:prstGeom>
+          <a:noFill/>
+        </p:spPr>
+        <p:txBody>
+          <a:bodyPr wrap="square">
+            <a:normAutofit/>
+          </a:bodyPr>
+          <a:lstStyle/>
+          <a:p>
+            <a:pPr algn="ctr">
+              <a:lnSpc>
+                <a:spcPct val="100000"/>
+              </a:lnSpc>
+            </a:pPr>
+            <a:r>
+              <a:rPr sz="869" b="1">
+                <a:solidFill>
+                  <a:srgbClr val="FFFFFF"/>
+                </a:solidFill>
+                <a:latin typeface="Aptos"/>
+              </a:rPr>
+              <a:t>Despliegue</a:t>
+            </a:r>
+          </a:p>
+        </p:txBody>
+      </p:sp>
+      <p:sp>
+        <p:nvSpPr>
+          <p:cNvPr id="31" name="TextBox 30"/>
+          <p:cNvSpPr txBox="1"/>
+          <p:nvPr/>
+        </p:nvSpPr>
+        <p:spPr>
+          <a:xfrm>
+            <a:off x="2880360" y="3977639"/>
+            <a:ext cx="7909560" cy="201168"/>
+          </a:xfrm>
+          <a:prstGeom prst="rect">
+            <a:avLst/>
+          </a:prstGeom>
+          <a:noFill/>
+        </p:spPr>
+        <p:txBody>
+          <a:bodyPr wrap="square">
+            <a:normAutofit/>
+          </a:bodyPr>
+          <a:lstStyle/>
+          <a:p>
+            <a:pPr algn="l">
+              <a:lnSpc>
+                <a:spcPct val="100000"/>
+              </a:lnSpc>
+            </a:pPr>
+            <a:r>
+              <a:rPr sz="1060" b="0">
+                <a:solidFill>
+                  <a:srgbClr val="373739"/>
+                </a:solidFill>
+                <a:latin typeface="Aptos"/>
+              </a:rPr>
+              <a:t>innovación, recursos, KPIs y alineamiento presupuestario</a:t>
+            </a:r>
+          </a:p>
+        </p:txBody>
+      </p:sp>
+      <p:sp>
+        <p:nvSpPr>
+          <p:cNvPr id="32" name="Rounded Rectangle 31"/>
+          <p:cNvSpPr/>
+          <p:nvPr/>
+        </p:nvSpPr>
+        <p:spPr>
+          <a:xfrm>
+            <a:off x="868680" y="4370831"/>
+            <a:ext cx="1828800" cy="310896"/>
+          </a:xfrm>
+          <a:prstGeom prst="roundRect">
+            <a:avLst/>
+          </a:prstGeom>
+          <a:solidFill>
+            <a:srgbClr val="D32F7A"/>
+          </a:solidFill>
+          <a:ln>
+            <a:noFill/>
+          </a:ln>
+        </p:spPr>
+        <p:style>
+          <a:lnRef idx="1">
+            <a:schemeClr val="accent1"/>
+          </a:lnRef>
+          <a:fillRef idx="3">
+            <a:schemeClr val="accent1"/>
+          </a:fillRef>
+          <a:effectRef idx="2">
+            <a:schemeClr val="accent1"/>
+          </a:effectRef>
+          <a:fontRef idx="minor">
+            <a:schemeClr val="lt1"/>
+          </a:fontRef>
+        </p:style>
+        <p:txBody>
+          <a:bodyPr rtlCol="0" anchor="ctr"/>
+          <a:lstStyle/>
+          <a:p>
+            <a:pPr algn="ctr"/>
+          </a:p>
+        </p:txBody>
+      </p:sp>
+      <p:sp>
+        <p:nvSpPr>
+          <p:cNvPr id="33" name="TextBox 32"/>
+          <p:cNvSpPr txBox="1"/>
+          <p:nvPr/>
+        </p:nvSpPr>
+        <p:spPr>
+          <a:xfrm>
+            <a:off x="941832" y="4443983"/>
+            <a:ext cx="1682496" cy="118872"/>
+          </a:xfrm>
+          <a:prstGeom prst="rect">
+            <a:avLst/>
+          </a:prstGeom>
+          <a:noFill/>
+        </p:spPr>
+        <p:txBody>
+          <a:bodyPr wrap="square">
+            <a:normAutofit/>
+          </a:bodyPr>
+          <a:lstStyle/>
+          <a:p>
+            <a:pPr algn="ctr">
+              <a:lnSpc>
+                <a:spcPct val="100000"/>
+              </a:lnSpc>
+            </a:pPr>
+            <a:r>
+              <a:rPr sz="869" b="1">
+                <a:solidFill>
+                  <a:srgbClr val="FFFFFF"/>
+                </a:solidFill>
+                <a:latin typeface="Aptos"/>
+              </a:rPr>
+              <a:t>Gobierno</a:t>
+            </a:r>
+          </a:p>
+        </p:txBody>
+      </p:sp>
+      <p:sp>
+        <p:nvSpPr>
+          <p:cNvPr id="34" name="TextBox 33"/>
+          <p:cNvSpPr txBox="1"/>
+          <p:nvPr/>
+        </p:nvSpPr>
+        <p:spPr>
+          <a:xfrm>
+            <a:off x="2880360" y="4416551"/>
+            <a:ext cx="7909560" cy="201168"/>
+          </a:xfrm>
+          <a:prstGeom prst="rect">
+            <a:avLst/>
+          </a:prstGeom>
+          <a:noFill/>
+        </p:spPr>
+        <p:txBody>
+          <a:bodyPr wrap="square">
+            <a:normAutofit/>
+          </a:bodyPr>
+          <a:lstStyle/>
+          <a:p>
+            <a:pPr algn="l">
+              <a:lnSpc>
+                <a:spcPct val="100000"/>
+              </a:lnSpc>
+            </a:pPr>
+            <a:r>
+              <a:rPr sz="1060" b="0">
+                <a:solidFill>
+                  <a:srgbClr val="373739"/>
+                </a:solidFill>
+                <a:latin typeface="Aptos"/>
+              </a:rPr>
+              <a:t>riesgos integrados a planes, comunicación interna/externa</a:t>
+            </a:r>
+          </a:p>
+        </p:txBody>
+      </p:sp>
+      <p:sp>
+        <p:nvSpPr>
+          <p:cNvPr id="35" name="Rounded Rectangle 34"/>
+          <p:cNvSpPr/>
+          <p:nvPr/>
+        </p:nvSpPr>
+        <p:spPr>
+          <a:xfrm>
+            <a:off x="868680" y="4809744"/>
+            <a:ext cx="1828800" cy="310896"/>
+          </a:xfrm>
+          <a:prstGeom prst="roundRect">
+            <a:avLst/>
+          </a:prstGeom>
+          <a:solidFill>
+            <a:srgbClr val="00ADB5"/>
+          </a:solidFill>
+          <a:ln>
+            <a:noFill/>
+          </a:ln>
+        </p:spPr>
+        <p:style>
+          <a:lnRef idx="1">
+            <a:schemeClr val="accent1"/>
+          </a:lnRef>
+          <a:fillRef idx="3">
+            <a:schemeClr val="accent1"/>
+          </a:fillRef>
+          <a:effectRef idx="2">
+            <a:schemeClr val="accent1"/>
+          </a:effectRef>
+          <a:fontRef idx="minor">
+            <a:schemeClr val="lt1"/>
+          </a:fontRef>
+        </p:style>
+        <p:txBody>
+          <a:bodyPr rtlCol="0" anchor="ctr"/>
+          <a:lstStyle/>
+          <a:p>
+            <a:pPr algn="ctr"/>
+          </a:p>
+        </p:txBody>
+      </p:sp>
+      <p:sp>
+        <p:nvSpPr>
+          <p:cNvPr id="36" name="TextBox 35"/>
+          <p:cNvSpPr txBox="1"/>
+          <p:nvPr/>
+        </p:nvSpPr>
+        <p:spPr>
+          <a:xfrm>
+            <a:off x="941832" y="4882896"/>
+            <a:ext cx="1682496" cy="118872"/>
+          </a:xfrm>
+          <a:prstGeom prst="rect">
+            <a:avLst/>
+          </a:prstGeom>
+          <a:noFill/>
+        </p:spPr>
+        <p:txBody>
+          <a:bodyPr wrap="square">
+            <a:normAutofit/>
+          </a:bodyPr>
+          <a:lstStyle/>
+          <a:p>
+            <a:pPr algn="ctr">
+              <a:lnSpc>
+                <a:spcPct val="100000"/>
+              </a:lnSpc>
+            </a:pPr>
+            <a:r>
+              <a:rPr sz="869" b="1">
+                <a:solidFill>
+                  <a:srgbClr val="FFFFFF"/>
+                </a:solidFill>
+                <a:latin typeface="Aptos"/>
+              </a:rPr>
+              <a:t>Revisión</a:t>
+            </a:r>
+          </a:p>
+        </p:txBody>
+      </p:sp>
+      <p:sp>
+        <p:nvSpPr>
+          <p:cNvPr id="37" name="TextBox 36"/>
+          <p:cNvSpPr txBox="1"/>
+          <p:nvPr/>
+        </p:nvSpPr>
+        <p:spPr>
+          <a:xfrm>
+            <a:off x="2880360" y="4855464"/>
+            <a:ext cx="7909560" cy="201168"/>
+          </a:xfrm>
+          <a:prstGeom prst="rect">
+            <a:avLst/>
+          </a:prstGeom>
+          <a:noFill/>
+        </p:spPr>
+        <p:txBody>
+          <a:bodyPr wrap="square">
+            <a:normAutofit/>
+          </a:bodyPr>
+          <a:lstStyle/>
+          <a:p>
+            <a:pPr algn="l">
+              <a:lnSpc>
+                <a:spcPct val="100000"/>
+              </a:lnSpc>
+            </a:pPr>
+            <a:r>
+              <a:rPr sz="1060" b="0">
+                <a:solidFill>
+                  <a:srgbClr val="373739"/>
+                </a:solidFill>
+                <a:latin typeface="Aptos"/>
+              </a:rPr>
+              <a:t>seguimiento de planes, desvíos, reforecast y mejora continua</a:t>
+            </a:r>
+          </a:p>
+        </p:txBody>
+      </p:sp>
+      <p:sp>
+        <p:nvSpPr>
+          <p:cNvPr id="38" name="Rounded Rectangle 37"/>
+          <p:cNvSpPr/>
+          <p:nvPr/>
+        </p:nvSpPr>
+        <p:spPr>
+          <a:xfrm>
+            <a:off x="868680" y="5440680"/>
+            <a:ext cx="10469880" cy="566928"/>
+          </a:xfrm>
+          <a:prstGeom prst="roundRect">
+            <a:avLst/>
+          </a:prstGeom>
+          <a:solidFill>
+            <a:srgbClr val="F4F6F8"/>
+          </a:solidFill>
+          <a:ln>
+            <a:noFill/>
+          </a:ln>
+        </p:spPr>
+        <p:style>
+          <a:lnRef idx="1">
+            <a:schemeClr val="accent1"/>
+          </a:lnRef>
+          <a:fillRef idx="3">
+            <a:schemeClr val="accent1"/>
+          </a:fillRef>
+          <a:effectRef idx="2">
+            <a:schemeClr val="accent1"/>
+          </a:effectRef>
+          <a:fontRef idx="minor">
+            <a:schemeClr val="lt1"/>
+          </a:fontRef>
+        </p:style>
+        <p:txBody>
+          <a:bodyPr rtlCol="0" anchor="ctr"/>
+          <a:lstStyle/>
+          <a:p>
+            <a:pPr algn="ctr"/>
+          </a:p>
+        </p:txBody>
+      </p:sp>
+      <p:sp>
+        <p:nvSpPr>
+          <p:cNvPr id="39" name="TextBox 38"/>
+          <p:cNvSpPr txBox="1"/>
+          <p:nvPr/>
+        </p:nvSpPr>
+        <p:spPr>
+          <a:xfrm>
+            <a:off x="1124712" y="5641848"/>
+            <a:ext cx="9957815" cy="182880"/>
           </a:xfrm>
           <a:prstGeom prst="rect">
             <a:avLst/>
@@ -6396,21 +7085,21 @@
                 </a:solidFill>
                 <a:latin typeface="Aptos"/>
               </a:rPr>
-              <a:t>En PNC, la IA acelera el diagnóstico; la excelencia sigue requiriendo criterio directivo y experto.</a:t>
-            </a:r>
-          </a:p>
-        </p:txBody>
-      </p:sp>
-      <p:sp>
-        <p:nvSpPr>
-          <p:cNvPr id="23" name="Rectangle 22"/>
+              <a:t>Mensaje para la charla: en PNC el agente acelera el ordenamiento de evidencias; el juicio de madurez queda en manos del experto.</a:t>
+            </a:r>
+          </a:p>
+        </p:txBody>
+      </p:sp>
+      <p:sp>
+        <p:nvSpPr>
+          <p:cNvPr id="40" name="Rectangle 39"/>
           <p:cNvSpPr/>
           <p:nvPr/>
         </p:nvSpPr>
         <p:spPr>
           <a:xfrm>
-            <a:off x="1005840" y="4800600"/>
-            <a:ext cx="73152" cy="777240"/>
+            <a:off x="868680" y="5440680"/>
+            <a:ext cx="73152" cy="566928"/>
           </a:xfrm>
           <a:prstGeom prst="rect">
             <a:avLst/>
@@ -6446,7 +7135,7 @@
       </p:sp>
       <p:sp>
         <p:nvSpPr>
-          <p:cNvPr id="24" name="TextBox 23"/>
+          <p:cNvPr id="41" name="TextBox 40"/>
           <p:cNvSpPr txBox="1"/>
           <p:nvPr/>
         </p:nvSpPr>
@@ -6485,7 +7174,7 @@
       </p:sp>
       <p:sp>
         <p:nvSpPr>
-          <p:cNvPr id="25" name="TextBox 24"/>
+          <p:cNvPr id="42" name="TextBox 41"/>
           <p:cNvSpPr txBox="1"/>
           <p:nvPr/>
         </p:nvSpPr>
@@ -6524,7 +7213,7 @@
       </p:sp>
       <p:sp>
         <p:nvSpPr>
-          <p:cNvPr id="26" name="Rectangle 25"/>
+          <p:cNvPr id="43" name="Rectangle 42"/>
           <p:cNvSpPr/>
           <p:nvPr/>
         </p:nvSpPr>

</xml_diff>

<commit_message>
Mejorar subejemplo PNC con cobertura
</commit_message>
<xml_diff>
--- a/presentacion/charla-excelencia-ia-organizacional.pptx
+++ b/presentacion/charla-excelencia-ia-organizacional.pptx
@@ -5620,7 +5620,7 @@
                 </a:solidFill>
                 <a:latin typeface="Aptos"/>
               </a:rPr>
-              <a:t>Subejemplo PNC · Planeamiento estratégico VMOS</a:t>
+              <a:t>Subejemplo PNC · Matriz de gaps VMOS</a:t>
             </a:r>
           </a:p>
         </p:txBody>
@@ -5830,7 +5830,7 @@
         <p:spPr>
           <a:xfrm>
             <a:off x="786384" y="1627632"/>
-            <a:ext cx="9784080" cy="256032"/>
+            <a:ext cx="9966960" cy="256032"/>
           </a:xfrm>
           <a:prstGeom prst="rect">
             <a:avLst/>
@@ -5855,7 +5855,7 @@
                 </a:solidFill>
                 <a:latin typeface="Aptos"/>
               </a:rPr>
-              <a:t>Muestra real tomada de matriz-gaps-pnc-vmos.xlsx · filas Excel 14 a 22 · ids 13 a 21 · Criterio 1. Liderazgo / Factor 1.3</a:t>
+              <a:t>Muestra real tomada de matriz-gaps-pnc-vmos.xlsx · filas Excel 14 a 22 · ids 13 a 21 · Liderazgo / Factor 1.3</a:t>
             </a:r>
           </a:p>
         </p:txBody>
@@ -6148,7 +6148,7 @@
                 </a:solidFill>
                 <a:latin typeface="Aptos"/>
               </a:rPr>
-              <a:t>Evidencias</a:t>
+              <a:t>Resultado</a:t>
             </a:r>
           </a:p>
         </p:txBody>
@@ -6187,7 +6187,7 @@
                 </a:solidFill>
                 <a:latin typeface="Aptos"/>
               </a:rPr>
-              <a:t>Estrategia, Sustentabilidad, Finanzas, Personas, Riesgos, Comunicaciones e Innovación.</a:t>
+              <a:t>9 cubiertos, 0 parciales, 0 no cubiertos según evidencia documental cargada.</a:t>
             </a:r>
           </a:p>
         </p:txBody>
@@ -6314,7 +6314,7 @@
                 </a:solidFill>
                 <a:latin typeface="Aptos"/>
               </a:rPr>
-              <a:t>Lectura PNC</a:t>
+              <a:t>Evidencias</a:t>
             </a:r>
           </a:p>
         </p:txBody>
@@ -6347,13 +6347,13 @@
               </a:lnSpc>
             </a:pPr>
             <a:r>
-              <a:rPr sz="1160" b="0">
+              <a:rPr sz="1100" b="0">
                 <a:solidFill>
                   <a:srgbClr val="69696C"/>
                 </a:solidFill>
                 <a:latin typeface="Aptos"/>
               </a:rPr>
-              <a:t>El agente ordena evidencias por aspecto, criterio, factor y fuente.</a:t>
+              <a:t>Estrategia, Sustentabilidad, Finanzas, Personas, Riesgos, Comunicaciones e Innovación.</a:t>
             </a:r>
           </a:p>
         </p:txBody>
@@ -6519,7 +6519,7 @@
                 </a:solidFill>
                 <a:latin typeface="Aptos"/>
               </a:rPr>
-              <a:t>Diagnóstico trazable para revisión experta y priorización de mejoras.</a:t>
+              <a:t>Cobertura por aspecto + fuente documental para revisión experta.</a:t>
             </a:r>
           </a:p>
         </p:txBody>
@@ -6533,13 +6533,13 @@
         <p:spPr>
           <a:xfrm>
             <a:off x="868680" y="3493008"/>
-            <a:ext cx="1828800" cy="310896"/>
+            <a:ext cx="1325880" cy="310896"/>
           </a:xfrm>
           <a:prstGeom prst="roundRect">
             <a:avLst/>
           </a:prstGeom>
           <a:solidFill>
-            <a:srgbClr val="F6BB26"/>
+            <a:srgbClr val="00ADB5"/>
           </a:solidFill>
           <a:ln>
             <a:noFill/>
@@ -6575,8 +6575,8 @@
         </p:nvSpPr>
         <p:spPr>
           <a:xfrm>
-            <a:off x="941832" y="3566160"/>
-            <a:ext cx="1682496" cy="118872"/>
+            <a:off x="932688" y="3566160"/>
+            <a:ext cx="1188720" cy="118872"/>
           </a:xfrm>
           <a:prstGeom prst="rect">
             <a:avLst/>
@@ -6595,13 +6595,13 @@
               </a:lnSpc>
             </a:pPr>
             <a:r>
-              <a:rPr sz="869" b="1">
+              <a:rPr sz="880" b="1">
                 <a:solidFill>
                   <a:srgbClr val="FFFFFF"/>
                 </a:solidFill>
                 <a:latin typeface="Aptos"/>
               </a:rPr>
-              <a:t>Horizonte y objetivos</a:t>
+              <a:t>Cubierto</a:t>
             </a:r>
           </a:p>
         </p:txBody>
@@ -6614,8 +6614,8 @@
         </p:nvSpPr>
         <p:spPr>
           <a:xfrm>
-            <a:off x="2880360" y="3538727"/>
-            <a:ext cx="7909560" cy="201168"/>
+            <a:off x="2423160" y="3538727"/>
+            <a:ext cx="8366760" cy="201168"/>
           </a:xfrm>
           <a:prstGeom prst="rect">
             <a:avLst/>
@@ -6634,13 +6634,13 @@
               </a:lnSpc>
             </a:pPr>
             <a:r>
-              <a:rPr sz="1060" b="0">
+              <a:rPr sz="1080" b="0">
                 <a:solidFill>
                   <a:srgbClr val="373739"/>
                 </a:solidFill>
                 <a:latin typeface="Aptos"/>
               </a:rPr>
-              <a:t>largo/corto plazo, objetivos estratégicos, planes operativos</a:t>
+              <a:t>a-b: horizonte, información decisoria y objetivos estratégicos</a:t>
             </a:r>
           </a:p>
         </p:txBody>
@@ -6654,13 +6654,13 @@
         <p:spPr>
           <a:xfrm>
             <a:off x="868680" y="3931920"/>
-            <a:ext cx="1828800" cy="310896"/>
+            <a:ext cx="1325880" cy="310896"/>
           </a:xfrm>
           <a:prstGeom prst="roundRect">
             <a:avLst/>
           </a:prstGeom>
           <a:solidFill>
-            <a:srgbClr val="EF6F28"/>
+            <a:srgbClr val="00ADB5"/>
           </a:solidFill>
           <a:ln>
             <a:noFill/>
@@ -6696,8 +6696,8 @@
         </p:nvSpPr>
         <p:spPr>
           <a:xfrm>
-            <a:off x="941832" y="4005072"/>
-            <a:ext cx="1682496" cy="118872"/>
+            <a:off x="932688" y="4005072"/>
+            <a:ext cx="1188720" cy="118872"/>
           </a:xfrm>
           <a:prstGeom prst="rect">
             <a:avLst/>
@@ -6716,13 +6716,13 @@
               </a:lnSpc>
             </a:pPr>
             <a:r>
-              <a:rPr sz="869" b="1">
+              <a:rPr sz="880" b="1">
                 <a:solidFill>
                   <a:srgbClr val="FFFFFF"/>
                 </a:solidFill>
                 <a:latin typeface="Aptos"/>
               </a:rPr>
-              <a:t>Despliegue</a:t>
+              <a:t>Cubierto</a:t>
             </a:r>
           </a:p>
         </p:txBody>
@@ -6735,8 +6735,8 @@
         </p:nvSpPr>
         <p:spPr>
           <a:xfrm>
-            <a:off x="2880360" y="3977639"/>
-            <a:ext cx="7909560" cy="201168"/>
+            <a:off x="2423160" y="3977639"/>
+            <a:ext cx="8366760" cy="201168"/>
           </a:xfrm>
           <a:prstGeom prst="rect">
             <a:avLst/>
@@ -6755,13 +6755,13 @@
               </a:lnSpc>
             </a:pPr>
             <a:r>
-              <a:rPr sz="1060" b="0">
+              <a:rPr sz="1080" b="0">
                 <a:solidFill>
                   <a:srgbClr val="373739"/>
                 </a:solidFill>
                 <a:latin typeface="Aptos"/>
               </a:rPr>
-              <a:t>innovación, recursos, KPIs y alineamiento presupuestario</a:t>
+              <a:t>c-d: innovación y despliegue de objetivos en planes operativos</a:t>
             </a:r>
           </a:p>
         </p:txBody>
@@ -6775,13 +6775,13 @@
         <p:spPr>
           <a:xfrm>
             <a:off x="868680" y="4370831"/>
-            <a:ext cx="1828800" cy="310896"/>
+            <a:ext cx="1325880" cy="310896"/>
           </a:xfrm>
           <a:prstGeom prst="roundRect">
             <a:avLst/>
           </a:prstGeom>
           <a:solidFill>
-            <a:srgbClr val="D32F7A"/>
+            <a:srgbClr val="00ADB5"/>
           </a:solidFill>
           <a:ln>
             <a:noFill/>
@@ -6817,8 +6817,8 @@
         </p:nvSpPr>
         <p:spPr>
           <a:xfrm>
-            <a:off x="941832" y="4443983"/>
-            <a:ext cx="1682496" cy="118872"/>
+            <a:off x="932688" y="4443983"/>
+            <a:ext cx="1188720" cy="118872"/>
           </a:xfrm>
           <a:prstGeom prst="rect">
             <a:avLst/>
@@ -6837,13 +6837,13 @@
               </a:lnSpc>
             </a:pPr>
             <a:r>
-              <a:rPr sz="869" b="1">
+              <a:rPr sz="880" b="1">
                 <a:solidFill>
                   <a:srgbClr val="FFFFFF"/>
                 </a:solidFill>
                 <a:latin typeface="Aptos"/>
               </a:rPr>
-              <a:t>Gobierno</a:t>
+              <a:t>Cubierto</a:t>
             </a:r>
           </a:p>
         </p:txBody>
@@ -6856,8 +6856,8 @@
         </p:nvSpPr>
         <p:spPr>
           <a:xfrm>
-            <a:off x="2880360" y="4416551"/>
-            <a:ext cx="7909560" cy="201168"/>
+            <a:off x="2423160" y="4416551"/>
+            <a:ext cx="8366760" cy="201168"/>
           </a:xfrm>
           <a:prstGeom prst="rect">
             <a:avLst/>
@@ -6876,13 +6876,13 @@
               </a:lnSpc>
             </a:pPr>
             <a:r>
-              <a:rPr sz="1060" b="0">
+              <a:rPr sz="1080" b="0">
                 <a:solidFill>
                   <a:srgbClr val="373739"/>
                 </a:solidFill>
                 <a:latin typeface="Aptos"/>
               </a:rPr>
-              <a:t>riesgos integrados a planes, comunicación interna/externa</a:t>
+              <a:t>e-g: riesgos, recursos e indicadores clave de desempeño</a:t>
             </a:r>
           </a:p>
         </p:txBody>
@@ -6896,7 +6896,7 @@
         <p:spPr>
           <a:xfrm>
             <a:off x="868680" y="4809744"/>
-            <a:ext cx="1828800" cy="310896"/>
+            <a:ext cx="1325880" cy="310896"/>
           </a:xfrm>
           <a:prstGeom prst="roundRect">
             <a:avLst/>
@@ -6938,8 +6938,8 @@
         </p:nvSpPr>
         <p:spPr>
           <a:xfrm>
-            <a:off x="941832" y="4882896"/>
-            <a:ext cx="1682496" cy="118872"/>
+            <a:off x="932688" y="4882896"/>
+            <a:ext cx="1188720" cy="118872"/>
           </a:xfrm>
           <a:prstGeom prst="rect">
             <a:avLst/>
@@ -6958,13 +6958,13 @@
               </a:lnSpc>
             </a:pPr>
             <a:r>
-              <a:rPr sz="869" b="1">
+              <a:rPr sz="880" b="1">
                 <a:solidFill>
                   <a:srgbClr val="FFFFFF"/>
                 </a:solidFill>
                 <a:latin typeface="Aptos"/>
               </a:rPr>
-              <a:t>Revisión</a:t>
+              <a:t>Cubierto</a:t>
             </a:r>
           </a:p>
         </p:txBody>
@@ -6977,8 +6977,8 @@
         </p:nvSpPr>
         <p:spPr>
           <a:xfrm>
-            <a:off x="2880360" y="4855464"/>
-            <a:ext cx="7909560" cy="201168"/>
+            <a:off x="2423160" y="4855464"/>
+            <a:ext cx="8366760" cy="201168"/>
           </a:xfrm>
           <a:prstGeom prst="rect">
             <a:avLst/>
@@ -6997,13 +6997,13 @@
               </a:lnSpc>
             </a:pPr>
             <a:r>
-              <a:rPr sz="1060" b="0">
+              <a:rPr sz="1080" b="0">
                 <a:solidFill>
                   <a:srgbClr val="373739"/>
                 </a:solidFill>
                 <a:latin typeface="Aptos"/>
               </a:rPr>
-              <a:t>seguimiento de planes, desvíos, reforecast y mejora continua</a:t>
+              <a:t>h-i: comunicación de estrategias y revisión de planes/objetivos</a:t>
             </a:r>
           </a:p>
         </p:txBody>
@@ -7085,7 +7085,7 @@
                 </a:solidFill>
                 <a:latin typeface="Aptos"/>
               </a:rPr>
-              <a:t>Mensaje para la charla: en PNC el agente acelera el ordenamiento de evidencias; el juicio de madurez queda en manos del experto.</a:t>
+              <a:t>Mensaje para la charla: el agente ordena la cobertura PNC por aspecto; el experto conserva el juicio de madurez.</a:t>
             </a:r>
           </a:p>
         </p:txBody>

</xml_diff>

<commit_message>
Agregar slides de beneficios y cierre
</commit_message>
<xml_diff>
--- a/presentacion/charla-excelencia-ia-organizacional.pptx
+++ b/presentacion/charla-excelencia-ia-organizacional.pptx
@@ -17,6 +17,8 @@
     <p:sldId id="265" r:id="rId16"/>
     <p:sldId id="266" r:id="rId17"/>
     <p:sldId id="267" r:id="rId18"/>
+    <p:sldId id="268" r:id="rId19"/>
+    <p:sldId id="269" r:id="rId20"/>
   </p:sldIdLst>
   <p:sldSz cx="12191999" cy="6858000" type="screen4x3"/>
   <p:notesSz cx="6858000" cy="9144000"/>
@@ -8375,6 +8377,1840 @@
       <p:sp>
         <p:nvSpPr>
           <p:cNvPr id="29" name="Rectangle 28"/>
+          <p:cNvSpPr/>
+          <p:nvPr/>
+        </p:nvSpPr>
+        <p:spPr>
+          <a:xfrm>
+            <a:off x="658368" y="6345936"/>
+            <a:ext cx="10881360" cy="9144"/>
+          </a:xfrm>
+          <a:prstGeom prst="rect">
+            <a:avLst/>
+          </a:prstGeom>
+          <a:solidFill>
+            <a:srgbClr val="E1E4E8"/>
+          </a:solidFill>
+          <a:ln>
+            <a:noFill/>
+          </a:ln>
+        </p:spPr>
+        <p:style>
+          <a:lnRef idx="1">
+            <a:schemeClr val="accent1"/>
+          </a:lnRef>
+          <a:fillRef idx="3">
+            <a:schemeClr val="accent1"/>
+          </a:fillRef>
+          <a:effectRef idx="2">
+            <a:schemeClr val="accent1"/>
+          </a:effectRef>
+          <a:fontRef idx="minor">
+            <a:schemeClr val="lt1"/>
+          </a:fontRef>
+        </p:style>
+        <p:txBody>
+          <a:bodyPr rtlCol="0" anchor="ctr"/>
+          <a:lstStyle/>
+          <a:p>
+            <a:pPr algn="ctr"/>
+          </a:p>
+        </p:txBody>
+      </p:sp>
+    </p:spTree>
+  </p:cSld>
+  <p:clrMapOvr>
+    <a:masterClrMapping/>
+  </p:clrMapOvr>
+</p:sld>
+</file>
+
+<file path=ppt/slides/slide13.xml><?xml version="1.0" encoding="utf-8"?>
+<p:sld xmlns:a="http://schemas.openxmlformats.org/drawingml/2006/main" xmlns:p="http://schemas.openxmlformats.org/presentationml/2006/main" xmlns:r="http://schemas.openxmlformats.org/officeDocument/2006/relationships">
+  <p:cSld>
+    <p:bg>
+      <p:bgPr>
+        <a:solidFill>
+          <a:srgbClr val="FFFFFF"/>
+        </a:solidFill>
+        <a:effectLst/>
+      </p:bgPr>
+    </p:bg>
+    <p:spTree>
+      <p:nvGrpSpPr>
+        <p:cNvPr id="1" name=""/>
+        <p:cNvGrpSpPr/>
+        <p:nvPr/>
+      </p:nvGrpSpPr>
+      <p:grpSpPr/>
+      <p:sp>
+        <p:nvSpPr>
+          <p:cNvPr id="2" name="TextBox 1"/>
+          <p:cNvSpPr txBox="1"/>
+          <p:nvPr/>
+        </p:nvSpPr>
+        <p:spPr>
+          <a:xfrm>
+            <a:off x="658368" y="411480"/>
+            <a:ext cx="7772400" cy="292608"/>
+          </a:xfrm>
+          <a:prstGeom prst="rect">
+            <a:avLst/>
+          </a:prstGeom>
+          <a:noFill/>
+        </p:spPr>
+        <p:txBody>
+          <a:bodyPr wrap="square">
+            <a:normAutofit/>
+          </a:bodyPr>
+          <a:lstStyle/>
+          <a:p>
+            <a:pPr algn="l">
+              <a:lnSpc>
+                <a:spcPct val="100000"/>
+              </a:lnSpc>
+            </a:pPr>
+            <a:r>
+              <a:rPr sz="1050" b="1">
+                <a:solidFill>
+                  <a:srgbClr val="00ADB5"/>
+                </a:solidFill>
+                <a:latin typeface="Aptos"/>
+              </a:rPr>
+              <a:t>VALOR TANGIBLE E INTANGIBLE</a:t>
+            </a:r>
+          </a:p>
+        </p:txBody>
+      </p:sp>
+      <p:sp>
+        <p:nvSpPr>
+          <p:cNvPr id="3" name="TextBox 2"/>
+          <p:cNvSpPr txBox="1"/>
+          <p:nvPr/>
+        </p:nvSpPr>
+        <p:spPr>
+          <a:xfrm>
+            <a:off x="621792" y="685800"/>
+            <a:ext cx="8961120" cy="713232"/>
+          </a:xfrm>
+          <a:prstGeom prst="rect">
+            <a:avLst/>
+          </a:prstGeom>
+          <a:noFill/>
+        </p:spPr>
+        <p:txBody>
+          <a:bodyPr wrap="square">
+            <a:normAutofit/>
+          </a:bodyPr>
+          <a:lstStyle/>
+          <a:p>
+            <a:pPr algn="l">
+              <a:lnSpc>
+                <a:spcPct val="100000"/>
+              </a:lnSpc>
+            </a:pPr>
+            <a:r>
+              <a:rPr sz="2700" b="1">
+                <a:solidFill>
+                  <a:srgbClr val="373739"/>
+                </a:solidFill>
+                <a:latin typeface="Aptos"/>
+              </a:rPr>
+              <a:t>Beneficios esperables en ISO y PNC</a:t>
+            </a:r>
+          </a:p>
+        </p:txBody>
+      </p:sp>
+      <p:pic>
+        <p:nvPicPr>
+          <p:cNvPr id="4" name="Picture 3" descr="excelencia-logo.png"/>
+          <p:cNvPicPr>
+            <a:picLocks noChangeAspect="1"/>
+          </p:cNvPicPr>
+          <p:nvPr/>
+        </p:nvPicPr>
+        <p:blipFill>
+          <a:blip r:embed="rId2"/>
+          <a:stretch>
+            <a:fillRect/>
+          </a:stretch>
+        </p:blipFill>
+        <p:spPr>
+          <a:xfrm>
+            <a:off x="9372600" y="292608"/>
+            <a:ext cx="2148840" cy="537210"/>
+          </a:xfrm>
+          <a:prstGeom prst="rect">
+            <a:avLst/>
+          </a:prstGeom>
+        </p:spPr>
+      </p:pic>
+      <p:sp>
+        <p:nvSpPr>
+          <p:cNvPr id="5" name="Rectangle 4"/>
+          <p:cNvSpPr/>
+          <p:nvPr/>
+        </p:nvSpPr>
+        <p:spPr>
+          <a:xfrm>
+            <a:off x="658368" y="1481328"/>
+            <a:ext cx="292608" cy="50292"/>
+          </a:xfrm>
+          <a:prstGeom prst="rect">
+            <a:avLst/>
+          </a:prstGeom>
+          <a:solidFill>
+            <a:srgbClr val="F6BB26"/>
+          </a:solidFill>
+          <a:ln>
+            <a:noFill/>
+          </a:ln>
+        </p:spPr>
+        <p:style>
+          <a:lnRef idx="1">
+            <a:schemeClr val="accent1"/>
+          </a:lnRef>
+          <a:fillRef idx="3">
+            <a:schemeClr val="accent1"/>
+          </a:fillRef>
+          <a:effectRef idx="2">
+            <a:schemeClr val="accent1"/>
+          </a:effectRef>
+          <a:fontRef idx="minor">
+            <a:schemeClr val="lt1"/>
+          </a:fontRef>
+        </p:style>
+        <p:txBody>
+          <a:bodyPr rtlCol="0" anchor="ctr"/>
+          <a:lstStyle/>
+          <a:p>
+            <a:pPr algn="ctr"/>
+          </a:p>
+        </p:txBody>
+      </p:sp>
+      <p:sp>
+        <p:nvSpPr>
+          <p:cNvPr id="6" name="Rectangle 5"/>
+          <p:cNvSpPr/>
+          <p:nvPr/>
+        </p:nvSpPr>
+        <p:spPr>
+          <a:xfrm>
+            <a:off x="1042415" y="1481328"/>
+            <a:ext cx="292608" cy="50292"/>
+          </a:xfrm>
+          <a:prstGeom prst="rect">
+            <a:avLst/>
+          </a:prstGeom>
+          <a:solidFill>
+            <a:srgbClr val="EF6F28"/>
+          </a:solidFill>
+          <a:ln>
+            <a:noFill/>
+          </a:ln>
+        </p:spPr>
+        <p:style>
+          <a:lnRef idx="1">
+            <a:schemeClr val="accent1"/>
+          </a:lnRef>
+          <a:fillRef idx="3">
+            <a:schemeClr val="accent1"/>
+          </a:fillRef>
+          <a:effectRef idx="2">
+            <a:schemeClr val="accent1"/>
+          </a:effectRef>
+          <a:fontRef idx="minor">
+            <a:schemeClr val="lt1"/>
+          </a:fontRef>
+        </p:style>
+        <p:txBody>
+          <a:bodyPr rtlCol="0" anchor="ctr"/>
+          <a:lstStyle/>
+          <a:p>
+            <a:pPr algn="ctr"/>
+          </a:p>
+        </p:txBody>
+      </p:sp>
+      <p:sp>
+        <p:nvSpPr>
+          <p:cNvPr id="7" name="Rectangle 6"/>
+          <p:cNvSpPr/>
+          <p:nvPr/>
+        </p:nvSpPr>
+        <p:spPr>
+          <a:xfrm>
+            <a:off x="1426464" y="1481328"/>
+            <a:ext cx="292608" cy="50292"/>
+          </a:xfrm>
+          <a:prstGeom prst="rect">
+            <a:avLst/>
+          </a:prstGeom>
+          <a:solidFill>
+            <a:srgbClr val="D32F7A"/>
+          </a:solidFill>
+          <a:ln>
+            <a:noFill/>
+          </a:ln>
+        </p:spPr>
+        <p:style>
+          <a:lnRef idx="1">
+            <a:schemeClr val="accent1"/>
+          </a:lnRef>
+          <a:fillRef idx="3">
+            <a:schemeClr val="accent1"/>
+          </a:fillRef>
+          <a:effectRef idx="2">
+            <a:schemeClr val="accent1"/>
+          </a:effectRef>
+          <a:fontRef idx="minor">
+            <a:schemeClr val="lt1"/>
+          </a:fontRef>
+        </p:style>
+        <p:txBody>
+          <a:bodyPr rtlCol="0" anchor="ctr"/>
+          <a:lstStyle/>
+          <a:p>
+            <a:pPr algn="ctr"/>
+          </a:p>
+        </p:txBody>
+      </p:sp>
+      <p:sp>
+        <p:nvSpPr>
+          <p:cNvPr id="8" name="Rectangle 7"/>
+          <p:cNvSpPr/>
+          <p:nvPr/>
+        </p:nvSpPr>
+        <p:spPr>
+          <a:xfrm>
+            <a:off x="1810512" y="1481328"/>
+            <a:ext cx="292608" cy="50292"/>
+          </a:xfrm>
+          <a:prstGeom prst="rect">
+            <a:avLst/>
+          </a:prstGeom>
+          <a:solidFill>
+            <a:srgbClr val="00ADB5"/>
+          </a:solidFill>
+          <a:ln>
+            <a:noFill/>
+          </a:ln>
+        </p:spPr>
+        <p:style>
+          <a:lnRef idx="1">
+            <a:schemeClr val="accent1"/>
+          </a:lnRef>
+          <a:fillRef idx="3">
+            <a:schemeClr val="accent1"/>
+          </a:fillRef>
+          <a:effectRef idx="2">
+            <a:schemeClr val="accent1"/>
+          </a:effectRef>
+          <a:fontRef idx="minor">
+            <a:schemeClr val="lt1"/>
+          </a:fontRef>
+        </p:style>
+        <p:txBody>
+          <a:bodyPr rtlCol="0" anchor="ctr"/>
+          <a:lstStyle/>
+          <a:p>
+            <a:pPr algn="ctr"/>
+          </a:p>
+        </p:txBody>
+      </p:sp>
+      <p:sp>
+        <p:nvSpPr>
+          <p:cNvPr id="9" name="Rounded Rectangle 8"/>
+          <p:cNvSpPr/>
+          <p:nvPr/>
+        </p:nvSpPr>
+        <p:spPr>
+          <a:xfrm>
+            <a:off x="777240" y="1874519"/>
+            <a:ext cx="2514600" cy="1965960"/>
+          </a:xfrm>
+          <a:prstGeom prst="roundRect">
+            <a:avLst/>
+          </a:prstGeom>
+          <a:solidFill>
+            <a:srgbClr val="FFFFFF"/>
+          </a:solidFill>
+          <a:ln w="12700">
+            <a:solidFill>
+              <a:srgbClr val="E1E4E8"/>
+            </a:solidFill>
+          </a:ln>
+        </p:spPr>
+        <p:style>
+          <a:lnRef idx="1">
+            <a:schemeClr val="accent1"/>
+          </a:lnRef>
+          <a:fillRef idx="3">
+            <a:schemeClr val="accent1"/>
+          </a:fillRef>
+          <a:effectRef idx="2">
+            <a:schemeClr val="accent1"/>
+          </a:effectRef>
+          <a:fontRef idx="minor">
+            <a:schemeClr val="lt1"/>
+          </a:fontRef>
+        </p:style>
+        <p:txBody>
+          <a:bodyPr rtlCol="0" anchor="ctr"/>
+          <a:lstStyle/>
+          <a:p>
+            <a:pPr algn="ctr"/>
+          </a:p>
+        </p:txBody>
+      </p:sp>
+      <p:sp>
+        <p:nvSpPr>
+          <p:cNvPr id="10" name="Rectangle 9"/>
+          <p:cNvSpPr/>
+          <p:nvPr/>
+        </p:nvSpPr>
+        <p:spPr>
+          <a:xfrm>
+            <a:off x="777240" y="1874519"/>
+            <a:ext cx="73152" cy="1965960"/>
+          </a:xfrm>
+          <a:prstGeom prst="rect">
+            <a:avLst/>
+          </a:prstGeom>
+          <a:solidFill>
+            <a:srgbClr val="00ADB5"/>
+          </a:solidFill>
+          <a:ln>
+            <a:noFill/>
+          </a:ln>
+        </p:spPr>
+        <p:style>
+          <a:lnRef idx="1">
+            <a:schemeClr val="accent1"/>
+          </a:lnRef>
+          <a:fillRef idx="3">
+            <a:schemeClr val="accent1"/>
+          </a:fillRef>
+          <a:effectRef idx="2">
+            <a:schemeClr val="accent1"/>
+          </a:effectRef>
+          <a:fontRef idx="minor">
+            <a:schemeClr val="lt1"/>
+          </a:fontRef>
+        </p:style>
+        <p:txBody>
+          <a:bodyPr rtlCol="0" anchor="ctr"/>
+          <a:lstStyle/>
+          <a:p>
+            <a:pPr algn="ctr"/>
+          </a:p>
+        </p:txBody>
+      </p:sp>
+      <p:sp>
+        <p:nvSpPr>
+          <p:cNvPr id="11" name="TextBox 10"/>
+          <p:cNvSpPr txBox="1"/>
+          <p:nvPr/>
+        </p:nvSpPr>
+        <p:spPr>
+          <a:xfrm>
+            <a:off x="1005840" y="2039112"/>
+            <a:ext cx="2103120" cy="320040"/>
+          </a:xfrm>
+          <a:prstGeom prst="rect">
+            <a:avLst/>
+          </a:prstGeom>
+          <a:noFill/>
+        </p:spPr>
+        <p:txBody>
+          <a:bodyPr wrap="square">
+            <a:normAutofit/>
+          </a:bodyPr>
+          <a:lstStyle/>
+          <a:p>
+            <a:pPr algn="l">
+              <a:lnSpc>
+                <a:spcPct val="100000"/>
+              </a:lnSpc>
+            </a:pPr>
+            <a:r>
+              <a:rPr sz="1500" b="1">
+                <a:solidFill>
+                  <a:srgbClr val="373739"/>
+                </a:solidFill>
+                <a:latin typeface="Aptos"/>
+              </a:rPr>
+              <a:t>Tiempo experto</a:t>
+            </a:r>
+          </a:p>
+        </p:txBody>
+      </p:sp>
+      <p:sp>
+        <p:nvSpPr>
+          <p:cNvPr id="12" name="TextBox 11"/>
+          <p:cNvSpPr txBox="1"/>
+          <p:nvPr/>
+        </p:nvSpPr>
+        <p:spPr>
+          <a:xfrm>
+            <a:off x="1005840" y="2487168"/>
+            <a:ext cx="2103120" cy="1216152"/>
+          </a:xfrm>
+          <a:prstGeom prst="rect">
+            <a:avLst/>
+          </a:prstGeom>
+          <a:noFill/>
+        </p:spPr>
+        <p:txBody>
+          <a:bodyPr wrap="square">
+            <a:normAutofit/>
+          </a:bodyPr>
+          <a:lstStyle/>
+          <a:p>
+            <a:pPr algn="l">
+              <a:lnSpc>
+                <a:spcPct val="100000"/>
+              </a:lnSpc>
+            </a:pPr>
+            <a:r>
+              <a:rPr sz="1220" b="0">
+                <a:solidFill>
+                  <a:srgbClr val="69696C"/>
+                </a:solidFill>
+                <a:latin typeface="Aptos"/>
+              </a:rPr>
+              <a:t>Menos tiempo en búsqueda documental, lectura repetitiva, comparación y armado de matrices.</a:t>
+            </a:r>
+          </a:p>
+        </p:txBody>
+      </p:sp>
+      <p:sp>
+        <p:nvSpPr>
+          <p:cNvPr id="13" name="Rounded Rectangle 12"/>
+          <p:cNvSpPr/>
+          <p:nvPr/>
+        </p:nvSpPr>
+        <p:spPr>
+          <a:xfrm>
+            <a:off x="3520440" y="1874519"/>
+            <a:ext cx="2514600" cy="1965960"/>
+          </a:xfrm>
+          <a:prstGeom prst="roundRect">
+            <a:avLst/>
+          </a:prstGeom>
+          <a:solidFill>
+            <a:srgbClr val="FFFFFF"/>
+          </a:solidFill>
+          <a:ln w="12700">
+            <a:solidFill>
+              <a:srgbClr val="E1E4E8"/>
+            </a:solidFill>
+          </a:ln>
+        </p:spPr>
+        <p:style>
+          <a:lnRef idx="1">
+            <a:schemeClr val="accent1"/>
+          </a:lnRef>
+          <a:fillRef idx="3">
+            <a:schemeClr val="accent1"/>
+          </a:fillRef>
+          <a:effectRef idx="2">
+            <a:schemeClr val="accent1"/>
+          </a:effectRef>
+          <a:fontRef idx="minor">
+            <a:schemeClr val="lt1"/>
+          </a:fontRef>
+        </p:style>
+        <p:txBody>
+          <a:bodyPr rtlCol="0" anchor="ctr"/>
+          <a:lstStyle/>
+          <a:p>
+            <a:pPr algn="ctr"/>
+          </a:p>
+        </p:txBody>
+      </p:sp>
+      <p:sp>
+        <p:nvSpPr>
+          <p:cNvPr id="14" name="Rectangle 13"/>
+          <p:cNvSpPr/>
+          <p:nvPr/>
+        </p:nvSpPr>
+        <p:spPr>
+          <a:xfrm>
+            <a:off x="3520440" y="1874519"/>
+            <a:ext cx="73152" cy="1965960"/>
+          </a:xfrm>
+          <a:prstGeom prst="rect">
+            <a:avLst/>
+          </a:prstGeom>
+          <a:solidFill>
+            <a:srgbClr val="EF6F28"/>
+          </a:solidFill>
+          <a:ln>
+            <a:noFill/>
+          </a:ln>
+        </p:spPr>
+        <p:style>
+          <a:lnRef idx="1">
+            <a:schemeClr val="accent1"/>
+          </a:lnRef>
+          <a:fillRef idx="3">
+            <a:schemeClr val="accent1"/>
+          </a:fillRef>
+          <a:effectRef idx="2">
+            <a:schemeClr val="accent1"/>
+          </a:effectRef>
+          <a:fontRef idx="minor">
+            <a:schemeClr val="lt1"/>
+          </a:fontRef>
+        </p:style>
+        <p:txBody>
+          <a:bodyPr rtlCol="0" anchor="ctr"/>
+          <a:lstStyle/>
+          <a:p>
+            <a:pPr algn="ctr"/>
+          </a:p>
+        </p:txBody>
+      </p:sp>
+      <p:sp>
+        <p:nvSpPr>
+          <p:cNvPr id="15" name="TextBox 14"/>
+          <p:cNvSpPr txBox="1"/>
+          <p:nvPr/>
+        </p:nvSpPr>
+        <p:spPr>
+          <a:xfrm>
+            <a:off x="3749039" y="2039112"/>
+            <a:ext cx="2103120" cy="320040"/>
+          </a:xfrm>
+          <a:prstGeom prst="rect">
+            <a:avLst/>
+          </a:prstGeom>
+          <a:noFill/>
+        </p:spPr>
+        <p:txBody>
+          <a:bodyPr wrap="square">
+            <a:normAutofit/>
+          </a:bodyPr>
+          <a:lstStyle/>
+          <a:p>
+            <a:pPr algn="l">
+              <a:lnSpc>
+                <a:spcPct val="100000"/>
+              </a:lnSpc>
+            </a:pPr>
+            <a:r>
+              <a:rPr sz="1500" b="1">
+                <a:solidFill>
+                  <a:srgbClr val="373739"/>
+                </a:solidFill>
+                <a:latin typeface="Aptos"/>
+              </a:rPr>
+              <a:t>Consistencia</a:t>
+            </a:r>
+          </a:p>
+        </p:txBody>
+      </p:sp>
+      <p:sp>
+        <p:nvSpPr>
+          <p:cNvPr id="16" name="TextBox 15"/>
+          <p:cNvSpPr txBox="1"/>
+          <p:nvPr/>
+        </p:nvSpPr>
+        <p:spPr>
+          <a:xfrm>
+            <a:off x="3749039" y="2487168"/>
+            <a:ext cx="2103120" cy="1216152"/>
+          </a:xfrm>
+          <a:prstGeom prst="rect">
+            <a:avLst/>
+          </a:prstGeom>
+          <a:noFill/>
+        </p:spPr>
+        <p:txBody>
+          <a:bodyPr wrap="square">
+            <a:normAutofit/>
+          </a:bodyPr>
+          <a:lstStyle/>
+          <a:p>
+            <a:pPr algn="l">
+              <a:lnSpc>
+                <a:spcPct val="100000"/>
+              </a:lnSpc>
+            </a:pPr>
+            <a:r>
+              <a:rPr sz="1220" b="0">
+                <a:solidFill>
+                  <a:srgbClr val="69696C"/>
+                </a:solidFill>
+                <a:latin typeface="Aptos"/>
+              </a:rPr>
+              <a:t>Mismo criterio entre filas, menor variabilidad y estructura homogénea de análisis.</a:t>
+            </a:r>
+          </a:p>
+        </p:txBody>
+      </p:sp>
+      <p:sp>
+        <p:nvSpPr>
+          <p:cNvPr id="17" name="Rounded Rectangle 16"/>
+          <p:cNvSpPr/>
+          <p:nvPr/>
+        </p:nvSpPr>
+        <p:spPr>
+          <a:xfrm>
+            <a:off x="6263640" y="1874519"/>
+            <a:ext cx="2514600" cy="1965960"/>
+          </a:xfrm>
+          <a:prstGeom prst="roundRect">
+            <a:avLst/>
+          </a:prstGeom>
+          <a:solidFill>
+            <a:srgbClr val="FFFFFF"/>
+          </a:solidFill>
+          <a:ln w="12700">
+            <a:solidFill>
+              <a:srgbClr val="E1E4E8"/>
+            </a:solidFill>
+          </a:ln>
+        </p:spPr>
+        <p:style>
+          <a:lnRef idx="1">
+            <a:schemeClr val="accent1"/>
+          </a:lnRef>
+          <a:fillRef idx="3">
+            <a:schemeClr val="accent1"/>
+          </a:fillRef>
+          <a:effectRef idx="2">
+            <a:schemeClr val="accent1"/>
+          </a:effectRef>
+          <a:fontRef idx="minor">
+            <a:schemeClr val="lt1"/>
+          </a:fontRef>
+        </p:style>
+        <p:txBody>
+          <a:bodyPr rtlCol="0" anchor="ctr"/>
+          <a:lstStyle/>
+          <a:p>
+            <a:pPr algn="ctr"/>
+          </a:p>
+        </p:txBody>
+      </p:sp>
+      <p:sp>
+        <p:nvSpPr>
+          <p:cNvPr id="18" name="Rectangle 17"/>
+          <p:cNvSpPr/>
+          <p:nvPr/>
+        </p:nvSpPr>
+        <p:spPr>
+          <a:xfrm>
+            <a:off x="6263640" y="1874519"/>
+            <a:ext cx="73152" cy="1965960"/>
+          </a:xfrm>
+          <a:prstGeom prst="rect">
+            <a:avLst/>
+          </a:prstGeom>
+          <a:solidFill>
+            <a:srgbClr val="D32F7A"/>
+          </a:solidFill>
+          <a:ln>
+            <a:noFill/>
+          </a:ln>
+        </p:spPr>
+        <p:style>
+          <a:lnRef idx="1">
+            <a:schemeClr val="accent1"/>
+          </a:lnRef>
+          <a:fillRef idx="3">
+            <a:schemeClr val="accent1"/>
+          </a:fillRef>
+          <a:effectRef idx="2">
+            <a:schemeClr val="accent1"/>
+          </a:effectRef>
+          <a:fontRef idx="minor">
+            <a:schemeClr val="lt1"/>
+          </a:fontRef>
+        </p:style>
+        <p:txBody>
+          <a:bodyPr rtlCol="0" anchor="ctr"/>
+          <a:lstStyle/>
+          <a:p>
+            <a:pPr algn="ctr"/>
+          </a:p>
+        </p:txBody>
+      </p:sp>
+      <p:sp>
+        <p:nvSpPr>
+          <p:cNvPr id="19" name="TextBox 18"/>
+          <p:cNvSpPr txBox="1"/>
+          <p:nvPr/>
+        </p:nvSpPr>
+        <p:spPr>
+          <a:xfrm>
+            <a:off x="6492240" y="2039112"/>
+            <a:ext cx="2103120" cy="320040"/>
+          </a:xfrm>
+          <a:prstGeom prst="rect">
+            <a:avLst/>
+          </a:prstGeom>
+          <a:noFill/>
+        </p:spPr>
+        <p:txBody>
+          <a:bodyPr wrap="square">
+            <a:normAutofit/>
+          </a:bodyPr>
+          <a:lstStyle/>
+          <a:p>
+            <a:pPr algn="l">
+              <a:lnSpc>
+                <a:spcPct val="100000"/>
+              </a:lnSpc>
+            </a:pPr>
+            <a:r>
+              <a:rPr sz="1500" b="1">
+                <a:solidFill>
+                  <a:srgbClr val="373739"/>
+                </a:solidFill>
+                <a:latin typeface="Aptos"/>
+              </a:rPr>
+              <a:t>Trazabilidad</a:t>
+            </a:r>
+          </a:p>
+        </p:txBody>
+      </p:sp>
+      <p:sp>
+        <p:nvSpPr>
+          <p:cNvPr id="20" name="TextBox 19"/>
+          <p:cNvSpPr txBox="1"/>
+          <p:nvPr/>
+        </p:nvSpPr>
+        <p:spPr>
+          <a:xfrm>
+            <a:off x="6492240" y="2487168"/>
+            <a:ext cx="2103120" cy="1216152"/>
+          </a:xfrm>
+          <a:prstGeom prst="rect">
+            <a:avLst/>
+          </a:prstGeom>
+          <a:noFill/>
+        </p:spPr>
+        <p:txBody>
+          <a:bodyPr wrap="square">
+            <a:normAutofit/>
+          </a:bodyPr>
+          <a:lstStyle/>
+          <a:p>
+            <a:pPr algn="l">
+              <a:lnSpc>
+                <a:spcPct val="100000"/>
+              </a:lnSpc>
+            </a:pPr>
+            <a:r>
+              <a:rPr sz="1220" b="0">
+                <a:solidFill>
+                  <a:srgbClr val="69696C"/>
+                </a:solidFill>
+                <a:latin typeface="Aptos"/>
+              </a:rPr>
+              <a:t>Requisito o criterio → evidencia → fuente → juicio experto → acción.</a:t>
+            </a:r>
+          </a:p>
+        </p:txBody>
+      </p:sp>
+      <p:sp>
+        <p:nvSpPr>
+          <p:cNvPr id="21" name="Rounded Rectangle 20"/>
+          <p:cNvSpPr/>
+          <p:nvPr/>
+        </p:nvSpPr>
+        <p:spPr>
+          <a:xfrm>
+            <a:off x="9006840" y="1874519"/>
+            <a:ext cx="2514600" cy="1965960"/>
+          </a:xfrm>
+          <a:prstGeom prst="roundRect">
+            <a:avLst/>
+          </a:prstGeom>
+          <a:solidFill>
+            <a:srgbClr val="FFFFFF"/>
+          </a:solidFill>
+          <a:ln w="12700">
+            <a:solidFill>
+              <a:srgbClr val="E1E4E8"/>
+            </a:solidFill>
+          </a:ln>
+        </p:spPr>
+        <p:style>
+          <a:lnRef idx="1">
+            <a:schemeClr val="accent1"/>
+          </a:lnRef>
+          <a:fillRef idx="3">
+            <a:schemeClr val="accent1"/>
+          </a:fillRef>
+          <a:effectRef idx="2">
+            <a:schemeClr val="accent1"/>
+          </a:effectRef>
+          <a:fontRef idx="minor">
+            <a:schemeClr val="lt1"/>
+          </a:fontRef>
+        </p:style>
+        <p:txBody>
+          <a:bodyPr rtlCol="0" anchor="ctr"/>
+          <a:lstStyle/>
+          <a:p>
+            <a:pPr algn="ctr"/>
+          </a:p>
+        </p:txBody>
+      </p:sp>
+      <p:sp>
+        <p:nvSpPr>
+          <p:cNvPr id="22" name="Rectangle 21"/>
+          <p:cNvSpPr/>
+          <p:nvPr/>
+        </p:nvSpPr>
+        <p:spPr>
+          <a:xfrm>
+            <a:off x="9006840" y="1874519"/>
+            <a:ext cx="73152" cy="1965960"/>
+          </a:xfrm>
+          <a:prstGeom prst="rect">
+            <a:avLst/>
+          </a:prstGeom>
+          <a:solidFill>
+            <a:srgbClr val="F6BB26"/>
+          </a:solidFill>
+          <a:ln>
+            <a:noFill/>
+          </a:ln>
+        </p:spPr>
+        <p:style>
+          <a:lnRef idx="1">
+            <a:schemeClr val="accent1"/>
+          </a:lnRef>
+          <a:fillRef idx="3">
+            <a:schemeClr val="accent1"/>
+          </a:fillRef>
+          <a:effectRef idx="2">
+            <a:schemeClr val="accent1"/>
+          </a:effectRef>
+          <a:fontRef idx="minor">
+            <a:schemeClr val="lt1"/>
+          </a:fontRef>
+        </p:style>
+        <p:txBody>
+          <a:bodyPr rtlCol="0" anchor="ctr"/>
+          <a:lstStyle/>
+          <a:p>
+            <a:pPr algn="ctr"/>
+          </a:p>
+        </p:txBody>
+      </p:sp>
+      <p:sp>
+        <p:nvSpPr>
+          <p:cNvPr id="23" name="TextBox 22"/>
+          <p:cNvSpPr txBox="1"/>
+          <p:nvPr/>
+        </p:nvSpPr>
+        <p:spPr>
+          <a:xfrm>
+            <a:off x="9235440" y="2039112"/>
+            <a:ext cx="2103120" cy="320040"/>
+          </a:xfrm>
+          <a:prstGeom prst="rect">
+            <a:avLst/>
+          </a:prstGeom>
+          <a:noFill/>
+        </p:spPr>
+        <p:txBody>
+          <a:bodyPr wrap="square">
+            <a:normAutofit/>
+          </a:bodyPr>
+          <a:lstStyle/>
+          <a:p>
+            <a:pPr algn="l">
+              <a:lnSpc>
+                <a:spcPct val="100000"/>
+              </a:lnSpc>
+            </a:pPr>
+            <a:r>
+              <a:rPr sz="1500" b="1">
+                <a:solidFill>
+                  <a:srgbClr val="373739"/>
+                </a:solidFill>
+                <a:latin typeface="Aptos"/>
+              </a:rPr>
+              <a:t>Foco directivo</a:t>
+            </a:r>
+          </a:p>
+        </p:txBody>
+      </p:sp>
+      <p:sp>
+        <p:nvSpPr>
+          <p:cNvPr id="24" name="TextBox 23"/>
+          <p:cNvSpPr txBox="1"/>
+          <p:nvPr/>
+        </p:nvSpPr>
+        <p:spPr>
+          <a:xfrm>
+            <a:off x="9235440" y="2487168"/>
+            <a:ext cx="2103120" cy="1216152"/>
+          </a:xfrm>
+          <a:prstGeom prst="rect">
+            <a:avLst/>
+          </a:prstGeom>
+          <a:noFill/>
+        </p:spPr>
+        <p:txBody>
+          <a:bodyPr wrap="square">
+            <a:normAutofit/>
+          </a:bodyPr>
+          <a:lstStyle/>
+          <a:p>
+            <a:pPr algn="l">
+              <a:lnSpc>
+                <a:spcPct val="100000"/>
+              </a:lnSpc>
+            </a:pPr>
+            <a:r>
+              <a:rPr sz="1220" b="0">
+                <a:solidFill>
+                  <a:srgbClr val="69696C"/>
+                </a:solidFill>
+                <a:latin typeface="Aptos"/>
+              </a:rPr>
+              <a:t>Más tiempo para validar, priorizar brechas, decidir y orientar planes de mejora.</a:t>
+            </a:r>
+          </a:p>
+        </p:txBody>
+      </p:sp>
+      <p:sp>
+        <p:nvSpPr>
+          <p:cNvPr id="25" name="Rounded Rectangle 24"/>
+          <p:cNvSpPr/>
+          <p:nvPr/>
+        </p:nvSpPr>
+        <p:spPr>
+          <a:xfrm>
+            <a:off x="868680" y="4663440"/>
+            <a:ext cx="10469880" cy="841248"/>
+          </a:xfrm>
+          <a:prstGeom prst="roundRect">
+            <a:avLst/>
+          </a:prstGeom>
+          <a:solidFill>
+            <a:srgbClr val="F4F6F8"/>
+          </a:solidFill>
+          <a:ln>
+            <a:noFill/>
+          </a:ln>
+        </p:spPr>
+        <p:style>
+          <a:lnRef idx="1">
+            <a:schemeClr val="accent1"/>
+          </a:lnRef>
+          <a:fillRef idx="3">
+            <a:schemeClr val="accent1"/>
+          </a:fillRef>
+          <a:effectRef idx="2">
+            <a:schemeClr val="accent1"/>
+          </a:effectRef>
+          <a:fontRef idx="minor">
+            <a:schemeClr val="lt1"/>
+          </a:fontRef>
+        </p:style>
+        <p:txBody>
+          <a:bodyPr rtlCol="0" anchor="ctr"/>
+          <a:lstStyle/>
+          <a:p>
+            <a:pPr algn="ctr"/>
+          </a:p>
+        </p:txBody>
+      </p:sp>
+      <p:sp>
+        <p:nvSpPr>
+          <p:cNvPr id="26" name="TextBox 25"/>
+          <p:cNvSpPr txBox="1"/>
+          <p:nvPr/>
+        </p:nvSpPr>
+        <p:spPr>
+          <a:xfrm>
+            <a:off x="1124712" y="4864607"/>
+            <a:ext cx="9957815" cy="457200"/>
+          </a:xfrm>
+          <a:prstGeom prst="rect">
+            <a:avLst/>
+          </a:prstGeom>
+          <a:noFill/>
+        </p:spPr>
+        <p:txBody>
+          <a:bodyPr wrap="square">
+            <a:normAutofit/>
+          </a:bodyPr>
+          <a:lstStyle/>
+          <a:p>
+            <a:pPr algn="l">
+              <a:lnSpc>
+                <a:spcPct val="105000"/>
+              </a:lnSpc>
+            </a:pPr>
+            <a:r>
+              <a:rPr sz="1800" b="1">
+                <a:solidFill>
+                  <a:srgbClr val="373739"/>
+                </a:solidFill>
+                <a:latin typeface="Aptos"/>
+              </a:rPr>
+              <a:t>El beneficio no es reemplazar al experto: es devolverle tiempo y foco para decidir mejor.</a:t>
+            </a:r>
+          </a:p>
+        </p:txBody>
+      </p:sp>
+      <p:sp>
+        <p:nvSpPr>
+          <p:cNvPr id="27" name="Rectangle 26"/>
+          <p:cNvSpPr/>
+          <p:nvPr/>
+        </p:nvSpPr>
+        <p:spPr>
+          <a:xfrm>
+            <a:off x="868680" y="4663440"/>
+            <a:ext cx="73152" cy="841248"/>
+          </a:xfrm>
+          <a:prstGeom prst="rect">
+            <a:avLst/>
+          </a:prstGeom>
+          <a:solidFill>
+            <a:srgbClr val="00ADB5"/>
+          </a:solidFill>
+          <a:ln>
+            <a:noFill/>
+          </a:ln>
+        </p:spPr>
+        <p:style>
+          <a:lnRef idx="1">
+            <a:schemeClr val="accent1"/>
+          </a:lnRef>
+          <a:fillRef idx="3">
+            <a:schemeClr val="accent1"/>
+          </a:fillRef>
+          <a:effectRef idx="2">
+            <a:schemeClr val="accent1"/>
+          </a:effectRef>
+          <a:fontRef idx="minor">
+            <a:schemeClr val="lt1"/>
+          </a:fontRef>
+        </p:style>
+        <p:txBody>
+          <a:bodyPr rtlCol="0" anchor="ctr"/>
+          <a:lstStyle/>
+          <a:p>
+            <a:pPr algn="ctr"/>
+          </a:p>
+        </p:txBody>
+      </p:sp>
+      <p:sp>
+        <p:nvSpPr>
+          <p:cNvPr id="28" name="TextBox 27"/>
+          <p:cNvSpPr txBox="1"/>
+          <p:nvPr/>
+        </p:nvSpPr>
+        <p:spPr>
+          <a:xfrm>
+            <a:off x="960120" y="5715000"/>
+            <a:ext cx="10241280" cy="256032"/>
+          </a:xfrm>
+          <a:prstGeom prst="rect">
+            <a:avLst/>
+          </a:prstGeom>
+          <a:noFill/>
+        </p:spPr>
+        <p:txBody>
+          <a:bodyPr wrap="square">
+            <a:normAutofit/>
+          </a:bodyPr>
+          <a:lstStyle/>
+          <a:p>
+            <a:pPr algn="ctr">
+              <a:lnSpc>
+                <a:spcPct val="100000"/>
+              </a:lnSpc>
+            </a:pPr>
+            <a:r>
+              <a:rPr sz="1280" b="0">
+                <a:solidFill>
+                  <a:srgbClr val="69696C"/>
+                </a:solidFill>
+                <a:latin typeface="Aptos"/>
+              </a:rPr>
+              <a:t>Aplicado a ISO y PNC: acelerar el ordenamiento de evidencia sin resignar criterio, trazabilidad ni validación humana.</a:t>
+            </a:r>
+          </a:p>
+        </p:txBody>
+      </p:sp>
+      <p:sp>
+        <p:nvSpPr>
+          <p:cNvPr id="29" name="TextBox 28"/>
+          <p:cNvSpPr txBox="1"/>
+          <p:nvPr/>
+        </p:nvSpPr>
+        <p:spPr>
+          <a:xfrm>
+            <a:off x="658368" y="6446520"/>
+            <a:ext cx="4023360" cy="182880"/>
+          </a:xfrm>
+          <a:prstGeom prst="rect">
+            <a:avLst/>
+          </a:prstGeom>
+          <a:noFill/>
+        </p:spPr>
+        <p:txBody>
+          <a:bodyPr wrap="square">
+            <a:normAutofit/>
+          </a:bodyPr>
+          <a:lstStyle/>
+          <a:p>
+            <a:pPr algn="l">
+              <a:lnSpc>
+                <a:spcPct val="100000"/>
+              </a:lnSpc>
+            </a:pPr>
+            <a:r>
+              <a:rPr sz="850" b="0">
+                <a:solidFill>
+                  <a:srgbClr val="69696C"/>
+                </a:solidFill>
+                <a:latin typeface="Aptos"/>
+              </a:rPr>
+              <a:t>EXCELENCIA · IA organizacional</a:t>
+            </a:r>
+          </a:p>
+        </p:txBody>
+      </p:sp>
+      <p:sp>
+        <p:nvSpPr>
+          <p:cNvPr id="30" name="TextBox 29"/>
+          <p:cNvSpPr txBox="1"/>
+          <p:nvPr/>
+        </p:nvSpPr>
+        <p:spPr>
+          <a:xfrm>
+            <a:off x="11109960" y="6446520"/>
+            <a:ext cx="411480" cy="182880"/>
+          </a:xfrm>
+          <a:prstGeom prst="rect">
+            <a:avLst/>
+          </a:prstGeom>
+          <a:noFill/>
+        </p:spPr>
+        <p:txBody>
+          <a:bodyPr wrap="square">
+            <a:normAutofit/>
+          </a:bodyPr>
+          <a:lstStyle/>
+          <a:p>
+            <a:pPr algn="r">
+              <a:lnSpc>
+                <a:spcPct val="100000"/>
+              </a:lnSpc>
+            </a:pPr>
+            <a:r>
+              <a:rPr sz="850" b="0">
+                <a:solidFill>
+                  <a:srgbClr val="69696C"/>
+                </a:solidFill>
+                <a:latin typeface="Aptos"/>
+              </a:rPr>
+              <a:t>13</a:t>
+            </a:r>
+          </a:p>
+        </p:txBody>
+      </p:sp>
+      <p:sp>
+        <p:nvSpPr>
+          <p:cNvPr id="31" name="Rectangle 30"/>
+          <p:cNvSpPr/>
+          <p:nvPr/>
+        </p:nvSpPr>
+        <p:spPr>
+          <a:xfrm>
+            <a:off x="658368" y="6345936"/>
+            <a:ext cx="10881360" cy="9144"/>
+          </a:xfrm>
+          <a:prstGeom prst="rect">
+            <a:avLst/>
+          </a:prstGeom>
+          <a:solidFill>
+            <a:srgbClr val="E1E4E8"/>
+          </a:solidFill>
+          <a:ln>
+            <a:noFill/>
+          </a:ln>
+        </p:spPr>
+        <p:style>
+          <a:lnRef idx="1">
+            <a:schemeClr val="accent1"/>
+          </a:lnRef>
+          <a:fillRef idx="3">
+            <a:schemeClr val="accent1"/>
+          </a:fillRef>
+          <a:effectRef idx="2">
+            <a:schemeClr val="accent1"/>
+          </a:effectRef>
+          <a:fontRef idx="minor">
+            <a:schemeClr val="lt1"/>
+          </a:fontRef>
+        </p:style>
+        <p:txBody>
+          <a:bodyPr rtlCol="0" anchor="ctr"/>
+          <a:lstStyle/>
+          <a:p>
+            <a:pPr algn="ctr"/>
+          </a:p>
+        </p:txBody>
+      </p:sp>
+    </p:spTree>
+  </p:cSld>
+  <p:clrMapOvr>
+    <a:masterClrMapping/>
+  </p:clrMapOvr>
+</p:sld>
+</file>
+
+<file path=ppt/slides/slide14.xml><?xml version="1.0" encoding="utf-8"?>
+<p:sld xmlns:a="http://schemas.openxmlformats.org/drawingml/2006/main" xmlns:p="http://schemas.openxmlformats.org/presentationml/2006/main" xmlns:r="http://schemas.openxmlformats.org/officeDocument/2006/relationships">
+  <p:cSld>
+    <p:bg>
+      <p:bgPr>
+        <a:solidFill>
+          <a:srgbClr val="FFFFFF"/>
+        </a:solidFill>
+        <a:effectLst/>
+      </p:bgPr>
+    </p:bg>
+    <p:spTree>
+      <p:nvGrpSpPr>
+        <p:cNvPr id="1" name=""/>
+        <p:cNvGrpSpPr/>
+        <p:nvPr/>
+      </p:nvGrpSpPr>
+      <p:grpSpPr/>
+      <p:sp>
+        <p:nvSpPr>
+          <p:cNvPr id="2" name="Parallelogram 1"/>
+          <p:cNvSpPr/>
+          <p:nvPr/>
+        </p:nvSpPr>
+        <p:spPr>
+          <a:xfrm>
+            <a:off x="8641080" y="-137160"/>
+            <a:ext cx="594360" cy="7269480"/>
+          </a:xfrm>
+          <a:prstGeom prst="parallelogram">
+            <a:avLst/>
+          </a:prstGeom>
+          <a:solidFill>
+            <a:srgbClr val="F6BB26"/>
+          </a:solidFill>
+          <a:ln>
+            <a:noFill/>
+          </a:ln>
+        </p:spPr>
+        <p:style>
+          <a:lnRef idx="1">
+            <a:schemeClr val="accent1"/>
+          </a:lnRef>
+          <a:fillRef idx="3">
+            <a:schemeClr val="accent1"/>
+          </a:fillRef>
+          <a:effectRef idx="2">
+            <a:schemeClr val="accent1"/>
+          </a:effectRef>
+          <a:fontRef idx="minor">
+            <a:schemeClr val="lt1"/>
+          </a:fontRef>
+        </p:style>
+        <p:txBody>
+          <a:bodyPr rtlCol="0" anchor="ctr"/>
+          <a:lstStyle/>
+          <a:p>
+            <a:pPr algn="ctr"/>
+          </a:p>
+        </p:txBody>
+      </p:sp>
+      <p:sp>
+        <p:nvSpPr>
+          <p:cNvPr id="3" name="Parallelogram 2"/>
+          <p:cNvSpPr/>
+          <p:nvPr/>
+        </p:nvSpPr>
+        <p:spPr>
+          <a:xfrm>
+            <a:off x="9189720" y="-137160"/>
+            <a:ext cx="594360" cy="7269480"/>
+          </a:xfrm>
+          <a:prstGeom prst="parallelogram">
+            <a:avLst/>
+          </a:prstGeom>
+          <a:solidFill>
+            <a:srgbClr val="EF6F28"/>
+          </a:solidFill>
+          <a:ln>
+            <a:noFill/>
+          </a:ln>
+        </p:spPr>
+        <p:style>
+          <a:lnRef idx="1">
+            <a:schemeClr val="accent1"/>
+          </a:lnRef>
+          <a:fillRef idx="3">
+            <a:schemeClr val="accent1"/>
+          </a:fillRef>
+          <a:effectRef idx="2">
+            <a:schemeClr val="accent1"/>
+          </a:effectRef>
+          <a:fontRef idx="minor">
+            <a:schemeClr val="lt1"/>
+          </a:fontRef>
+        </p:style>
+        <p:txBody>
+          <a:bodyPr rtlCol="0" anchor="ctr"/>
+          <a:lstStyle/>
+          <a:p>
+            <a:pPr algn="ctr"/>
+          </a:p>
+        </p:txBody>
+      </p:sp>
+      <p:sp>
+        <p:nvSpPr>
+          <p:cNvPr id="4" name="Parallelogram 3"/>
+          <p:cNvSpPr/>
+          <p:nvPr/>
+        </p:nvSpPr>
+        <p:spPr>
+          <a:xfrm>
+            <a:off x="9738360" y="-137160"/>
+            <a:ext cx="594360" cy="7269480"/>
+          </a:xfrm>
+          <a:prstGeom prst="parallelogram">
+            <a:avLst/>
+          </a:prstGeom>
+          <a:solidFill>
+            <a:srgbClr val="D32F7A"/>
+          </a:solidFill>
+          <a:ln>
+            <a:noFill/>
+          </a:ln>
+        </p:spPr>
+        <p:style>
+          <a:lnRef idx="1">
+            <a:schemeClr val="accent1"/>
+          </a:lnRef>
+          <a:fillRef idx="3">
+            <a:schemeClr val="accent1"/>
+          </a:fillRef>
+          <a:effectRef idx="2">
+            <a:schemeClr val="accent1"/>
+          </a:effectRef>
+          <a:fontRef idx="minor">
+            <a:schemeClr val="lt1"/>
+          </a:fontRef>
+        </p:style>
+        <p:txBody>
+          <a:bodyPr rtlCol="0" anchor="ctr"/>
+          <a:lstStyle/>
+          <a:p>
+            <a:pPr algn="ctr"/>
+          </a:p>
+        </p:txBody>
+      </p:sp>
+      <p:sp>
+        <p:nvSpPr>
+          <p:cNvPr id="5" name="Parallelogram 4"/>
+          <p:cNvSpPr/>
+          <p:nvPr/>
+        </p:nvSpPr>
+        <p:spPr>
+          <a:xfrm>
+            <a:off x="10287000" y="-137160"/>
+            <a:ext cx="594360" cy="7269480"/>
+          </a:xfrm>
+          <a:prstGeom prst="parallelogram">
+            <a:avLst/>
+          </a:prstGeom>
+          <a:solidFill>
+            <a:srgbClr val="00ADB5"/>
+          </a:solidFill>
+          <a:ln>
+            <a:noFill/>
+          </a:ln>
+        </p:spPr>
+        <p:style>
+          <a:lnRef idx="1">
+            <a:schemeClr val="accent1"/>
+          </a:lnRef>
+          <a:fillRef idx="3">
+            <a:schemeClr val="accent1"/>
+          </a:fillRef>
+          <a:effectRef idx="2">
+            <a:schemeClr val="accent1"/>
+          </a:effectRef>
+          <a:fontRef idx="minor">
+            <a:schemeClr val="lt1"/>
+          </a:fontRef>
+        </p:style>
+        <p:txBody>
+          <a:bodyPr rtlCol="0" anchor="ctr"/>
+          <a:lstStyle/>
+          <a:p>
+            <a:pPr algn="ctr"/>
+          </a:p>
+        </p:txBody>
+      </p:sp>
+      <p:pic>
+        <p:nvPicPr>
+          <p:cNvPr id="6" name="Picture 5" descr="excelencia-logo.png"/>
+          <p:cNvPicPr>
+            <a:picLocks noChangeAspect="1"/>
+          </p:cNvPicPr>
+          <p:nvPr/>
+        </p:nvPicPr>
+        <p:blipFill>
+          <a:blip r:embed="rId2"/>
+          <a:stretch>
+            <a:fillRect/>
+          </a:stretch>
+        </p:blipFill>
+        <p:spPr>
+          <a:xfrm>
+            <a:off x="9372600" y="292608"/>
+            <a:ext cx="2148840" cy="537210"/>
+          </a:xfrm>
+          <a:prstGeom prst="rect">
+            <a:avLst/>
+          </a:prstGeom>
+        </p:spPr>
+      </p:pic>
+      <p:sp>
+        <p:nvSpPr>
+          <p:cNvPr id="7" name="TextBox 6"/>
+          <p:cNvSpPr txBox="1"/>
+          <p:nvPr/>
+        </p:nvSpPr>
+        <p:spPr>
+          <a:xfrm>
+            <a:off x="749808" y="777240"/>
+            <a:ext cx="4114800" cy="274320"/>
+          </a:xfrm>
+          <a:prstGeom prst="rect">
+            <a:avLst/>
+          </a:prstGeom>
+          <a:noFill/>
+        </p:spPr>
+        <p:txBody>
+          <a:bodyPr wrap="square">
+            <a:normAutofit/>
+          </a:bodyPr>
+          <a:lstStyle/>
+          <a:p>
+            <a:pPr algn="l">
+              <a:lnSpc>
+                <a:spcPct val="100000"/>
+              </a:lnSpc>
+            </a:pPr>
+            <a:r>
+              <a:rPr sz="1100" b="1">
+                <a:solidFill>
+                  <a:srgbClr val="00ADB5"/>
+                </a:solidFill>
+                <a:latin typeface="Aptos"/>
+              </a:rPr>
+              <a:t>PREGUNTA FINAL</a:t>
+            </a:r>
+          </a:p>
+        </p:txBody>
+      </p:sp>
+      <p:sp>
+        <p:nvSpPr>
+          <p:cNvPr id="8" name="TextBox 7"/>
+          <p:cNvSpPr txBox="1"/>
+          <p:nvPr/>
+        </p:nvSpPr>
+        <p:spPr>
+          <a:xfrm>
+            <a:off x="749808" y="1417320"/>
+            <a:ext cx="7315200" cy="1828800"/>
+          </a:xfrm>
+          <a:prstGeom prst="rect">
+            <a:avLst/>
+          </a:prstGeom>
+          <a:noFill/>
+        </p:spPr>
+        <p:txBody>
+          <a:bodyPr wrap="square">
+            <a:normAutofit/>
+          </a:bodyPr>
+          <a:lstStyle/>
+          <a:p>
+            <a:pPr algn="l">
+              <a:lnSpc>
+                <a:spcPct val="95000"/>
+              </a:lnSpc>
+            </a:pPr>
+            <a:r>
+              <a:rPr sz="3000" b="1">
+                <a:solidFill>
+                  <a:srgbClr val="373739"/>
+                </a:solidFill>
+                <a:latin typeface="Aptos"/>
+              </a:rPr>
+              <a:t>Si mañana incorporáramos IA en nuestros procesos críticos, ¿trabajaría sobre la mejor versión de nuestra organización o sobre nuestro desorden documental?</a:t>
+            </a:r>
+          </a:p>
+        </p:txBody>
+      </p:sp>
+      <p:sp>
+        <p:nvSpPr>
+          <p:cNvPr id="9" name="Rounded Rectangle 8"/>
+          <p:cNvSpPr/>
+          <p:nvPr/>
+        </p:nvSpPr>
+        <p:spPr>
+          <a:xfrm>
+            <a:off x="804672" y="4251960"/>
+            <a:ext cx="6949440" cy="749808"/>
+          </a:xfrm>
+          <a:prstGeom prst="roundRect">
+            <a:avLst/>
+          </a:prstGeom>
+          <a:solidFill>
+            <a:srgbClr val="F4F6F8"/>
+          </a:solidFill>
+          <a:ln>
+            <a:noFill/>
+          </a:ln>
+        </p:spPr>
+        <p:style>
+          <a:lnRef idx="1">
+            <a:schemeClr val="accent1"/>
+          </a:lnRef>
+          <a:fillRef idx="3">
+            <a:schemeClr val="accent1"/>
+          </a:fillRef>
+          <a:effectRef idx="2">
+            <a:schemeClr val="accent1"/>
+          </a:effectRef>
+          <a:fontRef idx="minor">
+            <a:schemeClr val="lt1"/>
+          </a:fontRef>
+        </p:style>
+        <p:txBody>
+          <a:bodyPr rtlCol="0" anchor="ctr"/>
+          <a:lstStyle/>
+          <a:p>
+            <a:pPr algn="ctr"/>
+          </a:p>
+        </p:txBody>
+      </p:sp>
+      <p:sp>
+        <p:nvSpPr>
+          <p:cNvPr id="10" name="TextBox 9"/>
+          <p:cNvSpPr txBox="1"/>
+          <p:nvPr/>
+        </p:nvSpPr>
+        <p:spPr>
+          <a:xfrm>
+            <a:off x="1060704" y="4453128"/>
+            <a:ext cx="6437375" cy="365759"/>
+          </a:xfrm>
+          <a:prstGeom prst="rect">
+            <a:avLst/>
+          </a:prstGeom>
+          <a:noFill/>
+        </p:spPr>
+        <p:txBody>
+          <a:bodyPr wrap="square">
+            <a:normAutofit/>
+          </a:bodyPr>
+          <a:lstStyle/>
+          <a:p>
+            <a:pPr algn="l">
+              <a:lnSpc>
+                <a:spcPct val="105000"/>
+              </a:lnSpc>
+            </a:pPr>
+            <a:r>
+              <a:rPr sz="1800" b="1">
+                <a:solidFill>
+                  <a:srgbClr val="373739"/>
+                </a:solidFill>
+                <a:latin typeface="Aptos"/>
+              </a:rPr>
+              <a:t>Empezar por un diagnóstico: información confiable, datos íntegros, procesos claros y gobierno suficiente para que la IA cree valor real.</a:t>
+            </a:r>
+          </a:p>
+        </p:txBody>
+      </p:sp>
+      <p:sp>
+        <p:nvSpPr>
+          <p:cNvPr id="11" name="Rectangle 10"/>
+          <p:cNvSpPr/>
+          <p:nvPr/>
+        </p:nvSpPr>
+        <p:spPr>
+          <a:xfrm>
+            <a:off x="804672" y="4251960"/>
+            <a:ext cx="73152" cy="749808"/>
+          </a:xfrm>
+          <a:prstGeom prst="rect">
+            <a:avLst/>
+          </a:prstGeom>
+          <a:solidFill>
+            <a:srgbClr val="D32F7A"/>
+          </a:solidFill>
+          <a:ln>
+            <a:noFill/>
+          </a:ln>
+        </p:spPr>
+        <p:style>
+          <a:lnRef idx="1">
+            <a:schemeClr val="accent1"/>
+          </a:lnRef>
+          <a:fillRef idx="3">
+            <a:schemeClr val="accent1"/>
+          </a:fillRef>
+          <a:effectRef idx="2">
+            <a:schemeClr val="accent1"/>
+          </a:effectRef>
+          <a:fontRef idx="minor">
+            <a:schemeClr val="lt1"/>
+          </a:fontRef>
+        </p:style>
+        <p:txBody>
+          <a:bodyPr rtlCol="0" anchor="ctr"/>
+          <a:lstStyle/>
+          <a:p>
+            <a:pPr algn="ctr"/>
+          </a:p>
+        </p:txBody>
+      </p:sp>
+      <p:sp>
+        <p:nvSpPr>
+          <p:cNvPr id="12" name="TextBox 11"/>
+          <p:cNvSpPr txBox="1"/>
+          <p:nvPr/>
+        </p:nvSpPr>
+        <p:spPr>
+          <a:xfrm>
+            <a:off x="868680" y="5650992"/>
+            <a:ext cx="6858000" cy="329184"/>
+          </a:xfrm>
+          <a:prstGeom prst="rect">
+            <a:avLst/>
+          </a:prstGeom>
+          <a:noFill/>
+        </p:spPr>
+        <p:txBody>
+          <a:bodyPr wrap="square">
+            <a:normAutofit/>
+          </a:bodyPr>
+          <a:lstStyle/>
+          <a:p>
+            <a:pPr algn="l">
+              <a:lnSpc>
+                <a:spcPct val="100000"/>
+              </a:lnSpc>
+            </a:pPr>
+            <a:r>
+              <a:rPr sz="1350" b="0">
+                <a:solidFill>
+                  <a:srgbClr val="69696C"/>
+                </a:solidFill>
+                <a:latin typeface="Aptos"/>
+              </a:rPr>
+              <a:t>EXCELENCIA · Preparar la base confiable para IA y diseñar agentes gobernados orientados a resultados.</a:t>
+            </a:r>
+          </a:p>
+        </p:txBody>
+      </p:sp>
+      <p:sp>
+        <p:nvSpPr>
+          <p:cNvPr id="13" name="TextBox 12"/>
+          <p:cNvSpPr txBox="1"/>
+          <p:nvPr/>
+        </p:nvSpPr>
+        <p:spPr>
+          <a:xfrm>
+            <a:off x="658368" y="6446520"/>
+            <a:ext cx="4023360" cy="182880"/>
+          </a:xfrm>
+          <a:prstGeom prst="rect">
+            <a:avLst/>
+          </a:prstGeom>
+          <a:noFill/>
+        </p:spPr>
+        <p:txBody>
+          <a:bodyPr wrap="square">
+            <a:normAutofit/>
+          </a:bodyPr>
+          <a:lstStyle/>
+          <a:p>
+            <a:pPr algn="l">
+              <a:lnSpc>
+                <a:spcPct val="100000"/>
+              </a:lnSpc>
+            </a:pPr>
+            <a:r>
+              <a:rPr sz="850" b="0">
+                <a:solidFill>
+                  <a:srgbClr val="69696C"/>
+                </a:solidFill>
+                <a:latin typeface="Aptos"/>
+              </a:rPr>
+              <a:t>EXCELENCIA · IA organizacional</a:t>
+            </a:r>
+          </a:p>
+        </p:txBody>
+      </p:sp>
+      <p:sp>
+        <p:nvSpPr>
+          <p:cNvPr id="14" name="TextBox 13"/>
+          <p:cNvSpPr txBox="1"/>
+          <p:nvPr/>
+        </p:nvSpPr>
+        <p:spPr>
+          <a:xfrm>
+            <a:off x="11109960" y="6446520"/>
+            <a:ext cx="411480" cy="182880"/>
+          </a:xfrm>
+          <a:prstGeom prst="rect">
+            <a:avLst/>
+          </a:prstGeom>
+          <a:noFill/>
+        </p:spPr>
+        <p:txBody>
+          <a:bodyPr wrap="square">
+            <a:normAutofit/>
+          </a:bodyPr>
+          <a:lstStyle/>
+          <a:p>
+            <a:pPr algn="r">
+              <a:lnSpc>
+                <a:spcPct val="100000"/>
+              </a:lnSpc>
+            </a:pPr>
+            <a:r>
+              <a:rPr sz="850" b="0">
+                <a:solidFill>
+                  <a:srgbClr val="69696C"/>
+                </a:solidFill>
+                <a:latin typeface="Aptos"/>
+              </a:rPr>
+              <a:t>14</a:t>
+            </a:r>
+          </a:p>
+        </p:txBody>
+      </p:sp>
+      <p:sp>
+        <p:nvSpPr>
+          <p:cNvPr id="15" name="Rectangle 14"/>
           <p:cNvSpPr/>
           <p:nvPr/>
         </p:nvSpPr>

</xml_diff>

<commit_message>
Incorporar valor del agente en slides ISO y PNC
</commit_message>
<xml_diff>
--- a/presentacion/charla-excelencia-ia-organizacional.pptx
+++ b/presentacion/charla-excelencia-ia-organizacional.pptx
@@ -4802,7 +4802,7 @@
         <p:spPr>
           <a:xfrm>
             <a:off x="868680" y="3493008"/>
-            <a:ext cx="1325880" cy="310896"/>
+            <a:ext cx="1170432" cy="283464"/>
           </a:xfrm>
           <a:prstGeom prst="roundRect">
             <a:avLst/>
@@ -4844,8 +4844,8 @@
         </p:nvSpPr>
         <p:spPr>
           <a:xfrm>
-            <a:off x="932688" y="3566160"/>
-            <a:ext cx="1188720" cy="118872"/>
+            <a:off x="932688" y="3557015"/>
+            <a:ext cx="1042415" cy="118872"/>
           </a:xfrm>
           <a:prstGeom prst="rect">
             <a:avLst/>
@@ -4864,7 +4864,7 @@
               </a:lnSpc>
             </a:pPr>
             <a:r>
-              <a:rPr sz="880" b="1">
+              <a:rPr sz="800" b="1">
                 <a:solidFill>
                   <a:srgbClr val="FFFFFF"/>
                 </a:solidFill>
@@ -4883,8 +4883,8 @@
         </p:nvSpPr>
         <p:spPr>
           <a:xfrm>
-            <a:off x="2423160" y="3538727"/>
-            <a:ext cx="8366760" cy="201168"/>
+            <a:off x="2212848" y="3529584"/>
+            <a:ext cx="3703320" cy="201168"/>
           </a:xfrm>
           <a:prstGeom prst="rect">
             <a:avLst/>
@@ -4903,7 +4903,7 @@
               </a:lnSpc>
             </a:pPr>
             <a:r>
-              <a:rPr sz="1080" b="0">
+              <a:rPr sz="919" b="0">
                 <a:solidFill>
                   <a:srgbClr val="373739"/>
                 </a:solidFill>
@@ -4922,8 +4922,8 @@
         </p:nvSpPr>
         <p:spPr>
           <a:xfrm>
-            <a:off x="868680" y="3931920"/>
-            <a:ext cx="1325880" cy="310896"/>
+            <a:off x="868680" y="3895344"/>
+            <a:ext cx="1170432" cy="283464"/>
           </a:xfrm>
           <a:prstGeom prst="roundRect">
             <a:avLst/>
@@ -4965,8 +4965,8 @@
         </p:nvSpPr>
         <p:spPr>
           <a:xfrm>
-            <a:off x="932688" y="4005072"/>
-            <a:ext cx="1188720" cy="118872"/>
+            <a:off x="932688" y="3959352"/>
+            <a:ext cx="1042415" cy="118872"/>
           </a:xfrm>
           <a:prstGeom prst="rect">
             <a:avLst/>
@@ -4985,7 +4985,7 @@
               </a:lnSpc>
             </a:pPr>
             <a:r>
-              <a:rPr sz="880" b="1">
+              <a:rPr sz="800" b="1">
                 <a:solidFill>
                   <a:srgbClr val="FFFFFF"/>
                 </a:solidFill>
@@ -5004,8 +5004,8 @@
         </p:nvSpPr>
         <p:spPr>
           <a:xfrm>
-            <a:off x="2423160" y="3977639"/>
-            <a:ext cx="8366760" cy="201168"/>
+            <a:off x="2212848" y="3931920"/>
+            <a:ext cx="3703320" cy="201168"/>
           </a:xfrm>
           <a:prstGeom prst="rect">
             <a:avLst/>
@@ -5024,7 +5024,7 @@
               </a:lnSpc>
             </a:pPr>
             <a:r>
-              <a:rPr sz="1080" b="0">
+              <a:rPr sz="919" b="0">
                 <a:solidFill>
                   <a:srgbClr val="373739"/>
                 </a:solidFill>
@@ -5043,8 +5043,8 @@
         </p:nvSpPr>
         <p:spPr>
           <a:xfrm>
-            <a:off x="868680" y="4370831"/>
-            <a:ext cx="1325880" cy="310896"/>
+            <a:off x="868680" y="4297680"/>
+            <a:ext cx="1170432" cy="283464"/>
           </a:xfrm>
           <a:prstGeom prst="roundRect">
             <a:avLst/>
@@ -5086,8 +5086,8 @@
         </p:nvSpPr>
         <p:spPr>
           <a:xfrm>
-            <a:off x="932688" y="4443983"/>
-            <a:ext cx="1188720" cy="118872"/>
+            <a:off x="932688" y="4361688"/>
+            <a:ext cx="1042415" cy="118872"/>
           </a:xfrm>
           <a:prstGeom prst="rect">
             <a:avLst/>
@@ -5106,7 +5106,7 @@
               </a:lnSpc>
             </a:pPr>
             <a:r>
-              <a:rPr sz="880" b="1">
+              <a:rPr sz="800" b="1">
                 <a:solidFill>
                   <a:srgbClr val="FFFFFF"/>
                 </a:solidFill>
@@ -5125,8 +5125,8 @@
         </p:nvSpPr>
         <p:spPr>
           <a:xfrm>
-            <a:off x="2423160" y="4416551"/>
-            <a:ext cx="8366760" cy="201168"/>
+            <a:off x="2212848" y="4334256"/>
+            <a:ext cx="3703320" cy="201168"/>
           </a:xfrm>
           <a:prstGeom prst="rect">
             <a:avLst/>
@@ -5145,7 +5145,7 @@
               </a:lnSpc>
             </a:pPr>
             <a:r>
-              <a:rPr sz="1080" b="0">
+              <a:rPr sz="919" b="0">
                 <a:solidFill>
                   <a:srgbClr val="373739"/>
                 </a:solidFill>
@@ -5164,8 +5164,8 @@
         </p:nvSpPr>
         <p:spPr>
           <a:xfrm>
-            <a:off x="868680" y="4809744"/>
-            <a:ext cx="1325880" cy="310896"/>
+            <a:off x="868680" y="4700016"/>
+            <a:ext cx="1170432" cy="283464"/>
           </a:xfrm>
           <a:prstGeom prst="roundRect">
             <a:avLst/>
@@ -5207,8 +5207,8 @@
         </p:nvSpPr>
         <p:spPr>
           <a:xfrm>
-            <a:off x="932688" y="4882896"/>
-            <a:ext cx="1188720" cy="118872"/>
+            <a:off x="932688" y="4764024"/>
+            <a:ext cx="1042415" cy="118872"/>
           </a:xfrm>
           <a:prstGeom prst="rect">
             <a:avLst/>
@@ -5227,7 +5227,7 @@
               </a:lnSpc>
             </a:pPr>
             <a:r>
-              <a:rPr sz="880" b="1">
+              <a:rPr sz="800" b="1">
                 <a:solidFill>
                   <a:srgbClr val="FFFFFF"/>
                 </a:solidFill>
@@ -5246,8 +5246,8 @@
         </p:nvSpPr>
         <p:spPr>
           <a:xfrm>
-            <a:off x="2423160" y="4855464"/>
-            <a:ext cx="8366760" cy="201168"/>
+            <a:off x="2212848" y="4736592"/>
+            <a:ext cx="3703320" cy="201168"/>
           </a:xfrm>
           <a:prstGeom prst="rect">
             <a:avLst/>
@@ -5266,7 +5266,7 @@
               </a:lnSpc>
             </a:pPr>
             <a:r>
-              <a:rPr sz="1080" b="0">
+              <a:rPr sz="919" b="0">
                 <a:solidFill>
                   <a:srgbClr val="373739"/>
                 </a:solidFill>
@@ -5285,17 +5285,19 @@
         </p:nvSpPr>
         <p:spPr>
           <a:xfrm>
-            <a:off x="868680" y="5440680"/>
-            <a:ext cx="10469880" cy="566928"/>
+            <a:off x="6172200" y="3401568"/>
+            <a:ext cx="5166360" cy="1572768"/>
           </a:xfrm>
           <a:prstGeom prst="roundRect">
             <a:avLst/>
           </a:prstGeom>
           <a:solidFill>
-            <a:srgbClr val="F4F6F8"/>
-          </a:solidFill>
-          <a:ln>
-            <a:noFill/>
+            <a:srgbClr val="FFFFFF"/>
+          </a:solidFill>
+          <a:ln w="12700">
+            <a:solidFill>
+              <a:srgbClr val="E1E4E8"/>
+            </a:solidFill>
           </a:ln>
         </p:spPr>
         <p:style>
@@ -5322,7 +5324,171 @@
       </p:sp>
       <p:sp>
         <p:nvSpPr>
-          <p:cNvPr id="39" name="TextBox 38"/>
+          <p:cNvPr id="39" name="Rectangle 38"/>
+          <p:cNvSpPr/>
+          <p:nvPr/>
+        </p:nvSpPr>
+        <p:spPr>
+          <a:xfrm>
+            <a:off x="6172200" y="3401568"/>
+            <a:ext cx="73152" cy="1572768"/>
+          </a:xfrm>
+          <a:prstGeom prst="rect">
+            <a:avLst/>
+          </a:prstGeom>
+          <a:solidFill>
+            <a:srgbClr val="00ADB5"/>
+          </a:solidFill>
+          <a:ln>
+            <a:noFill/>
+          </a:ln>
+        </p:spPr>
+        <p:style>
+          <a:lnRef idx="1">
+            <a:schemeClr val="accent1"/>
+          </a:lnRef>
+          <a:fillRef idx="3">
+            <a:schemeClr val="accent1"/>
+          </a:fillRef>
+          <a:effectRef idx="2">
+            <a:schemeClr val="accent1"/>
+          </a:effectRef>
+          <a:fontRef idx="minor">
+            <a:schemeClr val="lt1"/>
+          </a:fontRef>
+        </p:style>
+        <p:txBody>
+          <a:bodyPr rtlCol="0" anchor="ctr"/>
+          <a:lstStyle/>
+          <a:p>
+            <a:pPr algn="ctr"/>
+          </a:p>
+        </p:txBody>
+      </p:sp>
+      <p:sp>
+        <p:nvSpPr>
+          <p:cNvPr id="40" name="TextBox 39"/>
+          <p:cNvSpPr txBox="1"/>
+          <p:nvPr/>
+        </p:nvSpPr>
+        <p:spPr>
+          <a:xfrm>
+            <a:off x="6400800" y="3566160"/>
+            <a:ext cx="4754880" cy="320040"/>
+          </a:xfrm>
+          <a:prstGeom prst="rect">
+            <a:avLst/>
+          </a:prstGeom>
+          <a:noFill/>
+        </p:spPr>
+        <p:txBody>
+          <a:bodyPr wrap="square">
+            <a:normAutofit/>
+          </a:bodyPr>
+          <a:lstStyle/>
+          <a:p>
+            <a:pPr algn="l">
+              <a:lnSpc>
+                <a:spcPct val="100000"/>
+              </a:lnSpc>
+            </a:pPr>
+            <a:r>
+              <a:rPr sz="1450" b="1">
+                <a:solidFill>
+                  <a:srgbClr val="373739"/>
+                </a:solidFill>
+                <a:latin typeface="Aptos"/>
+              </a:rPr>
+              <a:t>Valor del agente</a:t>
+            </a:r>
+          </a:p>
+        </p:txBody>
+      </p:sp>
+      <p:sp>
+        <p:nvSpPr>
+          <p:cNvPr id="41" name="TextBox 40"/>
+          <p:cNvSpPr txBox="1"/>
+          <p:nvPr/>
+        </p:nvSpPr>
+        <p:spPr>
+          <a:xfrm>
+            <a:off x="6400800" y="4014216"/>
+            <a:ext cx="4754880" cy="822960"/>
+          </a:xfrm>
+          <a:prstGeom prst="rect">
+            <a:avLst/>
+          </a:prstGeom>
+          <a:noFill/>
+        </p:spPr>
+        <p:txBody>
+          <a:bodyPr wrap="square">
+            <a:normAutofit/>
+          </a:bodyPr>
+          <a:lstStyle/>
+          <a:p>
+            <a:pPr algn="l">
+              <a:lnSpc>
+                <a:spcPct val="100000"/>
+              </a:lnSpc>
+            </a:pPr>
+            <a:r>
+              <a:rPr sz="1019" b="0">
+                <a:solidFill>
+                  <a:srgbClr val="69696C"/>
+                </a:solidFill>
+                <a:latin typeface="Aptos"/>
+              </a:rPr>
+              <a:t>Identifica documentos y evidencia; ubica secciones, citas o registros; propone cobertura o brecha; justifica el criterio; ordena acciones de cierre y conserva trazabilidad para validación experta.</a:t>
+            </a:r>
+          </a:p>
+        </p:txBody>
+      </p:sp>
+      <p:sp>
+        <p:nvSpPr>
+          <p:cNvPr id="42" name="Rounded Rectangle 41"/>
+          <p:cNvSpPr/>
+          <p:nvPr/>
+        </p:nvSpPr>
+        <p:spPr>
+          <a:xfrm>
+            <a:off x="868680" y="5440680"/>
+            <a:ext cx="10469880" cy="566928"/>
+          </a:xfrm>
+          <a:prstGeom prst="roundRect">
+            <a:avLst/>
+          </a:prstGeom>
+          <a:solidFill>
+            <a:srgbClr val="F4F6F8"/>
+          </a:solidFill>
+          <a:ln>
+            <a:noFill/>
+          </a:ln>
+        </p:spPr>
+        <p:style>
+          <a:lnRef idx="1">
+            <a:schemeClr val="accent1"/>
+          </a:lnRef>
+          <a:fillRef idx="3">
+            <a:schemeClr val="accent1"/>
+          </a:fillRef>
+          <a:effectRef idx="2">
+            <a:schemeClr val="accent1"/>
+          </a:effectRef>
+          <a:fontRef idx="minor">
+            <a:schemeClr val="lt1"/>
+          </a:fontRef>
+        </p:style>
+        <p:txBody>
+          <a:bodyPr rtlCol="0" anchor="ctr"/>
+          <a:lstStyle/>
+          <a:p>
+            <a:pPr algn="ctr"/>
+          </a:p>
+        </p:txBody>
+      </p:sp>
+      <p:sp>
+        <p:nvSpPr>
+          <p:cNvPr id="43" name="TextBox 42"/>
           <p:cNvSpPr txBox="1"/>
           <p:nvPr/>
         </p:nvSpPr>
@@ -5361,7 +5527,7 @@
       </p:sp>
       <p:sp>
         <p:nvSpPr>
-          <p:cNvPr id="40" name="Rectangle 39"/>
+          <p:cNvPr id="44" name="Rectangle 43"/>
           <p:cNvSpPr/>
           <p:nvPr/>
         </p:nvSpPr>
@@ -5404,7 +5570,7 @@
       </p:sp>
       <p:sp>
         <p:nvSpPr>
-          <p:cNvPr id="41" name="TextBox 40"/>
+          <p:cNvPr id="45" name="TextBox 44"/>
           <p:cNvSpPr txBox="1"/>
           <p:nvPr/>
         </p:nvSpPr>
@@ -5443,7 +5609,7 @@
       </p:sp>
       <p:sp>
         <p:nvSpPr>
-          <p:cNvPr id="42" name="TextBox 41"/>
+          <p:cNvPr id="46" name="TextBox 45"/>
           <p:cNvSpPr txBox="1"/>
           <p:nvPr/>
         </p:nvSpPr>
@@ -5482,7 +5648,7 @@
       </p:sp>
       <p:sp>
         <p:nvSpPr>
-          <p:cNvPr id="43" name="Rectangle 42"/>
+          <p:cNvPr id="47" name="Rectangle 46"/>
           <p:cNvSpPr/>
           <p:nvPr/>
         </p:nvSpPr>
@@ -6535,7 +6701,7 @@
         <p:spPr>
           <a:xfrm>
             <a:off x="868680" y="3493008"/>
-            <a:ext cx="1325880" cy="310896"/>
+            <a:ext cx="1170432" cy="283464"/>
           </a:xfrm>
           <a:prstGeom prst="roundRect">
             <a:avLst/>
@@ -6577,8 +6743,8 @@
         </p:nvSpPr>
         <p:spPr>
           <a:xfrm>
-            <a:off x="932688" y="3566160"/>
-            <a:ext cx="1188720" cy="118872"/>
+            <a:off x="932688" y="3557015"/>
+            <a:ext cx="1042415" cy="118872"/>
           </a:xfrm>
           <a:prstGeom prst="rect">
             <a:avLst/>
@@ -6597,7 +6763,7 @@
               </a:lnSpc>
             </a:pPr>
             <a:r>
-              <a:rPr sz="880" b="1">
+              <a:rPr sz="800" b="1">
                 <a:solidFill>
                   <a:srgbClr val="FFFFFF"/>
                 </a:solidFill>
@@ -6616,8 +6782,8 @@
         </p:nvSpPr>
         <p:spPr>
           <a:xfrm>
-            <a:off x="2423160" y="3538727"/>
-            <a:ext cx="8366760" cy="201168"/>
+            <a:off x="2212848" y="3529584"/>
+            <a:ext cx="3703320" cy="201168"/>
           </a:xfrm>
           <a:prstGeom prst="rect">
             <a:avLst/>
@@ -6636,7 +6802,7 @@
               </a:lnSpc>
             </a:pPr>
             <a:r>
-              <a:rPr sz="1080" b="0">
+              <a:rPr sz="919" b="0">
                 <a:solidFill>
                   <a:srgbClr val="373739"/>
                 </a:solidFill>
@@ -6655,8 +6821,8 @@
         </p:nvSpPr>
         <p:spPr>
           <a:xfrm>
-            <a:off x="868680" y="3931920"/>
-            <a:ext cx="1325880" cy="310896"/>
+            <a:off x="868680" y="3895344"/>
+            <a:ext cx="1170432" cy="283464"/>
           </a:xfrm>
           <a:prstGeom prst="roundRect">
             <a:avLst/>
@@ -6698,8 +6864,8 @@
         </p:nvSpPr>
         <p:spPr>
           <a:xfrm>
-            <a:off x="932688" y="4005072"/>
-            <a:ext cx="1188720" cy="118872"/>
+            <a:off x="932688" y="3959352"/>
+            <a:ext cx="1042415" cy="118872"/>
           </a:xfrm>
           <a:prstGeom prst="rect">
             <a:avLst/>
@@ -6718,7 +6884,7 @@
               </a:lnSpc>
             </a:pPr>
             <a:r>
-              <a:rPr sz="880" b="1">
+              <a:rPr sz="800" b="1">
                 <a:solidFill>
                   <a:srgbClr val="FFFFFF"/>
                 </a:solidFill>
@@ -6737,8 +6903,8 @@
         </p:nvSpPr>
         <p:spPr>
           <a:xfrm>
-            <a:off x="2423160" y="3977639"/>
-            <a:ext cx="8366760" cy="201168"/>
+            <a:off x="2212848" y="3931920"/>
+            <a:ext cx="3703320" cy="201168"/>
           </a:xfrm>
           <a:prstGeom prst="rect">
             <a:avLst/>
@@ -6757,7 +6923,7 @@
               </a:lnSpc>
             </a:pPr>
             <a:r>
-              <a:rPr sz="1080" b="0">
+              <a:rPr sz="919" b="0">
                 <a:solidFill>
                   <a:srgbClr val="373739"/>
                 </a:solidFill>
@@ -6776,8 +6942,8 @@
         </p:nvSpPr>
         <p:spPr>
           <a:xfrm>
-            <a:off x="868680" y="4370831"/>
-            <a:ext cx="1325880" cy="310896"/>
+            <a:off x="868680" y="4297680"/>
+            <a:ext cx="1170432" cy="283464"/>
           </a:xfrm>
           <a:prstGeom prst="roundRect">
             <a:avLst/>
@@ -6819,8 +6985,8 @@
         </p:nvSpPr>
         <p:spPr>
           <a:xfrm>
-            <a:off x="932688" y="4443983"/>
-            <a:ext cx="1188720" cy="118872"/>
+            <a:off x="932688" y="4361688"/>
+            <a:ext cx="1042415" cy="118872"/>
           </a:xfrm>
           <a:prstGeom prst="rect">
             <a:avLst/>
@@ -6839,7 +7005,7 @@
               </a:lnSpc>
             </a:pPr>
             <a:r>
-              <a:rPr sz="880" b="1">
+              <a:rPr sz="800" b="1">
                 <a:solidFill>
                   <a:srgbClr val="FFFFFF"/>
                 </a:solidFill>
@@ -6858,8 +7024,8 @@
         </p:nvSpPr>
         <p:spPr>
           <a:xfrm>
-            <a:off x="2423160" y="4416551"/>
-            <a:ext cx="8366760" cy="201168"/>
+            <a:off x="2212848" y="4334256"/>
+            <a:ext cx="3703320" cy="201168"/>
           </a:xfrm>
           <a:prstGeom prst="rect">
             <a:avLst/>
@@ -6878,7 +7044,7 @@
               </a:lnSpc>
             </a:pPr>
             <a:r>
-              <a:rPr sz="1080" b="0">
+              <a:rPr sz="919" b="0">
                 <a:solidFill>
                   <a:srgbClr val="373739"/>
                 </a:solidFill>
@@ -6897,8 +7063,8 @@
         </p:nvSpPr>
         <p:spPr>
           <a:xfrm>
-            <a:off x="868680" y="4809744"/>
-            <a:ext cx="1325880" cy="310896"/>
+            <a:off x="868680" y="4700016"/>
+            <a:ext cx="1170432" cy="283464"/>
           </a:xfrm>
           <a:prstGeom prst="roundRect">
             <a:avLst/>
@@ -6940,8 +7106,8 @@
         </p:nvSpPr>
         <p:spPr>
           <a:xfrm>
-            <a:off x="932688" y="4882896"/>
-            <a:ext cx="1188720" cy="118872"/>
+            <a:off x="932688" y="4764024"/>
+            <a:ext cx="1042415" cy="118872"/>
           </a:xfrm>
           <a:prstGeom prst="rect">
             <a:avLst/>
@@ -6960,7 +7126,7 @@
               </a:lnSpc>
             </a:pPr>
             <a:r>
-              <a:rPr sz="880" b="1">
+              <a:rPr sz="800" b="1">
                 <a:solidFill>
                   <a:srgbClr val="FFFFFF"/>
                 </a:solidFill>
@@ -6979,8 +7145,8 @@
         </p:nvSpPr>
         <p:spPr>
           <a:xfrm>
-            <a:off x="2423160" y="4855464"/>
-            <a:ext cx="8366760" cy="201168"/>
+            <a:off x="2212848" y="4736592"/>
+            <a:ext cx="3703320" cy="201168"/>
           </a:xfrm>
           <a:prstGeom prst="rect">
             <a:avLst/>
@@ -6999,7 +7165,7 @@
               </a:lnSpc>
             </a:pPr>
             <a:r>
-              <a:rPr sz="1080" b="0">
+              <a:rPr sz="919" b="0">
                 <a:solidFill>
                   <a:srgbClr val="373739"/>
                 </a:solidFill>
@@ -7018,17 +7184,19 @@
         </p:nvSpPr>
         <p:spPr>
           <a:xfrm>
-            <a:off x="868680" y="5440680"/>
-            <a:ext cx="10469880" cy="566928"/>
+            <a:off x="6172200" y="3401568"/>
+            <a:ext cx="5166360" cy="1572768"/>
           </a:xfrm>
           <a:prstGeom prst="roundRect">
             <a:avLst/>
           </a:prstGeom>
           <a:solidFill>
-            <a:srgbClr val="F4F6F8"/>
-          </a:solidFill>
-          <a:ln>
-            <a:noFill/>
+            <a:srgbClr val="FFFFFF"/>
+          </a:solidFill>
+          <a:ln w="12700">
+            <a:solidFill>
+              <a:srgbClr val="E1E4E8"/>
+            </a:solidFill>
           </a:ln>
         </p:spPr>
         <p:style>
@@ -7055,7 +7223,171 @@
       </p:sp>
       <p:sp>
         <p:nvSpPr>
-          <p:cNvPr id="39" name="TextBox 38"/>
+          <p:cNvPr id="39" name="Rectangle 38"/>
+          <p:cNvSpPr/>
+          <p:nvPr/>
+        </p:nvSpPr>
+        <p:spPr>
+          <a:xfrm>
+            <a:off x="6172200" y="3401568"/>
+            <a:ext cx="73152" cy="1572768"/>
+          </a:xfrm>
+          <a:prstGeom prst="rect">
+            <a:avLst/>
+          </a:prstGeom>
+          <a:solidFill>
+            <a:srgbClr val="D32F7A"/>
+          </a:solidFill>
+          <a:ln>
+            <a:noFill/>
+          </a:ln>
+        </p:spPr>
+        <p:style>
+          <a:lnRef idx="1">
+            <a:schemeClr val="accent1"/>
+          </a:lnRef>
+          <a:fillRef idx="3">
+            <a:schemeClr val="accent1"/>
+          </a:fillRef>
+          <a:effectRef idx="2">
+            <a:schemeClr val="accent1"/>
+          </a:effectRef>
+          <a:fontRef idx="minor">
+            <a:schemeClr val="lt1"/>
+          </a:fontRef>
+        </p:style>
+        <p:txBody>
+          <a:bodyPr rtlCol="0" anchor="ctr"/>
+          <a:lstStyle/>
+          <a:p>
+            <a:pPr algn="ctr"/>
+          </a:p>
+        </p:txBody>
+      </p:sp>
+      <p:sp>
+        <p:nvSpPr>
+          <p:cNvPr id="40" name="TextBox 39"/>
+          <p:cNvSpPr txBox="1"/>
+          <p:nvPr/>
+        </p:nvSpPr>
+        <p:spPr>
+          <a:xfrm>
+            <a:off x="6400800" y="3566160"/>
+            <a:ext cx="4754880" cy="320040"/>
+          </a:xfrm>
+          <a:prstGeom prst="rect">
+            <a:avLst/>
+          </a:prstGeom>
+          <a:noFill/>
+        </p:spPr>
+        <p:txBody>
+          <a:bodyPr wrap="square">
+            <a:normAutofit/>
+          </a:bodyPr>
+          <a:lstStyle/>
+          <a:p>
+            <a:pPr algn="l">
+              <a:lnSpc>
+                <a:spcPct val="100000"/>
+              </a:lnSpc>
+            </a:pPr>
+            <a:r>
+              <a:rPr sz="1450" b="1">
+                <a:solidFill>
+                  <a:srgbClr val="373739"/>
+                </a:solidFill>
+                <a:latin typeface="Aptos"/>
+              </a:rPr>
+              <a:t>Valor del agente</a:t>
+            </a:r>
+          </a:p>
+        </p:txBody>
+      </p:sp>
+      <p:sp>
+        <p:nvSpPr>
+          <p:cNvPr id="41" name="TextBox 40"/>
+          <p:cNvSpPr txBox="1"/>
+          <p:nvPr/>
+        </p:nvSpPr>
+        <p:spPr>
+          <a:xfrm>
+            <a:off x="6400800" y="4014216"/>
+            <a:ext cx="4754880" cy="822960"/>
+          </a:xfrm>
+          <a:prstGeom prst="rect">
+            <a:avLst/>
+          </a:prstGeom>
+          <a:noFill/>
+        </p:spPr>
+        <p:txBody>
+          <a:bodyPr wrap="square">
+            <a:normAutofit/>
+          </a:bodyPr>
+          <a:lstStyle/>
+          <a:p>
+            <a:pPr algn="l">
+              <a:lnSpc>
+                <a:spcPct val="100000"/>
+              </a:lnSpc>
+            </a:pPr>
+            <a:r>
+              <a:rPr sz="1019" b="0">
+                <a:solidFill>
+                  <a:srgbClr val="69696C"/>
+                </a:solidFill>
+                <a:latin typeface="Aptos"/>
+              </a:rPr>
+              <a:t>Lee el modelo; ordena evidencias por criterio, factor y aspecto; identifica cobertura documental, fuentes y trazabilidad; apoya diagnósticos y prepara insumos para revisión experta.</a:t>
+            </a:r>
+          </a:p>
+        </p:txBody>
+      </p:sp>
+      <p:sp>
+        <p:nvSpPr>
+          <p:cNvPr id="42" name="Rounded Rectangle 41"/>
+          <p:cNvSpPr/>
+          <p:nvPr/>
+        </p:nvSpPr>
+        <p:spPr>
+          <a:xfrm>
+            <a:off x="868680" y="5440680"/>
+            <a:ext cx="10469880" cy="566928"/>
+          </a:xfrm>
+          <a:prstGeom prst="roundRect">
+            <a:avLst/>
+          </a:prstGeom>
+          <a:solidFill>
+            <a:srgbClr val="F4F6F8"/>
+          </a:solidFill>
+          <a:ln>
+            <a:noFill/>
+          </a:ln>
+        </p:spPr>
+        <p:style>
+          <a:lnRef idx="1">
+            <a:schemeClr val="accent1"/>
+          </a:lnRef>
+          <a:fillRef idx="3">
+            <a:schemeClr val="accent1"/>
+          </a:fillRef>
+          <a:effectRef idx="2">
+            <a:schemeClr val="accent1"/>
+          </a:effectRef>
+          <a:fontRef idx="minor">
+            <a:schemeClr val="lt1"/>
+          </a:fontRef>
+        </p:style>
+        <p:txBody>
+          <a:bodyPr rtlCol="0" anchor="ctr"/>
+          <a:lstStyle/>
+          <a:p>
+            <a:pPr algn="ctr"/>
+          </a:p>
+        </p:txBody>
+      </p:sp>
+      <p:sp>
+        <p:nvSpPr>
+          <p:cNvPr id="43" name="TextBox 42"/>
           <p:cNvSpPr txBox="1"/>
           <p:nvPr/>
         </p:nvSpPr>
@@ -7094,7 +7426,7 @@
       </p:sp>
       <p:sp>
         <p:nvSpPr>
-          <p:cNvPr id="40" name="Rectangle 39"/>
+          <p:cNvPr id="44" name="Rectangle 43"/>
           <p:cNvSpPr/>
           <p:nvPr/>
         </p:nvSpPr>
@@ -7137,7 +7469,7 @@
       </p:sp>
       <p:sp>
         <p:nvSpPr>
-          <p:cNvPr id="41" name="TextBox 40"/>
+          <p:cNvPr id="45" name="TextBox 44"/>
           <p:cNvSpPr txBox="1"/>
           <p:nvPr/>
         </p:nvSpPr>
@@ -7176,7 +7508,7 @@
       </p:sp>
       <p:sp>
         <p:nvSpPr>
-          <p:cNvPr id="42" name="TextBox 41"/>
+          <p:cNvPr id="46" name="TextBox 45"/>
           <p:cNvSpPr txBox="1"/>
           <p:nvPr/>
         </p:nvSpPr>
@@ -7215,7 +7547,7 @@
       </p:sp>
       <p:sp>
         <p:nvSpPr>
-          <p:cNvPr id="43" name="Rectangle 42"/>
+          <p:cNvPr id="47" name="Rectangle 46"/>
           <p:cNvSpPr/>
           <p:nvPr/>
         </p:nvSpPr>

</xml_diff>